<commit_message>
Update PowerPoint template layouts
</commit_message>
<xml_diff>
--- a/ProjectTemplate/Vorlage AutoBericht.pptx
+++ b/ProjectTemplate/Vorlage AutoBericht.pptx
@@ -4298,7 +4298,7 @@
           <a:p>
             <a:fld id="{2587F81F-703A-486A-ABDB-8FD28DBE1C96}" type="datetimeFigureOut">
               <a:rPr lang="en-US" smtClean="0"/>
-              <a:t>3/2/2026</a:t>
+              <a:t>3/3/2026</a:t>
             </a:fld>
             <a:endParaRPr lang="en-US"/>
           </a:p>
@@ -4475,7 +4475,7 @@
           <a:p>
             <a:fld id="{1D7C7CC5-2BF5-4715-A2D9-EB8D14F8111B}" type="datetimeFigureOut">
               <a:rPr lang="en-US" smtClean="0"/>
-              <a:t>3/2/2026</a:t>
+              <a:t>3/3/2026</a:t>
             </a:fld>
             <a:endParaRPr lang="en-US"/>
           </a:p>
@@ -4865,6 +4865,750 @@
 </file>
 
 <file path=ppt/slideLayouts/slideLayout10.xml><?xml version="1.0" encoding="utf-8"?>
+<p:sldLayout xmlns:a="http://schemas.openxmlformats.org/drawingml/2006/main" xmlns:r="http://schemas.openxmlformats.org/officeDocument/2006/relationships" xmlns:p="http://schemas.openxmlformats.org/presentationml/2006/main" preserve="1" userDrawn="1">
+  <p:cSld name="ab_8pictures">
+    <p:spTree>
+      <p:nvGrpSpPr>
+        <p:cNvPr id="1" name=""/>
+        <p:cNvGrpSpPr/>
+        <p:nvPr/>
+      </p:nvGrpSpPr>
+      <p:grpSpPr>
+        <a:xfrm>
+          <a:off x="0" y="0"/>
+          <a:ext cx="0" cy="0"/>
+          <a:chOff x="0" y="0"/>
+          <a:chExt cx="0" cy="0"/>
+        </a:xfrm>
+      </p:grpSpPr>
+      <p:sp>
+        <p:nvSpPr>
+          <p:cNvPr id="2" name="Titel 1">
+            <a:extLst>
+              <a:ext uri="{FF2B5EF4-FFF2-40B4-BE49-F238E27FC236}">
+                <a16:creationId xmlns:a16="http://schemas.microsoft.com/office/drawing/2014/main" id="{A1540017-C5E1-4CC7-9997-40CEFDC98621}"/>
+              </a:ext>
+            </a:extLst>
+          </p:cNvPr>
+          <p:cNvSpPr>
+            <a:spLocks noGrp="1"/>
+          </p:cNvSpPr>
+          <p:nvPr>
+            <p:ph type="title"/>
+          </p:nvPr>
+        </p:nvSpPr>
+        <p:spPr/>
+        <p:txBody>
+          <a:bodyPr/>
+          <a:lstStyle/>
+          <a:p>
+            <a:r>
+              <a:rPr lang="de-DE"/>
+              <a:t>Mastertitelformat bearbeiten</a:t>
+            </a:r>
+            <a:endParaRPr lang="de-CH"/>
+          </a:p>
+        </p:txBody>
+      </p:sp>
+      <p:sp>
+        <p:nvSpPr>
+          <p:cNvPr id="7" name="Bildplatzhalter 6">
+            <a:extLst>
+              <a:ext uri="{FF2B5EF4-FFF2-40B4-BE49-F238E27FC236}">
+                <a16:creationId xmlns:a16="http://schemas.microsoft.com/office/drawing/2014/main" id="{0382034B-75CE-4875-AF93-5B9AEC42BF3E}"/>
+              </a:ext>
+            </a:extLst>
+          </p:cNvPr>
+          <p:cNvSpPr>
+            <a:spLocks noGrp="1"/>
+          </p:cNvSpPr>
+          <p:nvPr>
+            <p:ph type="pic" sz="quarter" idx="10"/>
+          </p:nvPr>
+        </p:nvSpPr>
+        <p:spPr>
+          <a:xfrm>
+            <a:off x="550863" y="1556983"/>
+            <a:ext cx="2664000" cy="2340000"/>
+          </a:xfrm>
+        </p:spPr>
+        <p:txBody>
+          <a:bodyPr/>
+          <a:lstStyle/>
+          <a:p>
+            <a:endParaRPr lang="de-CH"/>
+          </a:p>
+        </p:txBody>
+      </p:sp>
+      <p:sp>
+        <p:nvSpPr>
+          <p:cNvPr id="14" name="Bildplatzhalter 6">
+            <a:extLst>
+              <a:ext uri="{FF2B5EF4-FFF2-40B4-BE49-F238E27FC236}">
+                <a16:creationId xmlns:a16="http://schemas.microsoft.com/office/drawing/2014/main" id="{B38D0A6D-8C1B-41E3-90AE-960E8DAA3BA0}"/>
+              </a:ext>
+            </a:extLst>
+          </p:cNvPr>
+          <p:cNvSpPr>
+            <a:spLocks noGrp="1"/>
+          </p:cNvSpPr>
+          <p:nvPr>
+            <p:ph type="pic" sz="quarter" idx="11"/>
+          </p:nvPr>
+        </p:nvSpPr>
+        <p:spPr>
+          <a:xfrm>
+            <a:off x="3359447" y="1556983"/>
+            <a:ext cx="2664000" cy="2340000"/>
+          </a:xfrm>
+        </p:spPr>
+        <p:txBody>
+          <a:bodyPr/>
+          <a:lstStyle/>
+          <a:p>
+            <a:endParaRPr lang="de-CH"/>
+          </a:p>
+        </p:txBody>
+      </p:sp>
+      <p:sp>
+        <p:nvSpPr>
+          <p:cNvPr id="15" name="Bildplatzhalter 6">
+            <a:extLst>
+              <a:ext uri="{FF2B5EF4-FFF2-40B4-BE49-F238E27FC236}">
+                <a16:creationId xmlns:a16="http://schemas.microsoft.com/office/drawing/2014/main" id="{511998C5-CA15-491D-A5FC-E002D1FA4BB9}"/>
+              </a:ext>
+            </a:extLst>
+          </p:cNvPr>
+          <p:cNvSpPr>
+            <a:spLocks noGrp="1"/>
+          </p:cNvSpPr>
+          <p:nvPr>
+            <p:ph type="pic" sz="quarter" idx="12"/>
+          </p:nvPr>
+        </p:nvSpPr>
+        <p:spPr>
+          <a:xfrm>
+            <a:off x="6168031" y="1556983"/>
+            <a:ext cx="2664000" cy="2340000"/>
+          </a:xfrm>
+        </p:spPr>
+        <p:txBody>
+          <a:bodyPr/>
+          <a:lstStyle/>
+          <a:p>
+            <a:endParaRPr lang="de-CH"/>
+          </a:p>
+        </p:txBody>
+      </p:sp>
+      <p:sp>
+        <p:nvSpPr>
+          <p:cNvPr id="16" name="Bildplatzhalter 6">
+            <a:extLst>
+              <a:ext uri="{FF2B5EF4-FFF2-40B4-BE49-F238E27FC236}">
+                <a16:creationId xmlns:a16="http://schemas.microsoft.com/office/drawing/2014/main" id="{7919B8D0-ECEF-4226-AB3A-F8F566FD56A1}"/>
+              </a:ext>
+            </a:extLst>
+          </p:cNvPr>
+          <p:cNvSpPr>
+            <a:spLocks noGrp="1"/>
+          </p:cNvSpPr>
+          <p:nvPr>
+            <p:ph type="pic" sz="quarter" idx="13"/>
+          </p:nvPr>
+        </p:nvSpPr>
+        <p:spPr>
+          <a:xfrm>
+            <a:off x="8976616" y="1556983"/>
+            <a:ext cx="2664000" cy="2340000"/>
+          </a:xfrm>
+        </p:spPr>
+        <p:txBody>
+          <a:bodyPr/>
+          <a:lstStyle/>
+          <a:p>
+            <a:endParaRPr lang="de-CH"/>
+          </a:p>
+        </p:txBody>
+      </p:sp>
+      <p:sp>
+        <p:nvSpPr>
+          <p:cNvPr id="8" name="Bildplatzhalter 6">
+            <a:extLst>
+              <a:ext uri="{FF2B5EF4-FFF2-40B4-BE49-F238E27FC236}">
+                <a16:creationId xmlns:a16="http://schemas.microsoft.com/office/drawing/2014/main" id="{F419A863-A24E-4DC6-98B8-87B35CD3CAD3}"/>
+              </a:ext>
+            </a:extLst>
+          </p:cNvPr>
+          <p:cNvSpPr>
+            <a:spLocks noGrp="1"/>
+          </p:cNvSpPr>
+          <p:nvPr>
+            <p:ph type="pic" sz="quarter" idx="14"/>
+          </p:nvPr>
+        </p:nvSpPr>
+        <p:spPr>
+          <a:xfrm>
+            <a:off x="569475" y="4239870"/>
+            <a:ext cx="2664000" cy="2340000"/>
+          </a:xfrm>
+        </p:spPr>
+        <p:txBody>
+          <a:bodyPr/>
+          <a:lstStyle/>
+          <a:p>
+            <a:endParaRPr lang="de-CH"/>
+          </a:p>
+        </p:txBody>
+      </p:sp>
+      <p:sp>
+        <p:nvSpPr>
+          <p:cNvPr id="9" name="Bildplatzhalter 6">
+            <a:extLst>
+              <a:ext uri="{FF2B5EF4-FFF2-40B4-BE49-F238E27FC236}">
+                <a16:creationId xmlns:a16="http://schemas.microsoft.com/office/drawing/2014/main" id="{6108253A-EE25-4600-BE74-5FD974B5CED2}"/>
+              </a:ext>
+            </a:extLst>
+          </p:cNvPr>
+          <p:cNvSpPr>
+            <a:spLocks noGrp="1"/>
+          </p:cNvSpPr>
+          <p:nvPr>
+            <p:ph type="pic" sz="quarter" idx="15"/>
+          </p:nvPr>
+        </p:nvSpPr>
+        <p:spPr>
+          <a:xfrm>
+            <a:off x="3378059" y="4239870"/>
+            <a:ext cx="2664000" cy="2340000"/>
+          </a:xfrm>
+        </p:spPr>
+        <p:txBody>
+          <a:bodyPr/>
+          <a:lstStyle/>
+          <a:p>
+            <a:endParaRPr lang="de-CH"/>
+          </a:p>
+        </p:txBody>
+      </p:sp>
+      <p:sp>
+        <p:nvSpPr>
+          <p:cNvPr id="10" name="Bildplatzhalter 6">
+            <a:extLst>
+              <a:ext uri="{FF2B5EF4-FFF2-40B4-BE49-F238E27FC236}">
+                <a16:creationId xmlns:a16="http://schemas.microsoft.com/office/drawing/2014/main" id="{F6293461-5015-4965-A9BF-4F87175D0672}"/>
+              </a:ext>
+            </a:extLst>
+          </p:cNvPr>
+          <p:cNvSpPr>
+            <a:spLocks noGrp="1"/>
+          </p:cNvSpPr>
+          <p:nvPr>
+            <p:ph type="pic" sz="quarter" idx="16"/>
+          </p:nvPr>
+        </p:nvSpPr>
+        <p:spPr>
+          <a:xfrm>
+            <a:off x="6186643" y="4239870"/>
+            <a:ext cx="2664000" cy="2340000"/>
+          </a:xfrm>
+        </p:spPr>
+        <p:txBody>
+          <a:bodyPr/>
+          <a:lstStyle/>
+          <a:p>
+            <a:endParaRPr lang="de-CH"/>
+          </a:p>
+        </p:txBody>
+      </p:sp>
+      <p:sp>
+        <p:nvSpPr>
+          <p:cNvPr id="11" name="Bildplatzhalter 6">
+            <a:extLst>
+              <a:ext uri="{FF2B5EF4-FFF2-40B4-BE49-F238E27FC236}">
+                <a16:creationId xmlns:a16="http://schemas.microsoft.com/office/drawing/2014/main" id="{174B38FE-FC22-40DC-B260-374CEABC9C3A}"/>
+              </a:ext>
+            </a:extLst>
+          </p:cNvPr>
+          <p:cNvSpPr>
+            <a:spLocks noGrp="1"/>
+          </p:cNvSpPr>
+          <p:nvPr>
+            <p:ph type="pic" sz="quarter" idx="17"/>
+          </p:nvPr>
+        </p:nvSpPr>
+        <p:spPr>
+          <a:xfrm>
+            <a:off x="8995228" y="4239870"/>
+            <a:ext cx="2664000" cy="2340000"/>
+          </a:xfrm>
+        </p:spPr>
+        <p:txBody>
+          <a:bodyPr/>
+          <a:lstStyle/>
+          <a:p>
+            <a:endParaRPr lang="de-CH"/>
+          </a:p>
+        </p:txBody>
+      </p:sp>
+    </p:spTree>
+    <p:extLst>
+      <p:ext uri="{BB962C8B-B14F-4D97-AF65-F5344CB8AC3E}">
+        <p14:creationId xmlns:p14="http://schemas.microsoft.com/office/powerpoint/2010/main" val="4164158816"/>
+      </p:ext>
+    </p:extLst>
+  </p:cSld>
+  <p:clrMapOvr>
+    <a:masterClrMapping/>
+  </p:clrMapOvr>
+</p:sldLayout>
+</file>
+
+<file path=ppt/slideLayouts/slideLayout11.xml><?xml version="1.0" encoding="utf-8"?>
+<p:sldLayout xmlns:a="http://schemas.openxmlformats.org/drawingml/2006/main" xmlns:r="http://schemas.openxmlformats.org/officeDocument/2006/relationships" xmlns:p="http://schemas.openxmlformats.org/presentationml/2006/main" preserve="1" userDrawn="1">
+  <p:cSld name="ab_unterlassen_d">
+    <p:spTree>
+      <p:nvGrpSpPr>
+        <p:cNvPr id="1" name=""/>
+        <p:cNvGrpSpPr/>
+        <p:nvPr/>
+      </p:nvGrpSpPr>
+      <p:grpSpPr>
+        <a:xfrm>
+          <a:off x="0" y="0"/>
+          <a:ext cx="0" cy="0"/>
+          <a:chOff x="0" y="0"/>
+          <a:chExt cx="0" cy="0"/>
+        </a:xfrm>
+      </p:grpSpPr>
+      <p:sp>
+        <p:nvSpPr>
+          <p:cNvPr id="3" name="Title 10">
+            <a:extLst>
+              <a:ext uri="{FF2B5EF4-FFF2-40B4-BE49-F238E27FC236}">
+                <a16:creationId xmlns:a16="http://schemas.microsoft.com/office/drawing/2014/main" id="{B6A1CCF6-D41A-2EB9-D226-892BFBFD27D1}"/>
+              </a:ext>
+            </a:extLst>
+          </p:cNvPr>
+          <p:cNvSpPr txBox="1">
+            <a:spLocks/>
+          </p:cNvSpPr>
+          <p:nvPr userDrawn="1"/>
+        </p:nvSpPr>
+        <p:spPr>
+          <a:xfrm>
+            <a:off x="551384" y="476672"/>
+            <a:ext cx="11089232" cy="864096"/>
+          </a:xfrm>
+          <a:prstGeom prst="rect">
+            <a:avLst/>
+          </a:prstGeom>
+        </p:spPr>
+        <p:txBody>
+          <a:bodyPr vert="horz" lIns="0" tIns="0" rIns="0" bIns="0" rtlCol="0" anchor="t">
+            <a:noAutofit/>
+          </a:bodyPr>
+          <a:lstStyle>
+            <a:lvl1pPr algn="l" defTabSz="914400" rtl="0" eaLnBrk="1" latinLnBrk="0" hangingPunct="1">
+              <a:lnSpc>
+                <a:spcPct val="100000"/>
+              </a:lnSpc>
+              <a:spcBef>
+                <a:spcPct val="0"/>
+              </a:spcBef>
+              <a:buNone/>
+              <a:defRPr sz="2400" b="1" kern="1200">
+                <a:solidFill>
+                  <a:schemeClr val="accent2"/>
+                </a:solidFill>
+                <a:latin typeface="+mj-lt"/>
+                <a:ea typeface="+mj-ea"/>
+                <a:cs typeface="+mj-cs"/>
+              </a:defRPr>
+            </a:lvl1pPr>
+          </a:lstStyle>
+          <a:p>
+            <a:r>
+              <a:rPr lang="de-CH"/>
+              <a:t>Unterlassen, </a:t>
+            </a:r>
+            <a:r>
+              <a:rPr lang="de-CH">
+                <a:solidFill>
+                  <a:schemeClr val="accent2">
+                    <a:lumMod val="60000"/>
+                    <a:lumOff val="40000"/>
+                  </a:schemeClr>
+                </a:solidFill>
+              </a:rPr>
+              <a:t>Dulden, Handeln</a:t>
+            </a:r>
+            <a:endParaRPr lang="de-CH" dirty="0"/>
+          </a:p>
+        </p:txBody>
+      </p:sp>
+      <p:sp>
+        <p:nvSpPr>
+          <p:cNvPr id="4" name="Rectangle 16">
+            <a:extLst>
+              <a:ext uri="{FF2B5EF4-FFF2-40B4-BE49-F238E27FC236}">
+                <a16:creationId xmlns:a16="http://schemas.microsoft.com/office/drawing/2014/main" id="{18A2DA9F-6EEE-4BA7-481A-7654C0D2B41B}"/>
+              </a:ext>
+            </a:extLst>
+          </p:cNvPr>
+          <p:cNvSpPr/>
+          <p:nvPr userDrawn="1"/>
+        </p:nvSpPr>
+        <p:spPr>
+          <a:xfrm>
+            <a:off x="4097586" y="5167480"/>
+            <a:ext cx="3672408" cy="1260140"/>
+          </a:xfrm>
+          <a:prstGeom prst="rect">
+            <a:avLst/>
+          </a:prstGeom>
+          <a:noFill/>
+          <a:ln w="12700" cap="flat" cmpd="sng" algn="ctr">
+            <a:solidFill>
+              <a:srgbClr val="00B8CF"/>
+            </a:solidFill>
+            <a:prstDash val="solid"/>
+            <a:miter lim="800000"/>
+          </a:ln>
+          <a:effectLst/>
+        </p:spPr>
+        <p:txBody>
+          <a:bodyPr rot="0" spcFirstLastPara="0" vert="horz" wrap="square" lIns="126000" tIns="126000" rIns="126000" bIns="126000" numCol="1" spcCol="0" rtlCol="0" fromWordArt="0" anchor="ctr" anchorCtr="0" forceAA="0" compatLnSpc="1">
+            <a:prstTxWarp prst="textNoShape">
+              <a:avLst/>
+            </a:prstTxWarp>
+            <a:noAutofit/>
+          </a:bodyPr>
+          <a:lstStyle>
+            <a:defPPr>
+              <a:defRPr lang="aa-ET"/>
+            </a:defPPr>
+            <a:lvl1pPr marL="0" algn="l" defTabSz="914400" rtl="0" eaLnBrk="1" latinLnBrk="0" hangingPunct="1">
+              <a:defRPr sz="1800" kern="1200">
+                <a:solidFill>
+                  <a:schemeClr val="tx1"/>
+                </a:solidFill>
+                <a:latin typeface="+mn-lt"/>
+                <a:ea typeface="+mn-ea"/>
+                <a:cs typeface="+mn-cs"/>
+              </a:defRPr>
+            </a:lvl1pPr>
+            <a:lvl2pPr marL="457200" algn="l" defTabSz="914400" rtl="0" eaLnBrk="1" latinLnBrk="0" hangingPunct="1">
+              <a:defRPr sz="1800" kern="1200">
+                <a:solidFill>
+                  <a:schemeClr val="tx1"/>
+                </a:solidFill>
+                <a:latin typeface="+mn-lt"/>
+                <a:ea typeface="+mn-ea"/>
+                <a:cs typeface="+mn-cs"/>
+              </a:defRPr>
+            </a:lvl2pPr>
+            <a:lvl3pPr marL="914400" algn="l" defTabSz="914400" rtl="0" eaLnBrk="1" latinLnBrk="0" hangingPunct="1">
+              <a:defRPr sz="1800" kern="1200">
+                <a:solidFill>
+                  <a:schemeClr val="tx1"/>
+                </a:solidFill>
+                <a:latin typeface="+mn-lt"/>
+                <a:ea typeface="+mn-ea"/>
+                <a:cs typeface="+mn-cs"/>
+              </a:defRPr>
+            </a:lvl3pPr>
+            <a:lvl4pPr marL="1371600" algn="l" defTabSz="914400" rtl="0" eaLnBrk="1" latinLnBrk="0" hangingPunct="1">
+              <a:defRPr sz="1800" kern="1200">
+                <a:solidFill>
+                  <a:schemeClr val="tx1"/>
+                </a:solidFill>
+                <a:latin typeface="+mn-lt"/>
+                <a:ea typeface="+mn-ea"/>
+                <a:cs typeface="+mn-cs"/>
+              </a:defRPr>
+            </a:lvl4pPr>
+            <a:lvl5pPr marL="1828800" algn="l" defTabSz="914400" rtl="0" eaLnBrk="1" latinLnBrk="0" hangingPunct="1">
+              <a:defRPr sz="1800" kern="1200">
+                <a:solidFill>
+                  <a:schemeClr val="tx1"/>
+                </a:solidFill>
+                <a:latin typeface="+mn-lt"/>
+                <a:ea typeface="+mn-ea"/>
+                <a:cs typeface="+mn-cs"/>
+              </a:defRPr>
+            </a:lvl5pPr>
+            <a:lvl6pPr marL="2286000" algn="l" defTabSz="914400" rtl="0" eaLnBrk="1" latinLnBrk="0" hangingPunct="1">
+              <a:defRPr sz="1800" kern="1200">
+                <a:solidFill>
+                  <a:schemeClr val="tx1"/>
+                </a:solidFill>
+                <a:latin typeface="+mn-lt"/>
+                <a:ea typeface="+mn-ea"/>
+                <a:cs typeface="+mn-cs"/>
+              </a:defRPr>
+            </a:lvl6pPr>
+            <a:lvl7pPr marL="2743200" algn="l" defTabSz="914400" rtl="0" eaLnBrk="1" latinLnBrk="0" hangingPunct="1">
+              <a:defRPr sz="1800" kern="1200">
+                <a:solidFill>
+                  <a:schemeClr val="tx1"/>
+                </a:solidFill>
+                <a:latin typeface="+mn-lt"/>
+                <a:ea typeface="+mn-ea"/>
+                <a:cs typeface="+mn-cs"/>
+              </a:defRPr>
+            </a:lvl7pPr>
+            <a:lvl8pPr marL="3200400" algn="l" defTabSz="914400" rtl="0" eaLnBrk="1" latinLnBrk="0" hangingPunct="1">
+              <a:defRPr sz="1800" kern="1200">
+                <a:solidFill>
+                  <a:schemeClr val="tx1"/>
+                </a:solidFill>
+                <a:latin typeface="+mn-lt"/>
+                <a:ea typeface="+mn-ea"/>
+                <a:cs typeface="+mn-cs"/>
+              </a:defRPr>
+            </a:lvl8pPr>
+            <a:lvl9pPr marL="3657600" algn="l" defTabSz="914400" rtl="0" eaLnBrk="1" latinLnBrk="0" hangingPunct="1">
+              <a:defRPr sz="1800" kern="1200">
+                <a:solidFill>
+                  <a:schemeClr val="tx1"/>
+                </a:solidFill>
+                <a:latin typeface="+mn-lt"/>
+                <a:ea typeface="+mn-ea"/>
+                <a:cs typeface="+mn-cs"/>
+              </a:defRPr>
+            </a:lvl9pPr>
+          </a:lstStyle>
+          <a:p>
+            <a:pPr marR="0" lvl="0" defTabSz="914400" eaLnBrk="1" fontAlgn="auto" latinLnBrk="0" hangingPunct="1">
+              <a:lnSpc>
+                <a:spcPct val="100000"/>
+              </a:lnSpc>
+              <a:spcBef>
+                <a:spcPts val="0"/>
+              </a:spcBef>
+              <a:spcAft>
+                <a:spcPts val="0"/>
+              </a:spcAft>
+              <a:buClrTx/>
+              <a:buSzTx/>
+              <a:tabLst/>
+              <a:defRPr/>
+            </a:pPr>
+            <a:r>
+              <a:rPr kumimoji="0" lang="de-CH" sz="1400" b="0" i="0" u="none" strike="noStrike" kern="0" cap="none" spc="0" normalizeH="0" baseline="0" noProof="0">
+                <a:ln>
+                  <a:noFill/>
+                </a:ln>
+                <a:solidFill>
+                  <a:prstClr val="black"/>
+                </a:solidFill>
+                <a:effectLst/>
+                <a:uLnTx/>
+                <a:uFillTx/>
+                <a:latin typeface="Arial" panose="020B0604020202020204"/>
+                <a:ea typeface="+mn-ea"/>
+                <a:cs typeface="+mn-cs"/>
+              </a:rPr>
+              <a:t>«Wir sind nicht nur für das verantwortlich was wir tun, sondern auch für das, was wir nicht tun.» </a:t>
+            </a:r>
+          </a:p>
+          <a:p>
+            <a:pPr marR="0" lvl="0" defTabSz="914400" eaLnBrk="1" fontAlgn="auto" latinLnBrk="0" hangingPunct="1">
+              <a:lnSpc>
+                <a:spcPct val="100000"/>
+              </a:lnSpc>
+              <a:spcBef>
+                <a:spcPts val="0"/>
+              </a:spcBef>
+              <a:spcAft>
+                <a:spcPts val="0"/>
+              </a:spcAft>
+              <a:buClrTx/>
+              <a:buSzTx/>
+              <a:tabLst/>
+              <a:defRPr/>
+            </a:pPr>
+            <a:endParaRPr kumimoji="0" lang="de-CH" sz="1400" b="0" i="0" u="none" strike="noStrike" kern="0" cap="none" spc="0" normalizeH="0" baseline="0" noProof="0">
+              <a:ln>
+                <a:noFill/>
+              </a:ln>
+              <a:solidFill>
+                <a:prstClr val="black"/>
+              </a:solidFill>
+              <a:effectLst/>
+              <a:uLnTx/>
+              <a:uFillTx/>
+              <a:latin typeface="Arial" panose="020B0604020202020204"/>
+              <a:ea typeface="+mn-ea"/>
+              <a:cs typeface="+mn-cs"/>
+            </a:endParaRPr>
+          </a:p>
+          <a:p>
+            <a:pPr marR="0" lvl="0" defTabSz="914400" eaLnBrk="1" fontAlgn="auto" latinLnBrk="0" hangingPunct="1">
+              <a:lnSpc>
+                <a:spcPct val="100000"/>
+              </a:lnSpc>
+              <a:spcBef>
+                <a:spcPts val="0"/>
+              </a:spcBef>
+              <a:spcAft>
+                <a:spcPts val="0"/>
+              </a:spcAft>
+              <a:buClrTx/>
+              <a:buSzTx/>
+              <a:tabLst/>
+              <a:defRPr/>
+            </a:pPr>
+            <a:r>
+              <a:rPr kumimoji="0" lang="de-CH" sz="1200" i="1" u="none" strike="noStrike" kern="0" cap="none" spc="0" normalizeH="0" baseline="0" noProof="0">
+                <a:ln>
+                  <a:noFill/>
+                </a:ln>
+                <a:effectLst/>
+                <a:uLnTx/>
+                <a:uFillTx/>
+                <a:latin typeface="Arial" panose="020B0604020202020204"/>
+                <a:ea typeface="+mn-ea"/>
+                <a:cs typeface="+mn-cs"/>
+              </a:rPr>
+              <a:t>Molière</a:t>
+            </a:r>
+          </a:p>
+        </p:txBody>
+      </p:sp>
+      <p:sp>
+        <p:nvSpPr>
+          <p:cNvPr id="7" name="Picture Placeholder 9">
+            <a:extLst>
+              <a:ext uri="{FF2B5EF4-FFF2-40B4-BE49-F238E27FC236}">
+                <a16:creationId xmlns:a16="http://schemas.microsoft.com/office/drawing/2014/main" id="{4AEE75B3-3B50-99B6-8D63-40FC74741D0E}"/>
+              </a:ext>
+            </a:extLst>
+          </p:cNvPr>
+          <p:cNvSpPr>
+            <a:spLocks noGrp="1"/>
+          </p:cNvSpPr>
+          <p:nvPr>
+            <p:ph type="pic" sz="quarter" idx="10"/>
+          </p:nvPr>
+        </p:nvSpPr>
+        <p:spPr>
+          <a:xfrm>
+            <a:off x="3451225" y="1060450"/>
+            <a:ext cx="5197475" cy="3848100"/>
+          </a:xfrm>
+          <a:solidFill>
+            <a:schemeClr val="tx2"/>
+          </a:solidFill>
+          <a:ln>
+            <a:noFill/>
+          </a:ln>
+        </p:spPr>
+        <p:txBody>
+          <a:bodyPr/>
+          <a:lstStyle>
+            <a:lvl1pPr marL="0" indent="0">
+              <a:buNone/>
+              <a:defRPr/>
+            </a:lvl1pPr>
+          </a:lstStyle>
+          <a:p>
+            <a:endParaRPr lang="de-CH" dirty="0"/>
+          </a:p>
+        </p:txBody>
+      </p:sp>
+    </p:spTree>
+    <p:extLst>
+      <p:ext uri="{BB962C8B-B14F-4D97-AF65-F5344CB8AC3E}">
+        <p14:creationId xmlns:p14="http://schemas.microsoft.com/office/powerpoint/2010/main" val="2717718308"/>
+      </p:ext>
+    </p:extLst>
+  </p:cSld>
+  <p:clrMapOvr>
+    <a:masterClrMapping/>
+  </p:clrMapOvr>
+  <p:timing>
+    <p:tnLst>
+      <p:par>
+        <p:cTn id="1" dur="indefinite" restart="never" nodeType="tmRoot">
+          <p:childTnLst>
+            <p:seq concurrent="1" nextAc="seek">
+              <p:cTn id="2" dur="indefinite" nodeType="mainSeq">
+                <p:childTnLst>
+                  <p:par>
+                    <p:cTn id="3" fill="hold">
+                      <p:stCondLst>
+                        <p:cond delay="indefinite"/>
+                      </p:stCondLst>
+                      <p:childTnLst>
+                        <p:par>
+                          <p:cTn id="4" fill="hold">
+                            <p:stCondLst>
+                              <p:cond delay="0"/>
+                            </p:stCondLst>
+                            <p:childTnLst>
+                              <p:par>
+                                <p:cTn id="5" presetID="1" presetClass="entr" presetSubtype="0" fill="hold" grpId="0" nodeType="clickEffect">
+                                  <p:stCondLst>
+                                    <p:cond delay="0"/>
+                                  </p:stCondLst>
+                                  <p:childTnLst>
+                                    <p:set>
+                                      <p:cBhvr>
+                                        <p:cTn id="6" dur="1" fill="hold">
+                                          <p:stCondLst>
+                                            <p:cond delay="0"/>
+                                          </p:stCondLst>
+                                        </p:cTn>
+                                        <p:tgtEl>
+                                          <p:spTgt spid="4"/>
+                                        </p:tgtEl>
+                                        <p:attrNameLst>
+                                          <p:attrName>style.visibility</p:attrName>
+                                        </p:attrNameLst>
+                                      </p:cBhvr>
+                                      <p:to>
+                                        <p:strVal val="visible"/>
+                                      </p:to>
+                                    </p:set>
+                                  </p:childTnLst>
+                                </p:cTn>
+                              </p:par>
+                            </p:childTnLst>
+                          </p:cTn>
+                        </p:par>
+                      </p:childTnLst>
+                    </p:cTn>
+                  </p:par>
+                </p:childTnLst>
+              </p:cTn>
+              <p:prevCondLst>
+                <p:cond evt="onPrev" delay="0">
+                  <p:tgtEl>
+                    <p:sldTgt/>
+                  </p:tgtEl>
+                </p:cond>
+              </p:prevCondLst>
+              <p:nextCondLst>
+                <p:cond evt="onNext" delay="0">
+                  <p:tgtEl>
+                    <p:sldTgt/>
+                  </p:tgtEl>
+                </p:cond>
+              </p:nextCondLst>
+            </p:seq>
+          </p:childTnLst>
+        </p:cTn>
+      </p:par>
+    </p:tnLst>
+    <p:bldLst>
+      <p:bldP spid="4" grpId="0" animBg="1"/>
+    </p:bldLst>
+  </p:timing>
+</p:sldLayout>
+</file>
+
+<file path=ppt/slideLayouts/slideLayout12.xml><?xml version="1.0" encoding="utf-8"?>
 <p:sldLayout xmlns:a="http://schemas.openxmlformats.org/drawingml/2006/main" xmlns:r="http://schemas.openxmlformats.org/officeDocument/2006/relationships" xmlns:p="http://schemas.openxmlformats.org/presentationml/2006/main" preserve="1" userDrawn="1">
   <p:cSld name="ab_dulden_d">
     <p:spTree>
@@ -5471,7 +6215,7 @@
 </p:sldLayout>
 </file>
 
-<file path=ppt/slideLayouts/slideLayout11.xml><?xml version="1.0" encoding="utf-8"?>
+<file path=ppt/slideLayouts/slideLayout13.xml><?xml version="1.0" encoding="utf-8"?>
 <p:sldLayout xmlns:a="http://schemas.openxmlformats.org/drawingml/2006/main" xmlns:r="http://schemas.openxmlformats.org/officeDocument/2006/relationships" xmlns:p="http://schemas.openxmlformats.org/presentationml/2006/main" preserve="1" userDrawn="1">
   <p:cSld name="ab_handeln_d">
     <p:spTree>
@@ -5594,7 +6338,7 @@
 </p:sldLayout>
 </file>
 
-<file path=ppt/slideLayouts/slideLayout12.xml><?xml version="1.0" encoding="utf-8"?>
+<file path=ppt/slideLayouts/slideLayout14.xml><?xml version="1.0" encoding="utf-8"?>
 <p:sldLayout xmlns:a="http://schemas.openxmlformats.org/drawingml/2006/main" xmlns:r="http://schemas.openxmlformats.org/officeDocument/2006/relationships" xmlns:p="http://schemas.openxmlformats.org/presentationml/2006/main" preserve="1" userDrawn="1">
   <p:cSld name="ab_vorbild_d">
     <p:spTree>
@@ -5803,7 +6547,7 @@
 </p:sldLayout>
 </file>
 
-<file path=ppt/slideLayouts/slideLayout13.xml><?xml version="1.0" encoding="utf-8"?>
+<file path=ppt/slideLayouts/slideLayout15.xml><?xml version="1.0" encoding="utf-8"?>
 <p:sldLayout xmlns:a="http://schemas.openxmlformats.org/drawingml/2006/main" xmlns:r="http://schemas.openxmlformats.org/officeDocument/2006/relationships" xmlns:p="http://schemas.openxmlformats.org/presentationml/2006/main" showMasterSp="0" preserve="1" userDrawn="1">
   <p:cSld name="ab_picture">
     <p:bg>
@@ -5922,7 +6666,7 @@
 </p:sldLayout>
 </file>
 
-<file path=ppt/slideLayouts/slideLayout14.xml><?xml version="1.0" encoding="utf-8"?>
+<file path=ppt/slideLayouts/slideLayout16.xml><?xml version="1.0" encoding="utf-8"?>
 <p:sldLayout xmlns:a="http://schemas.openxmlformats.org/drawingml/2006/main" xmlns:r="http://schemas.openxmlformats.org/officeDocument/2006/relationships" xmlns:p="http://schemas.openxmlformats.org/presentationml/2006/main" preserve="1" userDrawn="1">
   <p:cSld name="ab_verhindern_d">
     <p:spTree>
@@ -6037,7 +6781,7 @@
 </p:sldLayout>
 </file>
 
-<file path=ppt/slideLayouts/slideLayout15.xml><?xml version="1.0" encoding="utf-8"?>
+<file path=ppt/slideLayouts/slideLayout17.xml><?xml version="1.0" encoding="utf-8"?>
 <p:sldLayout xmlns:a="http://schemas.openxmlformats.org/drawingml/2006/main" xmlns:r="http://schemas.openxmlformats.org/officeDocument/2006/relationships" xmlns:p="http://schemas.openxmlformats.org/presentationml/2006/main" preserve="1" userDrawn="1">
   <p:cSld name="ab_audit_d">
     <p:spTree>
@@ -6894,7 +7638,7 @@
 </p:sldLayout>
 </file>
 
-<file path=ppt/slideLayouts/slideLayout16.xml><?xml version="1.0" encoding="utf-8"?>
+<file path=ppt/slideLayouts/slideLayout18.xml><?xml version="1.0" encoding="utf-8"?>
 <p:sldLayout xmlns:a="http://schemas.openxmlformats.org/drawingml/2006/main" xmlns:r="http://schemas.openxmlformats.org/officeDocument/2006/relationships" xmlns:p="http://schemas.openxmlformats.org/presentationml/2006/main" preserve="1" userDrawn="1">
   <p:cSld name="ab_risikobeurteilung_d">
     <p:spTree>
@@ -9773,7 +10517,7 @@
 </p:sldLayout>
 </file>
 
-<file path=ppt/slideLayouts/slideLayout17.xml><?xml version="1.0" encoding="utf-8"?>
+<file path=ppt/slideLayouts/slideLayout19.xml><?xml version="1.0" encoding="utf-8"?>
 <p:sldLayout xmlns:a="http://schemas.openxmlformats.org/drawingml/2006/main" xmlns:r="http://schemas.openxmlformats.org/officeDocument/2006/relationships" xmlns:p="http://schemas.openxmlformats.org/presentationml/2006/main" preserve="1" userDrawn="1">
   <p:cSld name="ab_aviva_d">
     <p:spTree>
@@ -10016,7 +10760,287 @@
 </p:sldLayout>
 </file>
 
-<file path=ppt/slideLayouts/slideLayout18.xml><?xml version="1.0" encoding="utf-8"?>
+<file path=ppt/slideLayouts/slideLayout2.xml><?xml version="1.0" encoding="utf-8"?>
+<p:sldLayout xmlns:a="http://schemas.openxmlformats.org/drawingml/2006/main" xmlns:r="http://schemas.openxmlformats.org/officeDocument/2006/relationships" xmlns:p="http://schemas.openxmlformats.org/presentationml/2006/main" showMasterSp="0" preserve="1" userDrawn="1">
+  <p:cSld name="ab_title">
+    <p:bg>
+      <p:bgPr>
+        <a:solidFill>
+          <a:schemeClr val="bg1"/>
+        </a:solidFill>
+        <a:effectLst/>
+      </p:bgPr>
+    </p:bg>
+    <p:spTree>
+      <p:nvGrpSpPr>
+        <p:cNvPr id="1" name=""/>
+        <p:cNvGrpSpPr/>
+        <p:nvPr/>
+      </p:nvGrpSpPr>
+      <p:grpSpPr>
+        <a:xfrm>
+          <a:off x="0" y="0"/>
+          <a:ext cx="0" cy="0"/>
+          <a:chOff x="0" y="0"/>
+          <a:chExt cx="0" cy="0"/>
+        </a:xfrm>
+      </p:grpSpPr>
+      <p:sp>
+        <p:nvSpPr>
+          <p:cNvPr id="2" name="Title 1">
+            <a:extLst>
+              <a:ext uri="{FF2B5EF4-FFF2-40B4-BE49-F238E27FC236}">
+                <a16:creationId xmlns:a16="http://schemas.microsoft.com/office/drawing/2014/main" id="{72DA4C8A-1625-4420-BC20-C587ECC49B13}"/>
+              </a:ext>
+            </a:extLst>
+          </p:cNvPr>
+          <p:cNvSpPr>
+            <a:spLocks noGrp="1"/>
+          </p:cNvSpPr>
+          <p:nvPr>
+            <p:ph type="ctrTitle"/>
+          </p:nvPr>
+        </p:nvSpPr>
+        <p:spPr>
+          <a:xfrm>
+            <a:off x="551384" y="4581128"/>
+            <a:ext cx="7776864" cy="1152128"/>
+          </a:xfrm>
+        </p:spPr>
+        <p:txBody>
+          <a:bodyPr anchor="b"/>
+          <a:lstStyle>
+            <a:lvl1pPr algn="l">
+              <a:lnSpc>
+                <a:spcPct val="90000"/>
+              </a:lnSpc>
+              <a:defRPr sz="3600">
+                <a:solidFill>
+                  <a:schemeClr val="accent2"/>
+                </a:solidFill>
+              </a:defRPr>
+            </a:lvl1pPr>
+          </a:lstStyle>
+          <a:p>
+            <a:r>
+              <a:rPr lang="de-DE"/>
+              <a:t>Titelmasterformat durch Klicken bearbeiten</a:t>
+            </a:r>
+            <a:endParaRPr lang="de-CH"/>
+          </a:p>
+        </p:txBody>
+      </p:sp>
+      <p:sp>
+        <p:nvSpPr>
+          <p:cNvPr id="3" name="Subtitle 2">
+            <a:extLst>
+              <a:ext uri="{FF2B5EF4-FFF2-40B4-BE49-F238E27FC236}">
+                <a16:creationId xmlns:a16="http://schemas.microsoft.com/office/drawing/2014/main" id="{054364AC-34B8-4813-874E-7F08A9667AC8}"/>
+              </a:ext>
+            </a:extLst>
+          </p:cNvPr>
+          <p:cNvSpPr>
+            <a:spLocks noGrp="1"/>
+          </p:cNvSpPr>
+          <p:nvPr>
+            <p:ph type="subTitle" idx="1"/>
+          </p:nvPr>
+        </p:nvSpPr>
+        <p:spPr>
+          <a:xfrm>
+            <a:off x="551384" y="5922628"/>
+            <a:ext cx="7776864" cy="659146"/>
+          </a:xfrm>
+        </p:spPr>
+        <p:txBody>
+          <a:bodyPr/>
+          <a:lstStyle>
+            <a:lvl1pPr marL="0" indent="0" algn="l">
+              <a:buNone/>
+              <a:defRPr sz="1400" b="1">
+                <a:solidFill>
+                  <a:schemeClr val="accent1"/>
+                </a:solidFill>
+              </a:defRPr>
+            </a:lvl1pPr>
+            <a:lvl2pPr marL="457200" indent="0" algn="ctr">
+              <a:buNone/>
+              <a:defRPr sz="2000"/>
+            </a:lvl2pPr>
+            <a:lvl3pPr marL="914400" indent="0" algn="ctr">
+              <a:buNone/>
+              <a:defRPr sz="1800"/>
+            </a:lvl3pPr>
+            <a:lvl4pPr marL="1371600" indent="0" algn="ctr">
+              <a:buNone/>
+              <a:defRPr sz="1600"/>
+            </a:lvl4pPr>
+            <a:lvl5pPr marL="1828800" indent="0" algn="ctr">
+              <a:buNone/>
+              <a:defRPr sz="1600"/>
+            </a:lvl5pPr>
+            <a:lvl6pPr marL="2286000" indent="0" algn="ctr">
+              <a:buNone/>
+              <a:defRPr sz="1600"/>
+            </a:lvl6pPr>
+            <a:lvl7pPr marL="2743200" indent="0" algn="ctr">
+              <a:buNone/>
+              <a:defRPr sz="1600"/>
+            </a:lvl7pPr>
+            <a:lvl8pPr marL="3200400" indent="0" algn="ctr">
+              <a:buNone/>
+              <a:defRPr sz="1600"/>
+            </a:lvl8pPr>
+            <a:lvl9pPr marL="3657600" indent="0" algn="ctr">
+              <a:buNone/>
+              <a:defRPr sz="1600"/>
+            </a:lvl9pPr>
+          </a:lstStyle>
+          <a:p>
+            <a:r>
+              <a:rPr lang="de-DE"/>
+              <a:t>Formatvorlage des Untertitelmasters durch Klicken bearbeiten</a:t>
+            </a:r>
+            <a:endParaRPr lang="de-CH"/>
+          </a:p>
+        </p:txBody>
+      </p:sp>
+      <p:sp>
+        <p:nvSpPr>
+          <p:cNvPr id="7" name="Picture Placeholder 6">
+            <a:extLst>
+              <a:ext uri="{FF2B5EF4-FFF2-40B4-BE49-F238E27FC236}">
+                <a16:creationId xmlns:a16="http://schemas.microsoft.com/office/drawing/2014/main" id="{77BF588B-D687-40C3-9EF3-F45FB15D281D}"/>
+              </a:ext>
+            </a:extLst>
+          </p:cNvPr>
+          <p:cNvSpPr>
+            <a:spLocks noGrp="1"/>
+          </p:cNvSpPr>
+          <p:nvPr>
+            <p:ph type="pic" sz="quarter" idx="10"/>
+          </p:nvPr>
+        </p:nvSpPr>
+        <p:spPr>
+          <a:xfrm>
+            <a:off x="-2458" y="549275"/>
+            <a:ext cx="11643596" cy="3887788"/>
+          </a:xfrm>
+          <a:solidFill>
+            <a:schemeClr val="accent1">
+              <a:lumMod val="20000"/>
+              <a:lumOff val="80000"/>
+            </a:schemeClr>
+          </a:solidFill>
+        </p:spPr>
+        <p:txBody>
+          <a:bodyPr/>
+          <a:lstStyle>
+            <a:lvl1pPr marL="0" indent="0" algn="ctr">
+              <a:buNone/>
+              <a:defRPr/>
+            </a:lvl1pPr>
+          </a:lstStyle>
+          <a:p>
+            <a:r>
+              <a:rPr lang="de-DE"/>
+              <a:t>Bild durch Klicken auf Symbol hinzufügen</a:t>
+            </a:r>
+            <a:endParaRPr lang="en-US"/>
+          </a:p>
+        </p:txBody>
+      </p:sp>
+      <p:pic>
+        <p:nvPicPr>
+          <p:cNvPr id="8" name="Picture 7">
+            <a:extLst>
+              <a:ext uri="{FF2B5EF4-FFF2-40B4-BE49-F238E27FC236}">
+                <a16:creationId xmlns:a16="http://schemas.microsoft.com/office/drawing/2014/main" id="{4DE87502-C174-4E97-8780-2A00C529A84E}"/>
+              </a:ext>
+            </a:extLst>
+          </p:cNvPr>
+          <p:cNvPicPr>
+            <a:picLocks noChangeAspect="1"/>
+          </p:cNvPicPr>
+          <p:nvPr userDrawn="1"/>
+        </p:nvPicPr>
+        <p:blipFill>
+          <a:blip r:embed="rId2" cstate="print">
+            <a:extLst>
+              <a:ext uri="{28A0092B-C50C-407E-A947-70E740481C1C}">
+                <a14:useLocalDpi xmlns:a14="http://schemas.microsoft.com/office/drawing/2010/main" val="0"/>
+              </a:ext>
+            </a:extLst>
+          </a:blip>
+          <a:stretch>
+            <a:fillRect/>
+          </a:stretch>
+        </p:blipFill>
+        <p:spPr>
+          <a:xfrm>
+            <a:off x="10212366" y="5959998"/>
+            <a:ext cx="1440160" cy="361379"/>
+          </a:xfrm>
+          <a:prstGeom prst="rect">
+            <a:avLst/>
+          </a:prstGeom>
+        </p:spPr>
+      </p:pic>
+      <p:sp>
+        <p:nvSpPr>
+          <p:cNvPr id="10" name="Picture Placeholder 8">
+            <a:extLst>
+              <a:ext uri="{FF2B5EF4-FFF2-40B4-BE49-F238E27FC236}">
+                <a16:creationId xmlns:a16="http://schemas.microsoft.com/office/drawing/2014/main" id="{E8237610-DD2B-43F8-878C-2B011C2CF700}"/>
+              </a:ext>
+            </a:extLst>
+          </p:cNvPr>
+          <p:cNvSpPr>
+            <a:spLocks noGrp="1" noChangeAspect="1"/>
+          </p:cNvSpPr>
+          <p:nvPr>
+            <p:ph type="pic" sz="quarter" idx="12" hasCustomPrompt="1"/>
+          </p:nvPr>
+        </p:nvSpPr>
+        <p:spPr>
+          <a:xfrm>
+            <a:off x="8543925" y="5156795"/>
+            <a:ext cx="1152000" cy="1152525"/>
+          </a:xfrm>
+          <a:solidFill>
+            <a:schemeClr val="bg1"/>
+          </a:solidFill>
+        </p:spPr>
+        <p:txBody>
+          <a:bodyPr/>
+          <a:lstStyle>
+            <a:lvl1pPr marL="0" indent="0" algn="ctr">
+              <a:buNone/>
+              <a:defRPr/>
+            </a:lvl1pPr>
+          </a:lstStyle>
+          <a:p>
+            <a:r>
+              <a:rPr lang="de-CH"/>
+              <a:t>Logo</a:t>
+            </a:r>
+          </a:p>
+        </p:txBody>
+      </p:sp>
+    </p:spTree>
+    <p:extLst>
+      <p:ext uri="{BB962C8B-B14F-4D97-AF65-F5344CB8AC3E}">
+        <p14:creationId xmlns:p14="http://schemas.microsoft.com/office/powerpoint/2010/main" val="3123631928"/>
+      </p:ext>
+    </p:extLst>
+  </p:cSld>
+  <p:clrMapOvr>
+    <a:masterClrMapping/>
+  </p:clrMapOvr>
+</p:sldLayout>
+</file>
+
+<file path=ppt/slideLayouts/slideLayout20.xml><?xml version="1.0" encoding="utf-8"?>
 <p:sldLayout xmlns:a="http://schemas.openxmlformats.org/drawingml/2006/main" xmlns:r="http://schemas.openxmlformats.org/officeDocument/2006/relationships" xmlns:p="http://schemas.openxmlformats.org/presentationml/2006/main" showMasterSp="0" preserve="1" userDrawn="1">
   <p:cSld name="Kapiteltrenner (orange)">
     <p:bg>
@@ -10138,7 +11162,7 @@
 </p:sldLayout>
 </file>
 
-<file path=ppt/slideLayouts/slideLayout19.xml><?xml version="1.0" encoding="utf-8"?>
+<file path=ppt/slideLayouts/slideLayout21.xml><?xml version="1.0" encoding="utf-8"?>
 <p:sldLayout xmlns:a="http://schemas.openxmlformats.org/drawingml/2006/main" xmlns:r="http://schemas.openxmlformats.org/officeDocument/2006/relationships" xmlns:p="http://schemas.openxmlformats.org/presentationml/2006/main" preserve="1" userDrawn="1">
   <p:cSld name="Titel neues Design (co-Branding)">
     <p:spTree>
@@ -11426,287 +12450,7 @@
 </p:sldLayout>
 </file>
 
-<file path=ppt/slideLayouts/slideLayout2.xml><?xml version="1.0" encoding="utf-8"?>
-<p:sldLayout xmlns:a="http://schemas.openxmlformats.org/drawingml/2006/main" xmlns:r="http://schemas.openxmlformats.org/officeDocument/2006/relationships" xmlns:p="http://schemas.openxmlformats.org/presentationml/2006/main" showMasterSp="0" preserve="1" userDrawn="1">
-  <p:cSld name="ab_title">
-    <p:bg>
-      <p:bgPr>
-        <a:solidFill>
-          <a:schemeClr val="bg1"/>
-        </a:solidFill>
-        <a:effectLst/>
-      </p:bgPr>
-    </p:bg>
-    <p:spTree>
-      <p:nvGrpSpPr>
-        <p:cNvPr id="1" name=""/>
-        <p:cNvGrpSpPr/>
-        <p:nvPr/>
-      </p:nvGrpSpPr>
-      <p:grpSpPr>
-        <a:xfrm>
-          <a:off x="0" y="0"/>
-          <a:ext cx="0" cy="0"/>
-          <a:chOff x="0" y="0"/>
-          <a:chExt cx="0" cy="0"/>
-        </a:xfrm>
-      </p:grpSpPr>
-      <p:sp>
-        <p:nvSpPr>
-          <p:cNvPr id="2" name="Title 1">
-            <a:extLst>
-              <a:ext uri="{FF2B5EF4-FFF2-40B4-BE49-F238E27FC236}">
-                <a16:creationId xmlns:a16="http://schemas.microsoft.com/office/drawing/2014/main" id="{72DA4C8A-1625-4420-BC20-C587ECC49B13}"/>
-              </a:ext>
-            </a:extLst>
-          </p:cNvPr>
-          <p:cNvSpPr>
-            <a:spLocks noGrp="1"/>
-          </p:cNvSpPr>
-          <p:nvPr>
-            <p:ph type="ctrTitle"/>
-          </p:nvPr>
-        </p:nvSpPr>
-        <p:spPr>
-          <a:xfrm>
-            <a:off x="551384" y="4581128"/>
-            <a:ext cx="7776864" cy="1152128"/>
-          </a:xfrm>
-        </p:spPr>
-        <p:txBody>
-          <a:bodyPr anchor="b"/>
-          <a:lstStyle>
-            <a:lvl1pPr algn="l">
-              <a:lnSpc>
-                <a:spcPct val="90000"/>
-              </a:lnSpc>
-              <a:defRPr sz="3600">
-                <a:solidFill>
-                  <a:schemeClr val="accent2"/>
-                </a:solidFill>
-              </a:defRPr>
-            </a:lvl1pPr>
-          </a:lstStyle>
-          <a:p>
-            <a:r>
-              <a:rPr lang="de-DE"/>
-              <a:t>Titelmasterformat durch Klicken bearbeiten</a:t>
-            </a:r>
-            <a:endParaRPr lang="de-CH"/>
-          </a:p>
-        </p:txBody>
-      </p:sp>
-      <p:sp>
-        <p:nvSpPr>
-          <p:cNvPr id="3" name="Subtitle 2">
-            <a:extLst>
-              <a:ext uri="{FF2B5EF4-FFF2-40B4-BE49-F238E27FC236}">
-                <a16:creationId xmlns:a16="http://schemas.microsoft.com/office/drawing/2014/main" id="{054364AC-34B8-4813-874E-7F08A9667AC8}"/>
-              </a:ext>
-            </a:extLst>
-          </p:cNvPr>
-          <p:cNvSpPr>
-            <a:spLocks noGrp="1"/>
-          </p:cNvSpPr>
-          <p:nvPr>
-            <p:ph type="subTitle" idx="1"/>
-          </p:nvPr>
-        </p:nvSpPr>
-        <p:spPr>
-          <a:xfrm>
-            <a:off x="551384" y="5922628"/>
-            <a:ext cx="7776864" cy="659146"/>
-          </a:xfrm>
-        </p:spPr>
-        <p:txBody>
-          <a:bodyPr/>
-          <a:lstStyle>
-            <a:lvl1pPr marL="0" indent="0" algn="l">
-              <a:buNone/>
-              <a:defRPr sz="1400" b="1">
-                <a:solidFill>
-                  <a:schemeClr val="accent1"/>
-                </a:solidFill>
-              </a:defRPr>
-            </a:lvl1pPr>
-            <a:lvl2pPr marL="457200" indent="0" algn="ctr">
-              <a:buNone/>
-              <a:defRPr sz="2000"/>
-            </a:lvl2pPr>
-            <a:lvl3pPr marL="914400" indent="0" algn="ctr">
-              <a:buNone/>
-              <a:defRPr sz="1800"/>
-            </a:lvl3pPr>
-            <a:lvl4pPr marL="1371600" indent="0" algn="ctr">
-              <a:buNone/>
-              <a:defRPr sz="1600"/>
-            </a:lvl4pPr>
-            <a:lvl5pPr marL="1828800" indent="0" algn="ctr">
-              <a:buNone/>
-              <a:defRPr sz="1600"/>
-            </a:lvl5pPr>
-            <a:lvl6pPr marL="2286000" indent="0" algn="ctr">
-              <a:buNone/>
-              <a:defRPr sz="1600"/>
-            </a:lvl6pPr>
-            <a:lvl7pPr marL="2743200" indent="0" algn="ctr">
-              <a:buNone/>
-              <a:defRPr sz="1600"/>
-            </a:lvl7pPr>
-            <a:lvl8pPr marL="3200400" indent="0" algn="ctr">
-              <a:buNone/>
-              <a:defRPr sz="1600"/>
-            </a:lvl8pPr>
-            <a:lvl9pPr marL="3657600" indent="0" algn="ctr">
-              <a:buNone/>
-              <a:defRPr sz="1600"/>
-            </a:lvl9pPr>
-          </a:lstStyle>
-          <a:p>
-            <a:r>
-              <a:rPr lang="de-DE"/>
-              <a:t>Formatvorlage des Untertitelmasters durch Klicken bearbeiten</a:t>
-            </a:r>
-            <a:endParaRPr lang="de-CH"/>
-          </a:p>
-        </p:txBody>
-      </p:sp>
-      <p:sp>
-        <p:nvSpPr>
-          <p:cNvPr id="7" name="Picture Placeholder 6">
-            <a:extLst>
-              <a:ext uri="{FF2B5EF4-FFF2-40B4-BE49-F238E27FC236}">
-                <a16:creationId xmlns:a16="http://schemas.microsoft.com/office/drawing/2014/main" id="{77BF588B-D687-40C3-9EF3-F45FB15D281D}"/>
-              </a:ext>
-            </a:extLst>
-          </p:cNvPr>
-          <p:cNvSpPr>
-            <a:spLocks noGrp="1"/>
-          </p:cNvSpPr>
-          <p:nvPr>
-            <p:ph type="pic" sz="quarter" idx="10"/>
-          </p:nvPr>
-        </p:nvSpPr>
-        <p:spPr>
-          <a:xfrm>
-            <a:off x="-2458" y="549275"/>
-            <a:ext cx="11643596" cy="3887788"/>
-          </a:xfrm>
-          <a:solidFill>
-            <a:schemeClr val="accent1">
-              <a:lumMod val="20000"/>
-              <a:lumOff val="80000"/>
-            </a:schemeClr>
-          </a:solidFill>
-        </p:spPr>
-        <p:txBody>
-          <a:bodyPr/>
-          <a:lstStyle>
-            <a:lvl1pPr marL="0" indent="0" algn="ctr">
-              <a:buNone/>
-              <a:defRPr/>
-            </a:lvl1pPr>
-          </a:lstStyle>
-          <a:p>
-            <a:r>
-              <a:rPr lang="de-DE"/>
-              <a:t>Bild durch Klicken auf Symbol hinzufügen</a:t>
-            </a:r>
-            <a:endParaRPr lang="en-US"/>
-          </a:p>
-        </p:txBody>
-      </p:sp>
-      <p:pic>
-        <p:nvPicPr>
-          <p:cNvPr id="8" name="Picture 7">
-            <a:extLst>
-              <a:ext uri="{FF2B5EF4-FFF2-40B4-BE49-F238E27FC236}">
-                <a16:creationId xmlns:a16="http://schemas.microsoft.com/office/drawing/2014/main" id="{4DE87502-C174-4E97-8780-2A00C529A84E}"/>
-              </a:ext>
-            </a:extLst>
-          </p:cNvPr>
-          <p:cNvPicPr>
-            <a:picLocks noChangeAspect="1"/>
-          </p:cNvPicPr>
-          <p:nvPr userDrawn="1"/>
-        </p:nvPicPr>
-        <p:blipFill>
-          <a:blip r:embed="rId2" cstate="print">
-            <a:extLst>
-              <a:ext uri="{28A0092B-C50C-407E-A947-70E740481C1C}">
-                <a14:useLocalDpi xmlns:a14="http://schemas.microsoft.com/office/drawing/2010/main" val="0"/>
-              </a:ext>
-            </a:extLst>
-          </a:blip>
-          <a:stretch>
-            <a:fillRect/>
-          </a:stretch>
-        </p:blipFill>
-        <p:spPr>
-          <a:xfrm>
-            <a:off x="10212366" y="5959998"/>
-            <a:ext cx="1440160" cy="361379"/>
-          </a:xfrm>
-          <a:prstGeom prst="rect">
-            <a:avLst/>
-          </a:prstGeom>
-        </p:spPr>
-      </p:pic>
-      <p:sp>
-        <p:nvSpPr>
-          <p:cNvPr id="10" name="Picture Placeholder 8">
-            <a:extLst>
-              <a:ext uri="{FF2B5EF4-FFF2-40B4-BE49-F238E27FC236}">
-                <a16:creationId xmlns:a16="http://schemas.microsoft.com/office/drawing/2014/main" id="{E8237610-DD2B-43F8-878C-2B011C2CF700}"/>
-              </a:ext>
-            </a:extLst>
-          </p:cNvPr>
-          <p:cNvSpPr>
-            <a:spLocks noGrp="1" noChangeAspect="1"/>
-          </p:cNvSpPr>
-          <p:nvPr>
-            <p:ph type="pic" sz="quarter" idx="12" hasCustomPrompt="1"/>
-          </p:nvPr>
-        </p:nvSpPr>
-        <p:spPr>
-          <a:xfrm>
-            <a:off x="8543925" y="5156795"/>
-            <a:ext cx="1152000" cy="1152525"/>
-          </a:xfrm>
-          <a:solidFill>
-            <a:schemeClr val="bg1"/>
-          </a:solidFill>
-        </p:spPr>
-        <p:txBody>
-          <a:bodyPr/>
-          <a:lstStyle>
-            <a:lvl1pPr marL="0" indent="0" algn="ctr">
-              <a:buNone/>
-              <a:defRPr/>
-            </a:lvl1pPr>
-          </a:lstStyle>
-          <a:p>
-            <a:r>
-              <a:rPr lang="de-CH"/>
-              <a:t>Logo</a:t>
-            </a:r>
-          </a:p>
-        </p:txBody>
-      </p:sp>
-    </p:spTree>
-    <p:extLst>
-      <p:ext uri="{BB962C8B-B14F-4D97-AF65-F5344CB8AC3E}">
-        <p14:creationId xmlns:p14="http://schemas.microsoft.com/office/powerpoint/2010/main" val="3123631928"/>
-      </p:ext>
-    </p:extLst>
-  </p:cSld>
-  <p:clrMapOvr>
-    <a:masterClrMapping/>
-  </p:clrMapOvr>
-</p:sldLayout>
-</file>
-
-<file path=ppt/slideLayouts/slideLayout20.xml><?xml version="1.0" encoding="utf-8"?>
+<file path=ppt/slideLayouts/slideLayout22.xml><?xml version="1.0" encoding="utf-8"?>
 <p:sldLayout xmlns:a="http://schemas.openxmlformats.org/drawingml/2006/main" xmlns:r="http://schemas.openxmlformats.org/officeDocument/2006/relationships" xmlns:p="http://schemas.openxmlformats.org/presentationml/2006/main" preserve="1" userDrawn="1">
   <p:cSld name="Partnerfolie">
     <p:spTree>
@@ -11941,7 +12685,7 @@
 </p:sldLayout>
 </file>
 
-<file path=ppt/slideLayouts/slideLayout21.xml><?xml version="1.0" encoding="utf-8"?>
+<file path=ppt/slideLayouts/slideLayout23.xml><?xml version="1.0" encoding="utf-8"?>
 <p:sldLayout xmlns:a="http://schemas.openxmlformats.org/drawingml/2006/main" xmlns:r="http://schemas.openxmlformats.org/officeDocument/2006/relationships" xmlns:p="http://schemas.openxmlformats.org/presentationml/2006/main" type="obj" preserve="1">
   <p:cSld name="Agenda">
     <p:spTree>
@@ -12126,7 +12870,7 @@
 </p:sldLayout>
 </file>
 
-<file path=ppt/slideLayouts/slideLayout22.xml><?xml version="1.0" encoding="utf-8"?>
+<file path=ppt/slideLayouts/slideLayout24.xml><?xml version="1.0" encoding="utf-8"?>
 <p:sldLayout xmlns:a="http://schemas.openxmlformats.org/drawingml/2006/main" xmlns:r="http://schemas.openxmlformats.org/officeDocument/2006/relationships" xmlns:p="http://schemas.openxmlformats.org/presentationml/2006/main" preserve="1" userDrawn="1">
   <p:cSld name="Titel und Inhalt (24 pt)">
     <p:spTree>
@@ -12281,7 +13025,7 @@
 </p:sldLayout>
 </file>
 
-<file path=ppt/slideLayouts/slideLayout23.xml><?xml version="1.0" encoding="utf-8"?>
+<file path=ppt/slideLayouts/slideLayout25.xml><?xml version="1.0" encoding="utf-8"?>
 <p:sldLayout xmlns:a="http://schemas.openxmlformats.org/drawingml/2006/main" xmlns:r="http://schemas.openxmlformats.org/officeDocument/2006/relationships" xmlns:p="http://schemas.openxmlformats.org/presentationml/2006/main" preserve="1" userDrawn="1">
   <p:cSld name="Titel und Inhalt  (co-Branduing)">
     <p:spTree>
@@ -12477,7 +13221,7 @@
 </p:sldLayout>
 </file>
 
-<file path=ppt/slideLayouts/slideLayout24.xml><?xml version="1.0" encoding="utf-8"?>
+<file path=ppt/slideLayouts/slideLayout26.xml><?xml version="1.0" encoding="utf-8"?>
 <p:sldLayout xmlns:a="http://schemas.openxmlformats.org/drawingml/2006/main" xmlns:r="http://schemas.openxmlformats.org/officeDocument/2006/relationships" xmlns:p="http://schemas.openxmlformats.org/presentationml/2006/main" preserve="1" userDrawn="1">
   <p:cSld name="Kundenauswertung">
     <p:spTree>
@@ -12641,7 +13385,7 @@
 </p:sldLayout>
 </file>
 
-<file path=ppt/slideLayouts/slideLayout25.xml><?xml version="1.0" encoding="utf-8"?>
+<file path=ppt/slideLayouts/slideLayout27.xml><?xml version="1.0" encoding="utf-8"?>
 <p:sldLayout xmlns:a="http://schemas.openxmlformats.org/drawingml/2006/main" xmlns:r="http://schemas.openxmlformats.org/officeDocument/2006/relationships" xmlns:p="http://schemas.openxmlformats.org/presentationml/2006/main" preserve="1" userDrawn="1">
   <p:cSld name="Zitate, Berichte und Tabellen">
     <p:spTree>
@@ -12764,7 +13508,7 @@
 </p:sldLayout>
 </file>
 
-<file path=ppt/slideLayouts/slideLayout26.xml><?xml version="1.0" encoding="utf-8"?>
+<file path=ppt/slideLayouts/slideLayout28.xml><?xml version="1.0" encoding="utf-8"?>
 <p:sldLayout xmlns:a="http://schemas.openxmlformats.org/drawingml/2006/main" xmlns:r="http://schemas.openxmlformats.org/officeDocument/2006/relationships" xmlns:p="http://schemas.openxmlformats.org/presentationml/2006/main" preserve="1" userDrawn="1">
   <p:cSld name="Titel zweispaltig (20 pt)">
     <p:spTree>
@@ -12930,7 +13674,7 @@
 </p:sldLayout>
 </file>
 
-<file path=ppt/slideLayouts/slideLayout27.xml><?xml version="1.0" encoding="utf-8"?>
+<file path=ppt/slideLayouts/slideLayout29.xml><?xml version="1.0" encoding="utf-8"?>
 <p:sldLayout xmlns:a="http://schemas.openxmlformats.org/drawingml/2006/main" xmlns:r="http://schemas.openxmlformats.org/officeDocument/2006/relationships" xmlns:p="http://schemas.openxmlformats.org/presentationml/2006/main" preserve="1" userDrawn="1">
   <p:cSld name="Titel zweispaltig (co-Branding)">
     <p:spTree>
@@ -13149,200 +13893,6 @@
 </p:sldLayout>
 </file>
 
-<file path=ppt/slideLayouts/slideLayout28.xml><?xml version="1.0" encoding="utf-8"?>
-<p:sldLayout xmlns:a="http://schemas.openxmlformats.org/drawingml/2006/main" xmlns:r="http://schemas.openxmlformats.org/officeDocument/2006/relationships" xmlns:p="http://schemas.openxmlformats.org/presentationml/2006/main" preserve="1" userDrawn="1">
-  <p:cSld name="Bild grossflächig">
-    <p:spTree>
-      <p:nvGrpSpPr>
-        <p:cNvPr id="1" name=""/>
-        <p:cNvGrpSpPr/>
-        <p:nvPr/>
-      </p:nvGrpSpPr>
-      <p:grpSpPr>
-        <a:xfrm>
-          <a:off x="0" y="0"/>
-          <a:ext cx="0" cy="0"/>
-          <a:chOff x="0" y="0"/>
-          <a:chExt cx="0" cy="0"/>
-        </a:xfrm>
-      </p:grpSpPr>
-      <p:sp>
-        <p:nvSpPr>
-          <p:cNvPr id="12" name="Picture Placeholder 11">
-            <a:extLst>
-              <a:ext uri="{FF2B5EF4-FFF2-40B4-BE49-F238E27FC236}">
-                <a16:creationId xmlns:a16="http://schemas.microsoft.com/office/drawing/2014/main" id="{457D9D73-1B2C-4AAF-9B7A-DD94330A648C}"/>
-              </a:ext>
-            </a:extLst>
-          </p:cNvPr>
-          <p:cNvSpPr>
-            <a:spLocks noGrp="1"/>
-          </p:cNvSpPr>
-          <p:nvPr>
-            <p:ph type="pic" sz="quarter" idx="14"/>
-          </p:nvPr>
-        </p:nvSpPr>
-        <p:spPr>
-          <a:xfrm>
-            <a:off x="1" y="0"/>
-            <a:ext cx="12192000" cy="6165850"/>
-          </a:xfrm>
-          <a:solidFill>
-            <a:schemeClr val="accent1">
-              <a:lumMod val="20000"/>
-              <a:lumOff val="80000"/>
-            </a:schemeClr>
-          </a:solidFill>
-        </p:spPr>
-        <p:txBody>
-          <a:bodyPr/>
-          <a:lstStyle>
-            <a:lvl1pPr marL="0" indent="0" algn="ctr">
-              <a:buNone/>
-              <a:defRPr/>
-            </a:lvl1pPr>
-          </a:lstStyle>
-          <a:p>
-            <a:r>
-              <a:rPr lang="de-DE"/>
-              <a:t>Bild durch Klicken auf Symbol hinzufügen</a:t>
-            </a:r>
-            <a:endParaRPr lang="en-US"/>
-          </a:p>
-        </p:txBody>
-      </p:sp>
-      <p:pic>
-        <p:nvPicPr>
-          <p:cNvPr id="8" name="Picture 8">
-            <a:extLst>
-              <a:ext uri="{FF2B5EF4-FFF2-40B4-BE49-F238E27FC236}">
-                <a16:creationId xmlns:a16="http://schemas.microsoft.com/office/drawing/2014/main" id="{850193D8-B2DA-4A98-B3E7-486BC2DA978F}"/>
-              </a:ext>
-            </a:extLst>
-          </p:cNvPr>
-          <p:cNvPicPr>
-            <a:picLocks noChangeAspect="1"/>
-          </p:cNvPicPr>
-          <p:nvPr userDrawn="1"/>
-        </p:nvPicPr>
-        <p:blipFill>
-          <a:blip r:embed="rId2" cstate="print">
-            <a:extLst>
-              <a:ext uri="{28A0092B-C50C-407E-A947-70E740481C1C}">
-                <a14:useLocalDpi xmlns:a14="http://schemas.microsoft.com/office/drawing/2010/main" val="0"/>
-              </a:ext>
-            </a:extLst>
-          </a:blip>
-          <a:stretch>
-            <a:fillRect/>
-          </a:stretch>
-        </p:blipFill>
-        <p:spPr>
-          <a:xfrm>
-            <a:off x="10931128" y="6407803"/>
-            <a:ext cx="721398" cy="181020"/>
-          </a:xfrm>
-          <a:prstGeom prst="rect">
-            <a:avLst/>
-          </a:prstGeom>
-        </p:spPr>
-      </p:pic>
-    </p:spTree>
-    <p:extLst>
-      <p:ext uri="{BB962C8B-B14F-4D97-AF65-F5344CB8AC3E}">
-        <p14:creationId xmlns:p14="http://schemas.microsoft.com/office/powerpoint/2010/main" val="364619789"/>
-      </p:ext>
-    </p:extLst>
-  </p:cSld>
-  <p:clrMapOvr>
-    <a:masterClrMapping/>
-  </p:clrMapOvr>
-</p:sldLayout>
-</file>
-
-<file path=ppt/slideLayouts/slideLayout29.xml><?xml version="1.0" encoding="utf-8"?>
-<p:sldLayout xmlns:a="http://schemas.openxmlformats.org/drawingml/2006/main" xmlns:r="http://schemas.openxmlformats.org/officeDocument/2006/relationships" xmlns:p="http://schemas.openxmlformats.org/presentationml/2006/main" preserve="1" userDrawn="1">
-  <p:cSld name="Bild rechteckig schwarzer HG">
-    <p:bg>
-      <p:bgPr>
-        <a:solidFill>
-          <a:schemeClr val="tx1"/>
-        </a:solidFill>
-        <a:effectLst/>
-      </p:bgPr>
-    </p:bg>
-    <p:spTree>
-      <p:nvGrpSpPr>
-        <p:cNvPr id="1" name=""/>
-        <p:cNvGrpSpPr/>
-        <p:nvPr/>
-      </p:nvGrpSpPr>
-      <p:grpSpPr>
-        <a:xfrm>
-          <a:off x="0" y="0"/>
-          <a:ext cx="0" cy="0"/>
-          <a:chOff x="0" y="0"/>
-          <a:chExt cx="0" cy="0"/>
-        </a:xfrm>
-      </p:grpSpPr>
-      <p:sp>
-        <p:nvSpPr>
-          <p:cNvPr id="12" name="Picture Placeholder 11">
-            <a:extLst>
-              <a:ext uri="{FF2B5EF4-FFF2-40B4-BE49-F238E27FC236}">
-                <a16:creationId xmlns:a16="http://schemas.microsoft.com/office/drawing/2014/main" id="{457D9D73-1B2C-4AAF-9B7A-DD94330A648C}"/>
-              </a:ext>
-            </a:extLst>
-          </p:cNvPr>
-          <p:cNvSpPr>
-            <a:spLocks noGrp="1"/>
-          </p:cNvSpPr>
-          <p:nvPr>
-            <p:ph type="pic" sz="quarter" idx="14"/>
-          </p:nvPr>
-        </p:nvSpPr>
-        <p:spPr>
-          <a:xfrm>
-            <a:off x="1" y="0"/>
-            <a:ext cx="12192000" cy="6165850"/>
-          </a:xfrm>
-          <a:solidFill>
-            <a:schemeClr val="accent1">
-              <a:lumMod val="20000"/>
-              <a:lumOff val="80000"/>
-            </a:schemeClr>
-          </a:solidFill>
-        </p:spPr>
-        <p:txBody>
-          <a:bodyPr/>
-          <a:lstStyle>
-            <a:lvl1pPr marL="0" indent="0" algn="ctr">
-              <a:buNone/>
-              <a:defRPr/>
-            </a:lvl1pPr>
-          </a:lstStyle>
-          <a:p>
-            <a:r>
-              <a:rPr lang="de-DE"/>
-              <a:t>Bild durch Klicken auf Symbol hinzufügen</a:t>
-            </a:r>
-            <a:endParaRPr lang="en-US"/>
-          </a:p>
-        </p:txBody>
-      </p:sp>
-    </p:spTree>
-    <p:extLst>
-      <p:ext uri="{BB962C8B-B14F-4D97-AF65-F5344CB8AC3E}">
-        <p14:creationId xmlns:p14="http://schemas.microsoft.com/office/powerpoint/2010/main" val="2859866936"/>
-      </p:ext>
-    </p:extLst>
-  </p:cSld>
-  <p:clrMapOvr>
-    <a:masterClrMapping/>
-  </p:clrMapOvr>
-</p:sldLayout>
-</file>
-
 <file path=ppt/slideLayouts/slideLayout3.xml><?xml version="1.0" encoding="utf-8"?>
 <p:sldLayout xmlns:a="http://schemas.openxmlformats.org/drawingml/2006/main" xmlns:r="http://schemas.openxmlformats.org/officeDocument/2006/relationships" xmlns:p="http://schemas.openxmlformats.org/presentationml/2006/main" preserve="1" userDrawn="1">
   <p:cSld name="ab_titleandtext">
@@ -13499,6 +14049,200 @@
 </file>
 
 <file path=ppt/slideLayouts/slideLayout30.xml><?xml version="1.0" encoding="utf-8"?>
+<p:sldLayout xmlns:a="http://schemas.openxmlformats.org/drawingml/2006/main" xmlns:r="http://schemas.openxmlformats.org/officeDocument/2006/relationships" xmlns:p="http://schemas.openxmlformats.org/presentationml/2006/main" preserve="1" userDrawn="1">
+  <p:cSld name="Bild grossflächig">
+    <p:spTree>
+      <p:nvGrpSpPr>
+        <p:cNvPr id="1" name=""/>
+        <p:cNvGrpSpPr/>
+        <p:nvPr/>
+      </p:nvGrpSpPr>
+      <p:grpSpPr>
+        <a:xfrm>
+          <a:off x="0" y="0"/>
+          <a:ext cx="0" cy="0"/>
+          <a:chOff x="0" y="0"/>
+          <a:chExt cx="0" cy="0"/>
+        </a:xfrm>
+      </p:grpSpPr>
+      <p:sp>
+        <p:nvSpPr>
+          <p:cNvPr id="12" name="Picture Placeholder 11">
+            <a:extLst>
+              <a:ext uri="{FF2B5EF4-FFF2-40B4-BE49-F238E27FC236}">
+                <a16:creationId xmlns:a16="http://schemas.microsoft.com/office/drawing/2014/main" id="{457D9D73-1B2C-4AAF-9B7A-DD94330A648C}"/>
+              </a:ext>
+            </a:extLst>
+          </p:cNvPr>
+          <p:cNvSpPr>
+            <a:spLocks noGrp="1"/>
+          </p:cNvSpPr>
+          <p:nvPr>
+            <p:ph type="pic" sz="quarter" idx="14"/>
+          </p:nvPr>
+        </p:nvSpPr>
+        <p:spPr>
+          <a:xfrm>
+            <a:off x="1" y="0"/>
+            <a:ext cx="12192000" cy="6165850"/>
+          </a:xfrm>
+          <a:solidFill>
+            <a:schemeClr val="accent1">
+              <a:lumMod val="20000"/>
+              <a:lumOff val="80000"/>
+            </a:schemeClr>
+          </a:solidFill>
+        </p:spPr>
+        <p:txBody>
+          <a:bodyPr/>
+          <a:lstStyle>
+            <a:lvl1pPr marL="0" indent="0" algn="ctr">
+              <a:buNone/>
+              <a:defRPr/>
+            </a:lvl1pPr>
+          </a:lstStyle>
+          <a:p>
+            <a:r>
+              <a:rPr lang="de-DE"/>
+              <a:t>Bild durch Klicken auf Symbol hinzufügen</a:t>
+            </a:r>
+            <a:endParaRPr lang="en-US"/>
+          </a:p>
+        </p:txBody>
+      </p:sp>
+      <p:pic>
+        <p:nvPicPr>
+          <p:cNvPr id="8" name="Picture 8">
+            <a:extLst>
+              <a:ext uri="{FF2B5EF4-FFF2-40B4-BE49-F238E27FC236}">
+                <a16:creationId xmlns:a16="http://schemas.microsoft.com/office/drawing/2014/main" id="{850193D8-B2DA-4A98-B3E7-486BC2DA978F}"/>
+              </a:ext>
+            </a:extLst>
+          </p:cNvPr>
+          <p:cNvPicPr>
+            <a:picLocks noChangeAspect="1"/>
+          </p:cNvPicPr>
+          <p:nvPr userDrawn="1"/>
+        </p:nvPicPr>
+        <p:blipFill>
+          <a:blip r:embed="rId2" cstate="print">
+            <a:extLst>
+              <a:ext uri="{28A0092B-C50C-407E-A947-70E740481C1C}">
+                <a14:useLocalDpi xmlns:a14="http://schemas.microsoft.com/office/drawing/2010/main" val="0"/>
+              </a:ext>
+            </a:extLst>
+          </a:blip>
+          <a:stretch>
+            <a:fillRect/>
+          </a:stretch>
+        </p:blipFill>
+        <p:spPr>
+          <a:xfrm>
+            <a:off x="10931128" y="6407803"/>
+            <a:ext cx="721398" cy="181020"/>
+          </a:xfrm>
+          <a:prstGeom prst="rect">
+            <a:avLst/>
+          </a:prstGeom>
+        </p:spPr>
+      </p:pic>
+    </p:spTree>
+    <p:extLst>
+      <p:ext uri="{BB962C8B-B14F-4D97-AF65-F5344CB8AC3E}">
+        <p14:creationId xmlns:p14="http://schemas.microsoft.com/office/powerpoint/2010/main" val="364619789"/>
+      </p:ext>
+    </p:extLst>
+  </p:cSld>
+  <p:clrMapOvr>
+    <a:masterClrMapping/>
+  </p:clrMapOvr>
+</p:sldLayout>
+</file>
+
+<file path=ppt/slideLayouts/slideLayout31.xml><?xml version="1.0" encoding="utf-8"?>
+<p:sldLayout xmlns:a="http://schemas.openxmlformats.org/drawingml/2006/main" xmlns:r="http://schemas.openxmlformats.org/officeDocument/2006/relationships" xmlns:p="http://schemas.openxmlformats.org/presentationml/2006/main" preserve="1" userDrawn="1">
+  <p:cSld name="Bild rechteckig schwarzer HG">
+    <p:bg>
+      <p:bgPr>
+        <a:solidFill>
+          <a:schemeClr val="tx1"/>
+        </a:solidFill>
+        <a:effectLst/>
+      </p:bgPr>
+    </p:bg>
+    <p:spTree>
+      <p:nvGrpSpPr>
+        <p:cNvPr id="1" name=""/>
+        <p:cNvGrpSpPr/>
+        <p:nvPr/>
+      </p:nvGrpSpPr>
+      <p:grpSpPr>
+        <a:xfrm>
+          <a:off x="0" y="0"/>
+          <a:ext cx="0" cy="0"/>
+          <a:chOff x="0" y="0"/>
+          <a:chExt cx="0" cy="0"/>
+        </a:xfrm>
+      </p:grpSpPr>
+      <p:sp>
+        <p:nvSpPr>
+          <p:cNvPr id="12" name="Picture Placeholder 11">
+            <a:extLst>
+              <a:ext uri="{FF2B5EF4-FFF2-40B4-BE49-F238E27FC236}">
+                <a16:creationId xmlns:a16="http://schemas.microsoft.com/office/drawing/2014/main" id="{457D9D73-1B2C-4AAF-9B7A-DD94330A648C}"/>
+              </a:ext>
+            </a:extLst>
+          </p:cNvPr>
+          <p:cNvSpPr>
+            <a:spLocks noGrp="1"/>
+          </p:cNvSpPr>
+          <p:nvPr>
+            <p:ph type="pic" sz="quarter" idx="14"/>
+          </p:nvPr>
+        </p:nvSpPr>
+        <p:spPr>
+          <a:xfrm>
+            <a:off x="1" y="0"/>
+            <a:ext cx="12192000" cy="6165850"/>
+          </a:xfrm>
+          <a:solidFill>
+            <a:schemeClr val="accent1">
+              <a:lumMod val="20000"/>
+              <a:lumOff val="80000"/>
+            </a:schemeClr>
+          </a:solidFill>
+        </p:spPr>
+        <p:txBody>
+          <a:bodyPr/>
+          <a:lstStyle>
+            <a:lvl1pPr marL="0" indent="0" algn="ctr">
+              <a:buNone/>
+              <a:defRPr/>
+            </a:lvl1pPr>
+          </a:lstStyle>
+          <a:p>
+            <a:r>
+              <a:rPr lang="de-DE"/>
+              <a:t>Bild durch Klicken auf Symbol hinzufügen</a:t>
+            </a:r>
+            <a:endParaRPr lang="en-US"/>
+          </a:p>
+        </p:txBody>
+      </p:sp>
+    </p:spTree>
+    <p:extLst>
+      <p:ext uri="{BB962C8B-B14F-4D97-AF65-F5344CB8AC3E}">
+        <p14:creationId xmlns:p14="http://schemas.microsoft.com/office/powerpoint/2010/main" val="2859866936"/>
+      </p:ext>
+    </p:extLst>
+  </p:cSld>
+  <p:clrMapOvr>
+    <a:masterClrMapping/>
+  </p:clrMapOvr>
+</p:sldLayout>
+</file>
+
+<file path=ppt/slideLayouts/slideLayout32.xml><?xml version="1.0" encoding="utf-8"?>
 <p:sldLayout xmlns:a="http://schemas.openxmlformats.org/drawingml/2006/main" xmlns:r="http://schemas.openxmlformats.org/officeDocument/2006/relationships" xmlns:p="http://schemas.openxmlformats.org/presentationml/2006/main" showMasterSp="0" preserve="1" userDrawn="1">
   <p:cSld name="Bild quadratisch schwarzer HG">
     <p:bg>
@@ -13617,7 +14361,7 @@
 </p:sldLayout>
 </file>
 
-<file path=ppt/slideLayouts/slideLayout31.xml><?xml version="1.0" encoding="utf-8"?>
+<file path=ppt/slideLayouts/slideLayout33.xml><?xml version="1.0" encoding="utf-8"?>
 <p:sldLayout xmlns:a="http://schemas.openxmlformats.org/drawingml/2006/main" xmlns:r="http://schemas.openxmlformats.org/officeDocument/2006/relationships" xmlns:p="http://schemas.openxmlformats.org/presentationml/2006/main" preserve="1" userDrawn="1">
   <p:cSld name="Titel und Video">
     <p:spTree>
@@ -13761,7 +14505,7 @@
 </p:sldLayout>
 </file>
 
-<file path=ppt/slideLayouts/slideLayout32.xml><?xml version="1.0" encoding="utf-8"?>
+<file path=ppt/slideLayouts/slideLayout34.xml><?xml version="1.0" encoding="utf-8"?>
 <p:sldLayout xmlns:a="http://schemas.openxmlformats.org/drawingml/2006/main" xmlns:r="http://schemas.openxmlformats.org/officeDocument/2006/relationships" xmlns:p="http://schemas.openxmlformats.org/presentationml/2006/main" showMasterSp="0" preserve="1" userDrawn="1">
   <p:cSld name="Video grossflächig">
     <p:spTree>
@@ -13836,7 +14580,7 @@
 </p:sldLayout>
 </file>
 
-<file path=ppt/slideLayouts/slideLayout33.xml><?xml version="1.0" encoding="utf-8"?>
+<file path=ppt/slideLayouts/slideLayout35.xml><?xml version="1.0" encoding="utf-8"?>
 <p:sldLayout xmlns:a="http://schemas.openxmlformats.org/drawingml/2006/main" xmlns:r="http://schemas.openxmlformats.org/officeDocument/2006/relationships" xmlns:p="http://schemas.openxmlformats.org/presentationml/2006/main" showMasterSp="0" preserve="1" userDrawn="1">
   <p:cSld name="Zitat (blau)">
     <p:bg>
@@ -14027,7 +14771,7 @@
 </p:sldLayout>
 </file>
 
-<file path=ppt/slideLayouts/slideLayout34.xml><?xml version="1.0" encoding="utf-8"?>
+<file path=ppt/slideLayouts/slideLayout36.xml><?xml version="1.0" encoding="utf-8"?>
 <p:sldLayout xmlns:a="http://schemas.openxmlformats.org/drawingml/2006/main" xmlns:r="http://schemas.openxmlformats.org/officeDocument/2006/relationships" xmlns:p="http://schemas.openxmlformats.org/presentationml/2006/main" preserve="1" userDrawn="1">
   <p:cSld name="Schlussfolie">
     <p:spTree>
@@ -14219,7 +14963,7 @@
 </p:sldLayout>
 </file>
 
-<file path=ppt/slideLayouts/slideLayout35.xml><?xml version="1.0" encoding="utf-8"?>
+<file path=ppt/slideLayouts/slideLayout37.xml><?xml version="1.0" encoding="utf-8"?>
 <p:sldLayout xmlns:a="http://schemas.openxmlformats.org/drawingml/2006/main" xmlns:r="http://schemas.openxmlformats.org/officeDocument/2006/relationships" xmlns:p="http://schemas.openxmlformats.org/presentationml/2006/main" showMasterSp="0" preserve="1" userDrawn="1">
   <p:cSld name="Schlussfolie (co-Branding)">
     <p:spTree>
@@ -14460,7 +15204,7 @@
 </p:sldLayout>
 </file>
 
-<file path=ppt/slideLayouts/slideLayout36.xml><?xml version="1.0" encoding="utf-8"?>
+<file path=ppt/slideLayouts/slideLayout38.xml><?xml version="1.0" encoding="utf-8"?>
 <p:sldLayout xmlns:a="http://schemas.openxmlformats.org/drawingml/2006/main" xmlns:r="http://schemas.openxmlformats.org/officeDocument/2006/relationships" xmlns:p="http://schemas.openxmlformats.org/presentationml/2006/main" preserve="1" userDrawn="1">
   <p:cSld name="4 Bilder Folie">
     <p:spTree>
@@ -14647,7 +15391,7 @@
 </p:sldLayout>
 </file>
 
-<file path=ppt/slideLayouts/slideLayout37.xml><?xml version="1.0" encoding="utf-8"?>
+<file path=ppt/slideLayouts/slideLayout39.xml><?xml version="1.0" encoding="utf-8"?>
 <p:sldLayout xmlns:a="http://schemas.openxmlformats.org/drawingml/2006/main" xmlns:r="http://schemas.openxmlformats.org/officeDocument/2006/relationships" xmlns:p="http://schemas.openxmlformats.org/presentationml/2006/main" preserve="1" userDrawn="1">
   <p:cSld name="6 Bilder Folie">
     <p:spTree>
@@ -14894,7 +15638,92 @@
 </p:sldLayout>
 </file>
 
-<file path=ppt/slideLayouts/slideLayout38.xml><?xml version="1.0" encoding="utf-8"?>
+<file path=ppt/slideLayouts/slideLayout4.xml><?xml version="1.0" encoding="utf-8"?>
+<p:sldLayout xmlns:a="http://schemas.openxmlformats.org/drawingml/2006/main" xmlns:r="http://schemas.openxmlformats.org/officeDocument/2006/relationships" xmlns:p="http://schemas.openxmlformats.org/presentationml/2006/main" preserve="1" userDrawn="1">
+  <p:cSld name="ab_titleandpicture">
+    <p:spTree>
+      <p:nvGrpSpPr>
+        <p:cNvPr id="1" name=""/>
+        <p:cNvGrpSpPr/>
+        <p:nvPr/>
+      </p:nvGrpSpPr>
+      <p:grpSpPr>
+        <a:xfrm>
+          <a:off x="0" y="0"/>
+          <a:ext cx="0" cy="0"/>
+          <a:chOff x="0" y="0"/>
+          <a:chExt cx="0" cy="0"/>
+        </a:xfrm>
+      </p:grpSpPr>
+      <p:sp>
+        <p:nvSpPr>
+          <p:cNvPr id="2" name="Title 1">
+            <a:extLst>
+              <a:ext uri="{FF2B5EF4-FFF2-40B4-BE49-F238E27FC236}">
+                <a16:creationId xmlns:a16="http://schemas.microsoft.com/office/drawing/2014/main" id="{DF030912-C259-45CB-9810-1C7B1566778B}"/>
+              </a:ext>
+            </a:extLst>
+          </p:cNvPr>
+          <p:cNvSpPr>
+            <a:spLocks noGrp="1"/>
+          </p:cNvSpPr>
+          <p:nvPr>
+            <p:ph type="title"/>
+          </p:nvPr>
+        </p:nvSpPr>
+        <p:spPr/>
+        <p:txBody>
+          <a:bodyPr/>
+          <a:lstStyle/>
+          <a:p>
+            <a:r>
+              <a:rPr lang="de-DE"/>
+              <a:t>Titelmasterformat durch Klicken bearbeiten</a:t>
+            </a:r>
+            <a:endParaRPr lang="de-CH"/>
+          </a:p>
+        </p:txBody>
+      </p:sp>
+      <p:sp>
+        <p:nvSpPr>
+          <p:cNvPr id="8" name="Bildplatzhalter 7"/>
+          <p:cNvSpPr>
+            <a:spLocks noGrp="1"/>
+          </p:cNvSpPr>
+          <p:nvPr>
+            <p:ph type="pic" sz="quarter" idx="13"/>
+          </p:nvPr>
+        </p:nvSpPr>
+        <p:spPr>
+          <a:solidFill>
+            <a:schemeClr val="accent1">
+              <a:lumMod val="20000"/>
+              <a:lumOff val="80000"/>
+            </a:schemeClr>
+          </a:solidFill>
+        </p:spPr>
+        <p:txBody>
+          <a:bodyPr/>
+          <a:lstStyle/>
+          <a:p>
+            <a:endParaRPr lang="de-CH"/>
+          </a:p>
+        </p:txBody>
+      </p:sp>
+    </p:spTree>
+    <p:extLst>
+      <p:ext uri="{BB962C8B-B14F-4D97-AF65-F5344CB8AC3E}">
+        <p14:creationId xmlns:p14="http://schemas.microsoft.com/office/powerpoint/2010/main" val="2446208346"/>
+      </p:ext>
+    </p:extLst>
+  </p:cSld>
+  <p:clrMapOvr>
+    <a:masterClrMapping/>
+  </p:clrMapOvr>
+</p:sldLayout>
+</file>
+
+<file path=ppt/slideLayouts/slideLayout40.xml><?xml version="1.0" encoding="utf-8"?>
 <p:sldLayout xmlns:a="http://schemas.openxmlformats.org/drawingml/2006/main" xmlns:r="http://schemas.openxmlformats.org/officeDocument/2006/relationships" xmlns:p="http://schemas.openxmlformats.org/presentationml/2006/main" preserve="1" userDrawn="1">
   <p:cSld name="8 Bilder Folie">
     <p:spTree>
@@ -15193,7 +16022,7 @@
 </p:sldLayout>
 </file>
 
-<file path=ppt/slideLayouts/slideLayout39.xml><?xml version="1.0" encoding="utf-8"?>
+<file path=ppt/slideLayouts/slideLayout41.xml><?xml version="1.0" encoding="utf-8"?>
 <p:sldLayout xmlns:a="http://schemas.openxmlformats.org/drawingml/2006/main" xmlns:r="http://schemas.openxmlformats.org/officeDocument/2006/relationships" xmlns:p="http://schemas.openxmlformats.org/presentationml/2006/main" preserve="1" userDrawn="1">
   <p:cSld name="Original KKD 7">
     <p:spTree>
@@ -15696,92 +16525,7 @@
 </p:sldLayout>
 </file>
 
-<file path=ppt/slideLayouts/slideLayout4.xml><?xml version="1.0" encoding="utf-8"?>
-<p:sldLayout xmlns:a="http://schemas.openxmlformats.org/drawingml/2006/main" xmlns:r="http://schemas.openxmlformats.org/officeDocument/2006/relationships" xmlns:p="http://schemas.openxmlformats.org/presentationml/2006/main" preserve="1" userDrawn="1">
-  <p:cSld name="ab_titleandpicture">
-    <p:spTree>
-      <p:nvGrpSpPr>
-        <p:cNvPr id="1" name=""/>
-        <p:cNvGrpSpPr/>
-        <p:nvPr/>
-      </p:nvGrpSpPr>
-      <p:grpSpPr>
-        <a:xfrm>
-          <a:off x="0" y="0"/>
-          <a:ext cx="0" cy="0"/>
-          <a:chOff x="0" y="0"/>
-          <a:chExt cx="0" cy="0"/>
-        </a:xfrm>
-      </p:grpSpPr>
-      <p:sp>
-        <p:nvSpPr>
-          <p:cNvPr id="2" name="Title 1">
-            <a:extLst>
-              <a:ext uri="{FF2B5EF4-FFF2-40B4-BE49-F238E27FC236}">
-                <a16:creationId xmlns:a16="http://schemas.microsoft.com/office/drawing/2014/main" id="{DF030912-C259-45CB-9810-1C7B1566778B}"/>
-              </a:ext>
-            </a:extLst>
-          </p:cNvPr>
-          <p:cNvSpPr>
-            <a:spLocks noGrp="1"/>
-          </p:cNvSpPr>
-          <p:nvPr>
-            <p:ph type="title"/>
-          </p:nvPr>
-        </p:nvSpPr>
-        <p:spPr/>
-        <p:txBody>
-          <a:bodyPr/>
-          <a:lstStyle/>
-          <a:p>
-            <a:r>
-              <a:rPr lang="de-DE"/>
-              <a:t>Titelmasterformat durch Klicken bearbeiten</a:t>
-            </a:r>
-            <a:endParaRPr lang="de-CH"/>
-          </a:p>
-        </p:txBody>
-      </p:sp>
-      <p:sp>
-        <p:nvSpPr>
-          <p:cNvPr id="8" name="Bildplatzhalter 7"/>
-          <p:cNvSpPr>
-            <a:spLocks noGrp="1"/>
-          </p:cNvSpPr>
-          <p:nvPr>
-            <p:ph type="pic" sz="quarter" idx="13"/>
-          </p:nvPr>
-        </p:nvSpPr>
-        <p:spPr>
-          <a:solidFill>
-            <a:schemeClr val="accent1">
-              <a:lumMod val="20000"/>
-              <a:lumOff val="80000"/>
-            </a:schemeClr>
-          </a:solidFill>
-        </p:spPr>
-        <p:txBody>
-          <a:bodyPr/>
-          <a:lstStyle/>
-          <a:p>
-            <a:endParaRPr lang="de-CH"/>
-          </a:p>
-        </p:txBody>
-      </p:sp>
-    </p:spTree>
-    <p:extLst>
-      <p:ext uri="{BB962C8B-B14F-4D97-AF65-F5344CB8AC3E}">
-        <p14:creationId xmlns:p14="http://schemas.microsoft.com/office/powerpoint/2010/main" val="2446208346"/>
-      </p:ext>
-    </p:extLst>
-  </p:cSld>
-  <p:clrMapOvr>
-    <a:masterClrMapping/>
-  </p:clrMapOvr>
-</p:sldLayout>
-</file>
-
-<file path=ppt/slideLayouts/slideLayout40.xml><?xml version="1.0" encoding="utf-8"?>
+<file path=ppt/slideLayouts/slideLayout42.xml><?xml version="1.0" encoding="utf-8"?>
 <p:sldLayout xmlns:a="http://schemas.openxmlformats.org/drawingml/2006/main" xmlns:r="http://schemas.openxmlformats.org/officeDocument/2006/relationships" xmlns:p="http://schemas.openxmlformats.org/presentationml/2006/main" preserve="1" userDrawn="1">
   <p:cSld name="Original KKD 8">
     <p:spTree>
@@ -16569,7 +17313,7 @@
 </p:sldLayout>
 </file>
 
-<file path=ppt/slideLayouts/slideLayout41.xml><?xml version="1.0" encoding="utf-8"?>
+<file path=ppt/slideLayouts/slideLayout43.xml><?xml version="1.0" encoding="utf-8"?>
 <p:sldLayout xmlns:a="http://schemas.openxmlformats.org/drawingml/2006/main" xmlns:r="http://schemas.openxmlformats.org/officeDocument/2006/relationships" xmlns:p="http://schemas.openxmlformats.org/presentationml/2006/main" preserve="1" userDrawn="1">
   <p:cSld name="Original KKD 9">
     <p:spTree>
@@ -17119,7 +17863,7 @@
 </p:sldLayout>
 </file>
 
-<file path=ppt/slideLayouts/slideLayout42.xml><?xml version="1.0" encoding="utf-8"?>
+<file path=ppt/slideLayouts/slideLayout44.xml><?xml version="1.0" encoding="utf-8"?>
 <p:sldLayout xmlns:a="http://schemas.openxmlformats.org/drawingml/2006/main" xmlns:r="http://schemas.openxmlformats.org/officeDocument/2006/relationships" xmlns:p="http://schemas.openxmlformats.org/presentationml/2006/main" preserve="1" userDrawn="1">
   <p:cSld name="Original KKD 10">
     <p:spTree>
@@ -17890,7 +18634,7 @@
 </p:sldLayout>
 </file>
 
-<file path=ppt/slideLayouts/slideLayout43.xml><?xml version="1.0" encoding="utf-8"?>
+<file path=ppt/slideLayouts/slideLayout45.xml><?xml version="1.0" encoding="utf-8"?>
 <p:sldLayout xmlns:a="http://schemas.openxmlformats.org/drawingml/2006/main" xmlns:r="http://schemas.openxmlformats.org/officeDocument/2006/relationships" xmlns:p="http://schemas.openxmlformats.org/presentationml/2006/main" preserve="1" userDrawn="1">
   <p:cSld name="Vorstellungsrunde PM">
     <p:spTree>
@@ -18172,7 +18916,7 @@
 </p:sldLayout>
 </file>
 
-<file path=ppt/slideLayouts/slideLayout44.xml><?xml version="1.0" encoding="utf-8"?>
+<file path=ppt/slideLayouts/slideLayout46.xml><?xml version="1.0" encoding="utf-8"?>
 <p:sldLayout xmlns:a="http://schemas.openxmlformats.org/drawingml/2006/main" xmlns:r="http://schemas.openxmlformats.org/officeDocument/2006/relationships" xmlns:p="http://schemas.openxmlformats.org/presentationml/2006/main" preserve="1" userDrawn="1">
   <p:cSld name="ab_unterlassen_f">
     <p:spTree>
@@ -18617,7 +19361,7 @@
 </p:sldLayout>
 </file>
 
-<file path=ppt/slideLayouts/slideLayout45.xml><?xml version="1.0" encoding="utf-8"?>
+<file path=ppt/slideLayouts/slideLayout47.xml><?xml version="1.0" encoding="utf-8"?>
 <p:sldLayout xmlns:a="http://schemas.openxmlformats.org/drawingml/2006/main" xmlns:r="http://schemas.openxmlformats.org/officeDocument/2006/relationships" xmlns:p="http://schemas.openxmlformats.org/presentationml/2006/main" preserve="1" userDrawn="1">
   <p:cSld name="ab_unterlassen_i">
     <p:spTree>
@@ -19062,7 +19806,7 @@
 </p:sldLayout>
 </file>
 
-<file path=ppt/slideLayouts/slideLayout46.xml><?xml version="1.0" encoding="utf-8"?>
+<file path=ppt/slideLayouts/slideLayout48.xml><?xml version="1.0" encoding="utf-8"?>
 <p:sldLayout xmlns:a="http://schemas.openxmlformats.org/drawingml/2006/main" xmlns:r="http://schemas.openxmlformats.org/officeDocument/2006/relationships" xmlns:p="http://schemas.openxmlformats.org/presentationml/2006/main" preserve="1" userDrawn="1">
   <p:cSld name="ab_dulden_f">
     <p:spTree>
@@ -19669,7 +20413,7 @@
 </p:sldLayout>
 </file>
 
-<file path=ppt/slideLayouts/slideLayout47.xml><?xml version="1.0" encoding="utf-8"?>
+<file path=ppt/slideLayouts/slideLayout49.xml><?xml version="1.0" encoding="utf-8"?>
 <p:sldLayout xmlns:a="http://schemas.openxmlformats.org/drawingml/2006/main" xmlns:r="http://schemas.openxmlformats.org/officeDocument/2006/relationships" xmlns:p="http://schemas.openxmlformats.org/presentationml/2006/main" preserve="1" userDrawn="1">
   <p:cSld name="ab_dulden_i">
     <p:spTree>
@@ -20276,7 +21020,173 @@
 </p:sldLayout>
 </file>
 
-<file path=ppt/slideLayouts/slideLayout48.xml><?xml version="1.0" encoding="utf-8"?>
+<file path=ppt/slideLayouts/slideLayout5.xml><?xml version="1.0" encoding="utf-8"?>
+<p:sldLayout xmlns:a="http://schemas.openxmlformats.org/drawingml/2006/main" xmlns:r="http://schemas.openxmlformats.org/officeDocument/2006/relationships" xmlns:p="http://schemas.openxmlformats.org/presentationml/2006/main" preserve="1" userDrawn="1">
+  <p:cSld name="ab_textandpicture">
+    <p:spTree>
+      <p:nvGrpSpPr>
+        <p:cNvPr id="1" name=""/>
+        <p:cNvGrpSpPr/>
+        <p:nvPr/>
+      </p:nvGrpSpPr>
+      <p:grpSpPr>
+        <a:xfrm>
+          <a:off x="0" y="0"/>
+          <a:ext cx="0" cy="0"/>
+          <a:chOff x="0" y="0"/>
+          <a:chExt cx="0" cy="0"/>
+        </a:xfrm>
+      </p:grpSpPr>
+      <p:sp>
+        <p:nvSpPr>
+          <p:cNvPr id="11" name="Bildplatzhalter 10"/>
+          <p:cNvSpPr>
+            <a:spLocks noGrp="1"/>
+          </p:cNvSpPr>
+          <p:nvPr>
+            <p:ph type="pic" sz="quarter" idx="13"/>
+          </p:nvPr>
+        </p:nvSpPr>
+        <p:spPr>
+          <a:xfrm>
+            <a:off x="6383338" y="1557338"/>
+            <a:ext cx="5256000" cy="4608512"/>
+          </a:xfrm>
+        </p:spPr>
+        <p:txBody>
+          <a:bodyPr/>
+          <a:lstStyle/>
+          <a:p>
+            <a:endParaRPr lang="de-CH"/>
+          </a:p>
+        </p:txBody>
+      </p:sp>
+      <p:sp>
+        <p:nvSpPr>
+          <p:cNvPr id="2" name="Title 1">
+            <a:extLst>
+              <a:ext uri="{FF2B5EF4-FFF2-40B4-BE49-F238E27FC236}">
+                <a16:creationId xmlns:a16="http://schemas.microsoft.com/office/drawing/2014/main" id="{0DD17F60-50C9-498E-870C-52D42C0B20AA}"/>
+              </a:ext>
+            </a:extLst>
+          </p:cNvPr>
+          <p:cNvSpPr>
+            <a:spLocks noGrp="1"/>
+          </p:cNvSpPr>
+          <p:nvPr>
+            <p:ph type="title"/>
+          </p:nvPr>
+        </p:nvSpPr>
+        <p:spPr/>
+        <p:txBody>
+          <a:bodyPr/>
+          <a:lstStyle>
+            <a:lvl1pPr>
+              <a:defRPr>
+                <a:solidFill>
+                  <a:schemeClr val="accent2"/>
+                </a:solidFill>
+              </a:defRPr>
+            </a:lvl1pPr>
+          </a:lstStyle>
+          <a:p>
+            <a:r>
+              <a:rPr lang="de-DE"/>
+              <a:t>Titelmasterformat durch Klicken bearbeiten</a:t>
+            </a:r>
+            <a:endParaRPr lang="de-CH"/>
+          </a:p>
+        </p:txBody>
+      </p:sp>
+      <p:sp>
+        <p:nvSpPr>
+          <p:cNvPr id="3" name="Content Placeholder 2">
+            <a:extLst>
+              <a:ext uri="{FF2B5EF4-FFF2-40B4-BE49-F238E27FC236}">
+                <a16:creationId xmlns:a16="http://schemas.microsoft.com/office/drawing/2014/main" id="{D3387FA7-E97F-4398-A657-A2CFEB322B08}"/>
+              </a:ext>
+            </a:extLst>
+          </p:cNvPr>
+          <p:cNvSpPr>
+            <a:spLocks noGrp="1"/>
+          </p:cNvSpPr>
+          <p:nvPr>
+            <p:ph sz="half" idx="1"/>
+          </p:nvPr>
+        </p:nvSpPr>
+        <p:spPr>
+          <a:xfrm>
+            <a:off x="550863" y="1557339"/>
+            <a:ext cx="5256000" cy="4608512"/>
+          </a:xfrm>
+        </p:spPr>
+        <p:txBody>
+          <a:bodyPr/>
+          <a:lstStyle>
+            <a:lvl1pPr marL="0" indent="0">
+              <a:buNone/>
+              <a:defRPr/>
+            </a:lvl1pPr>
+          </a:lstStyle>
+          <a:p>
+            <a:pPr lvl="0"/>
+            <a:r>
+              <a:rPr lang="de-DE"/>
+              <a:t>Textmasterformat bearbeiten</a:t>
+            </a:r>
+          </a:p>
+        </p:txBody>
+      </p:sp>
+      <p:pic>
+        <p:nvPicPr>
+          <p:cNvPr id="8" name="Picture 8">
+            <a:extLst>
+              <a:ext uri="{FF2B5EF4-FFF2-40B4-BE49-F238E27FC236}">
+                <a16:creationId xmlns:a16="http://schemas.microsoft.com/office/drawing/2014/main" id="{3CA5065B-B47F-4EFF-A8DB-739B22B705E3}"/>
+              </a:ext>
+            </a:extLst>
+          </p:cNvPr>
+          <p:cNvPicPr>
+            <a:picLocks noChangeAspect="1"/>
+          </p:cNvPicPr>
+          <p:nvPr userDrawn="1"/>
+        </p:nvPicPr>
+        <p:blipFill>
+          <a:blip r:embed="rId2" cstate="print">
+            <a:extLst>
+              <a:ext uri="{28A0092B-C50C-407E-A947-70E740481C1C}">
+                <a14:useLocalDpi xmlns:a14="http://schemas.microsoft.com/office/drawing/2010/main" val="0"/>
+              </a:ext>
+            </a:extLst>
+          </a:blip>
+          <a:stretch>
+            <a:fillRect/>
+          </a:stretch>
+        </p:blipFill>
+        <p:spPr>
+          <a:xfrm>
+            <a:off x="10931128" y="6407803"/>
+            <a:ext cx="721398" cy="181020"/>
+          </a:xfrm>
+          <a:prstGeom prst="rect">
+            <a:avLst/>
+          </a:prstGeom>
+        </p:spPr>
+      </p:pic>
+    </p:spTree>
+    <p:extLst>
+      <p:ext uri="{BB962C8B-B14F-4D97-AF65-F5344CB8AC3E}">
+        <p14:creationId xmlns:p14="http://schemas.microsoft.com/office/powerpoint/2010/main" val="3827209210"/>
+      </p:ext>
+    </p:extLst>
+  </p:cSld>
+  <p:clrMapOvr>
+    <a:masterClrMapping/>
+  </p:clrMapOvr>
+</p:sldLayout>
+</file>
+
+<file path=ppt/slideLayouts/slideLayout50.xml><?xml version="1.0" encoding="utf-8"?>
 <p:sldLayout xmlns:a="http://schemas.openxmlformats.org/drawingml/2006/main" xmlns:r="http://schemas.openxmlformats.org/officeDocument/2006/relationships" xmlns:p="http://schemas.openxmlformats.org/presentationml/2006/main" preserve="1" userDrawn="1">
   <p:cSld name="ab_handeln_f">
     <p:spTree>
@@ -20399,7 +21309,7 @@
 </p:sldLayout>
 </file>
 
-<file path=ppt/slideLayouts/slideLayout49.xml><?xml version="1.0" encoding="utf-8"?>
+<file path=ppt/slideLayouts/slideLayout51.xml><?xml version="1.0" encoding="utf-8"?>
 <p:sldLayout xmlns:a="http://schemas.openxmlformats.org/drawingml/2006/main" xmlns:r="http://schemas.openxmlformats.org/officeDocument/2006/relationships" xmlns:p="http://schemas.openxmlformats.org/presentationml/2006/main" preserve="1" userDrawn="1">
   <p:cSld name="ab_handeln_i">
     <p:spTree>
@@ -20522,173 +21432,7 @@
 </p:sldLayout>
 </file>
 
-<file path=ppt/slideLayouts/slideLayout5.xml><?xml version="1.0" encoding="utf-8"?>
-<p:sldLayout xmlns:a="http://schemas.openxmlformats.org/drawingml/2006/main" xmlns:ns2="http://schemas.microsoft.com/office/drawing/2014/main" xmlns:ns4="http://schemas.microsoft.com/office/drawing/2010/main" xmlns:ns5="http://schemas.microsoft.com/office/powerpoint/2010/main" xmlns:p="http://schemas.openxmlformats.org/presentationml/2006/main" xmlns:r="http://schemas.openxmlformats.org/officeDocument/2006/relationships" preserve="1" userDrawn="1">
-  <p:cSld name="ab_textandpicture">
-    <p:spTree>
-      <p:nvGrpSpPr>
-        <p:cNvPr id="1" name=""/>
-        <p:cNvGrpSpPr/>
-        <p:nvPr/>
-      </p:nvGrpSpPr>
-      <p:grpSpPr>
-        <a:xfrm>
-          <a:off x="0" y="0"/>
-          <a:ext cx="0" cy="0"/>
-          <a:chOff x="0" y="0"/>
-          <a:chExt cx="0" cy="0"/>
-        </a:xfrm>
-      </p:grpSpPr>
-      <p:sp>
-        <p:nvSpPr>
-          <p:cNvPr id="11" name="Bildplatzhalter 10"/>
-          <p:cNvSpPr>
-            <a:spLocks noGrp="1"/>
-          </p:cNvSpPr>
-          <p:nvPr>
-            <p:ph type="pic" sz="quarter" idx="13"/>
-          </p:nvPr>
-        </p:nvSpPr>
-        <p:spPr>
-          <a:xfrm>
-            <a:off x="6383338" y="1557338"/>
-            <a:ext cx="5256000" cy="4608512"/>
-          </a:xfrm>
-        </p:spPr>
-        <p:txBody>
-          <a:bodyPr/>
-          <a:lstStyle/>
-          <a:p>
-            <a:endParaRPr lang="de-CH"/>
-          </a:p>
-        </p:txBody>
-      </p:sp>
-      <p:sp>
-        <p:nvSpPr>
-          <p:cNvPr id="2" name="Title 1">
-            <a:extLst>
-              <a:ext uri="{FF2B5EF4-FFF2-40B4-BE49-F238E27FC236}">
-                <ns2:creationId id="{0DD17F60-50C9-498E-870C-52D42C0B20AA}"/>
-              </a:ext>
-            </a:extLst>
-          </p:cNvPr>
-          <p:cNvSpPr>
-            <a:spLocks noGrp="1"/>
-          </p:cNvSpPr>
-          <p:nvPr>
-            <p:ph type="title"/>
-          </p:nvPr>
-        </p:nvSpPr>
-        <p:spPr/>
-        <p:txBody>
-          <a:bodyPr/>
-          <a:lstStyle>
-            <a:lvl1pPr>
-              <a:defRPr>
-                <a:solidFill>
-                  <a:schemeClr val="accent2"/>
-                </a:solidFill>
-              </a:defRPr>
-            </a:lvl1pPr>
-          </a:lstStyle>
-          <a:p>
-            <a:r>
-              <a:rPr lang="de-DE"/>
-              <a:t>Titelmasterformat durch Klicken bearbeiten</a:t>
-            </a:r>
-            <a:endParaRPr lang="de-CH"/>
-          </a:p>
-        </p:txBody>
-      </p:sp>
-      <p:sp>
-        <p:nvSpPr>
-          <p:cNvPr id="3" name="Content Placeholder 2">
-            <a:extLst>
-              <a:ext uri="{FF2B5EF4-FFF2-40B4-BE49-F238E27FC236}">
-                <ns2:creationId id="{D3387FA7-E97F-4398-A657-A2CFEB322B08}"/>
-              </a:ext>
-            </a:extLst>
-          </p:cNvPr>
-          <p:cNvSpPr>
-            <a:spLocks noGrp="1"/>
-          </p:cNvSpPr>
-          <p:nvPr>
-            <p:ph sz="half" idx="1"/>
-          </p:nvPr>
-        </p:nvSpPr>
-        <p:spPr>
-          <a:xfrm>
-            <a:off x="550863" y="1557339"/>
-            <a:ext cx="5256000" cy="4608512"/>
-          </a:xfrm>
-        </p:spPr>
-        <p:txBody>
-          <a:bodyPr/>
-          <a:lstStyle>
-            <a:lvl1pPr marL="0" indent="0">
-              <a:buNone/>
-              <a:defRPr/>
-            </a:lvl1pPr>
-          </a:lstStyle>
-          <a:p>
-            <a:pPr lvl="0"/>
-            <a:r>
-              <a:rPr lang="de-DE"/>
-              <a:t>Textmasterformat bearbeiten</a:t>
-            </a:r>
-          </a:p>
-        </p:txBody>
-      </p:sp>
-      <p:pic>
-        <p:nvPicPr>
-          <p:cNvPr id="8" name="Picture 8">
-            <a:extLst>
-              <a:ext uri="{FF2B5EF4-FFF2-40B4-BE49-F238E27FC236}">
-                <ns2:creationId id="{3CA5065B-B47F-4EFF-A8DB-739B22B705E3}"/>
-              </a:ext>
-            </a:extLst>
-          </p:cNvPr>
-          <p:cNvPicPr>
-            <a:picLocks noChangeAspect="1"/>
-          </p:cNvPicPr>
-          <p:nvPr userDrawn="1"/>
-        </p:nvPicPr>
-        <p:blipFill>
-          <a:blip r:embed="rId2" cstate="print">
-            <a:extLst>
-              <a:ext uri="{28A0092B-C50C-407E-A947-70E740481C1C}">
-                <ns4:useLocalDpi val="0"/>
-              </a:ext>
-            </a:extLst>
-          </a:blip>
-          <a:stretch>
-            <a:fillRect/>
-          </a:stretch>
-        </p:blipFill>
-        <p:spPr>
-          <a:xfrm>
-            <a:off x="10931128" y="6407803"/>
-            <a:ext cx="721398" cy="181020"/>
-          </a:xfrm>
-          <a:prstGeom prst="rect">
-            <a:avLst/>
-          </a:prstGeom>
-        </p:spPr>
-      </p:pic>
-    </p:spTree>
-    <p:extLst>
-      <p:ext uri="{BB962C8B-B14F-4D97-AF65-F5344CB8AC3E}">
-        <ns5:creationId val="3827209210"/>
-      </p:ext>
-    </p:extLst>
-  </p:cSld>
-  <p:clrMapOvr>
-    <a:masterClrMapping/>
-  </p:clrMapOvr>
-</p:sldLayout>
-</file>
-
-<file path=ppt/slideLayouts/slideLayout50.xml><?xml version="1.0" encoding="utf-8"?>
+<file path=ppt/slideLayouts/slideLayout52.xml><?xml version="1.0" encoding="utf-8"?>
 <p:sldLayout xmlns:a="http://schemas.openxmlformats.org/drawingml/2006/main" xmlns:r="http://schemas.openxmlformats.org/officeDocument/2006/relationships" xmlns:p="http://schemas.openxmlformats.org/presentationml/2006/main" preserve="1" userDrawn="1">
   <p:cSld name="ab_vorbild_f">
     <p:spTree>
@@ -20897,7 +21641,7 @@
 </p:sldLayout>
 </file>
 
-<file path=ppt/slideLayouts/slideLayout51.xml><?xml version="1.0" encoding="utf-8"?>
+<file path=ppt/slideLayouts/slideLayout53.xml><?xml version="1.0" encoding="utf-8"?>
 <p:sldLayout xmlns:a="http://schemas.openxmlformats.org/drawingml/2006/main" xmlns:r="http://schemas.openxmlformats.org/officeDocument/2006/relationships" xmlns:p="http://schemas.openxmlformats.org/presentationml/2006/main" preserve="1" userDrawn="1">
   <p:cSld name="ab_vorbild_i">
     <p:spTree>
@@ -21106,7 +21850,7 @@
 </p:sldLayout>
 </file>
 
-<file path=ppt/slideLayouts/slideLayout52.xml><?xml version="1.0" encoding="utf-8"?>
+<file path=ppt/slideLayouts/slideLayout54.xml><?xml version="1.0" encoding="utf-8"?>
 <p:sldLayout xmlns:a="http://schemas.openxmlformats.org/drawingml/2006/main" xmlns:r="http://schemas.openxmlformats.org/officeDocument/2006/relationships" xmlns:p="http://schemas.openxmlformats.org/presentationml/2006/main" preserve="1" userDrawn="1">
   <p:cSld name="ab_verhindern_f">
     <p:spTree>
@@ -21221,7 +21965,7 @@
 </p:sldLayout>
 </file>
 
-<file path=ppt/slideLayouts/slideLayout53.xml><?xml version="1.0" encoding="utf-8"?>
+<file path=ppt/slideLayouts/slideLayout55.xml><?xml version="1.0" encoding="utf-8"?>
 <p:sldLayout xmlns:a="http://schemas.openxmlformats.org/drawingml/2006/main" xmlns:r="http://schemas.openxmlformats.org/officeDocument/2006/relationships" xmlns:p="http://schemas.openxmlformats.org/presentationml/2006/main" preserve="1" userDrawn="1">
   <p:cSld name="ab_verhindern_i">
     <p:spTree>
@@ -21336,7 +22080,7 @@
 </p:sldLayout>
 </file>
 
-<file path=ppt/slideLayouts/slideLayout54.xml><?xml version="1.0" encoding="utf-8"?>
+<file path=ppt/slideLayouts/slideLayout56.xml><?xml version="1.0" encoding="utf-8"?>
 <p:sldLayout xmlns:a="http://schemas.openxmlformats.org/drawingml/2006/main" xmlns:r="http://schemas.openxmlformats.org/officeDocument/2006/relationships" xmlns:p="http://schemas.openxmlformats.org/presentationml/2006/main" preserve="1" userDrawn="1">
   <p:cSld name="ab_audit_f">
     <p:spTree>
@@ -22193,7 +22937,7 @@
 </p:sldLayout>
 </file>
 
-<file path=ppt/slideLayouts/slideLayout55.xml><?xml version="1.0" encoding="utf-8"?>
+<file path=ppt/slideLayouts/slideLayout57.xml><?xml version="1.0" encoding="utf-8"?>
 <p:sldLayout xmlns:a="http://schemas.openxmlformats.org/drawingml/2006/main" xmlns:r="http://schemas.openxmlformats.org/officeDocument/2006/relationships" xmlns:p="http://schemas.openxmlformats.org/presentationml/2006/main" preserve="1" userDrawn="1">
   <p:cSld name="ab_audit_i">
     <p:spTree>
@@ -23050,7 +23794,7 @@
 </p:sldLayout>
 </file>
 
-<file path=ppt/slideLayouts/slideLayout56.xml><?xml version="1.0" encoding="utf-8"?>
+<file path=ppt/slideLayouts/slideLayout58.xml><?xml version="1.0" encoding="utf-8"?>
 <p:sldLayout xmlns:a="http://schemas.openxmlformats.org/drawingml/2006/main" xmlns:r="http://schemas.openxmlformats.org/officeDocument/2006/relationships" xmlns:p="http://schemas.openxmlformats.org/presentationml/2006/main" preserve="1" userDrawn="1">
   <p:cSld name="ab_risikobeurteilung_f">
     <p:spTree>
@@ -25929,7 +26673,7 @@
 </p:sldLayout>
 </file>
 
-<file path=ppt/slideLayouts/slideLayout57.xml><?xml version="1.0" encoding="utf-8"?>
+<file path=ppt/slideLayouts/slideLayout59.xml><?xml version="1.0" encoding="utf-8"?>
 <p:sldLayout xmlns:a="http://schemas.openxmlformats.org/drawingml/2006/main" xmlns:r="http://schemas.openxmlformats.org/officeDocument/2006/relationships" xmlns:p="http://schemas.openxmlformats.org/presentationml/2006/main" preserve="1" userDrawn="1">
   <p:cSld name="ab_risikobeurteilung_i">
     <p:spTree>
@@ -28808,7 +29552,164 @@
 </p:sldLayout>
 </file>
 
-<file path=ppt/slideLayouts/slideLayout58.xml><?xml version="1.0" encoding="utf-8"?>
+<file path=ppt/slideLayouts/slideLayout6.xml><?xml version="1.0" encoding="utf-8"?>
+<p:sldLayout xmlns:a="http://schemas.openxmlformats.org/drawingml/2006/main" xmlns:r="http://schemas.openxmlformats.org/officeDocument/2006/relationships" xmlns:p="http://schemas.openxmlformats.org/presentationml/2006/main" preserve="1" userDrawn="1">
+  <p:cSld name="ab_2pictures">
+    <p:spTree>
+      <p:nvGrpSpPr>
+        <p:cNvPr id="1" name=""/>
+        <p:cNvGrpSpPr/>
+        <p:nvPr/>
+      </p:nvGrpSpPr>
+      <p:grpSpPr>
+        <a:xfrm>
+          <a:off x="0" y="0"/>
+          <a:ext cx="0" cy="0"/>
+          <a:chOff x="0" y="0"/>
+          <a:chExt cx="0" cy="0"/>
+        </a:xfrm>
+      </p:grpSpPr>
+      <p:sp>
+        <p:nvSpPr>
+          <p:cNvPr id="11" name="Bildplatzhalter 10"/>
+          <p:cNvSpPr>
+            <a:spLocks noGrp="1"/>
+          </p:cNvSpPr>
+          <p:nvPr>
+            <p:ph type="pic" sz="quarter" idx="13"/>
+          </p:nvPr>
+        </p:nvSpPr>
+        <p:spPr>
+          <a:xfrm>
+            <a:off x="551384" y="1557338"/>
+            <a:ext cx="5256000" cy="4608512"/>
+          </a:xfrm>
+        </p:spPr>
+        <p:txBody>
+          <a:bodyPr/>
+          <a:lstStyle/>
+          <a:p>
+            <a:endParaRPr lang="de-CH"/>
+          </a:p>
+        </p:txBody>
+      </p:sp>
+      <p:sp>
+        <p:nvSpPr>
+          <p:cNvPr id="2" name="Title 1">
+            <a:extLst>
+              <a:ext uri="{FF2B5EF4-FFF2-40B4-BE49-F238E27FC236}">
+                <a16:creationId xmlns:a16="http://schemas.microsoft.com/office/drawing/2014/main" id="{0DD17F60-50C9-498E-870C-52D42C0B20AA}"/>
+              </a:ext>
+            </a:extLst>
+          </p:cNvPr>
+          <p:cNvSpPr>
+            <a:spLocks noGrp="1"/>
+          </p:cNvSpPr>
+          <p:nvPr>
+            <p:ph type="title"/>
+          </p:nvPr>
+        </p:nvSpPr>
+        <p:spPr/>
+        <p:txBody>
+          <a:bodyPr/>
+          <a:lstStyle>
+            <a:lvl1pPr>
+              <a:defRPr>
+                <a:solidFill>
+                  <a:schemeClr val="accent2"/>
+                </a:solidFill>
+              </a:defRPr>
+            </a:lvl1pPr>
+          </a:lstStyle>
+          <a:p>
+            <a:r>
+              <a:rPr lang="de-DE"/>
+              <a:t>Titelmasterformat durch Klicken bearbeiten</a:t>
+            </a:r>
+            <a:endParaRPr lang="de-CH"/>
+          </a:p>
+        </p:txBody>
+      </p:sp>
+      <p:pic>
+        <p:nvPicPr>
+          <p:cNvPr id="8" name="Picture 8">
+            <a:extLst>
+              <a:ext uri="{FF2B5EF4-FFF2-40B4-BE49-F238E27FC236}">
+                <a16:creationId xmlns:a16="http://schemas.microsoft.com/office/drawing/2014/main" id="{3CA5065B-B47F-4EFF-A8DB-739B22B705E3}"/>
+              </a:ext>
+            </a:extLst>
+          </p:cNvPr>
+          <p:cNvPicPr>
+            <a:picLocks noChangeAspect="1"/>
+          </p:cNvPicPr>
+          <p:nvPr userDrawn="1"/>
+        </p:nvPicPr>
+        <p:blipFill>
+          <a:blip r:embed="rId2" cstate="print">
+            <a:extLst>
+              <a:ext uri="{28A0092B-C50C-407E-A947-70E740481C1C}">
+                <a14:useLocalDpi xmlns:a14="http://schemas.microsoft.com/office/drawing/2010/main" val="0"/>
+              </a:ext>
+            </a:extLst>
+          </a:blip>
+          <a:stretch>
+            <a:fillRect/>
+          </a:stretch>
+        </p:blipFill>
+        <p:spPr>
+          <a:xfrm>
+            <a:off x="10931128" y="6407803"/>
+            <a:ext cx="721398" cy="181020"/>
+          </a:xfrm>
+          <a:prstGeom prst="rect">
+            <a:avLst/>
+          </a:prstGeom>
+        </p:spPr>
+      </p:pic>
+      <p:sp>
+        <p:nvSpPr>
+          <p:cNvPr id="4" name="Bildplatzhalter 10">
+            <a:extLst>
+              <a:ext uri="{FF2B5EF4-FFF2-40B4-BE49-F238E27FC236}">
+                <a16:creationId xmlns:a16="http://schemas.microsoft.com/office/drawing/2014/main" id="{5B24F6E3-B1B1-E6CD-07C4-213B3165F708}"/>
+              </a:ext>
+            </a:extLst>
+          </p:cNvPr>
+          <p:cNvSpPr>
+            <a:spLocks noGrp="1"/>
+          </p:cNvSpPr>
+          <p:nvPr>
+            <p:ph type="pic" sz="quarter" idx="14"/>
+          </p:nvPr>
+        </p:nvSpPr>
+        <p:spPr>
+          <a:xfrm>
+            <a:off x="6384616" y="1548269"/>
+            <a:ext cx="5256000" cy="4608512"/>
+          </a:xfrm>
+        </p:spPr>
+        <p:txBody>
+          <a:bodyPr/>
+          <a:lstStyle/>
+          <a:p>
+            <a:endParaRPr lang="de-CH"/>
+          </a:p>
+        </p:txBody>
+      </p:sp>
+    </p:spTree>
+    <p:extLst>
+      <p:ext uri="{BB962C8B-B14F-4D97-AF65-F5344CB8AC3E}">
+        <p14:creationId xmlns:p14="http://schemas.microsoft.com/office/powerpoint/2010/main" val="3767186152"/>
+      </p:ext>
+    </p:extLst>
+  </p:cSld>
+  <p:clrMapOvr>
+    <a:masterClrMapping/>
+  </p:clrMapOvr>
+</p:sldLayout>
+</file>
+
+<file path=ppt/slideLayouts/slideLayout60.xml><?xml version="1.0" encoding="utf-8"?>
 <p:sldLayout xmlns:a="http://schemas.openxmlformats.org/drawingml/2006/main" xmlns:r="http://schemas.openxmlformats.org/officeDocument/2006/relationships" xmlns:p="http://schemas.openxmlformats.org/presentationml/2006/main" preserve="1" userDrawn="1">
   <p:cSld name="ab_aviva_f">
     <p:spTree>
@@ -29051,7 +29952,7 @@
 </p:sldLayout>
 </file>
 
-<file path=ppt/slideLayouts/slideLayout59.xml><?xml version="1.0" encoding="utf-8"?>
+<file path=ppt/slideLayouts/slideLayout61.xml><?xml version="1.0" encoding="utf-8"?>
 <p:sldLayout xmlns:a="http://schemas.openxmlformats.org/drawingml/2006/main" xmlns:r="http://schemas.openxmlformats.org/officeDocument/2006/relationships" xmlns:p="http://schemas.openxmlformats.org/presentationml/2006/main" preserve="1" userDrawn="1">
   <p:cSld name="ab_aviva_i">
     <p:spTree>
@@ -29294,8 +30195,195 @@
 </p:sldLayout>
 </file>
 
-<file path=ppt/slideLayouts/slideLayout6.xml><?xml version="1.0" encoding="utf-8"?>
-<p:sldLayout xmlns:a="http://schemas.openxmlformats.org/drawingml/2006/main" xmlns:ns2="http://schemas.microsoft.com/office/drawing/2014/main" xmlns:ns3="http://schemas.microsoft.com/office/powerpoint/2010/main" xmlns:p="http://schemas.openxmlformats.org/presentationml/2006/main" preserve="1" userDrawn="1">
+<file path=ppt/slideLayouts/slideLayout7.xml><?xml version="1.0" encoding="utf-8"?>
+<p:sldLayout xmlns:a="http://schemas.openxmlformats.org/drawingml/2006/main" xmlns:r="http://schemas.openxmlformats.org/officeDocument/2006/relationships" xmlns:p="http://schemas.openxmlformats.org/presentationml/2006/main" preserve="1" userDrawn="1">
+  <p:cSld name="ab_3pictures">
+    <p:spTree>
+      <p:nvGrpSpPr>
+        <p:cNvPr id="1" name=""/>
+        <p:cNvGrpSpPr/>
+        <p:nvPr/>
+      </p:nvGrpSpPr>
+      <p:grpSpPr>
+        <a:xfrm>
+          <a:off x="0" y="0"/>
+          <a:ext cx="0" cy="0"/>
+          <a:chOff x="0" y="0"/>
+          <a:chExt cx="0" cy="0"/>
+        </a:xfrm>
+      </p:grpSpPr>
+      <p:sp>
+        <p:nvSpPr>
+          <p:cNvPr id="11" name="Bildplatzhalter 10"/>
+          <p:cNvSpPr>
+            <a:spLocks noGrp="1"/>
+          </p:cNvSpPr>
+          <p:nvPr>
+            <p:ph type="pic" sz="quarter" idx="13"/>
+          </p:nvPr>
+        </p:nvSpPr>
+        <p:spPr>
+          <a:xfrm>
+            <a:off x="551384" y="2225248"/>
+            <a:ext cx="3456355" cy="3030566"/>
+          </a:xfrm>
+        </p:spPr>
+        <p:txBody>
+          <a:bodyPr/>
+          <a:lstStyle/>
+          <a:p>
+            <a:endParaRPr lang="de-CH"/>
+          </a:p>
+        </p:txBody>
+      </p:sp>
+      <p:sp>
+        <p:nvSpPr>
+          <p:cNvPr id="2" name="Title 1">
+            <a:extLst>
+              <a:ext uri="{FF2B5EF4-FFF2-40B4-BE49-F238E27FC236}">
+                <a16:creationId xmlns:a16="http://schemas.microsoft.com/office/drawing/2014/main" id="{0DD17F60-50C9-498E-870C-52D42C0B20AA}"/>
+              </a:ext>
+            </a:extLst>
+          </p:cNvPr>
+          <p:cNvSpPr>
+            <a:spLocks noGrp="1"/>
+          </p:cNvSpPr>
+          <p:nvPr>
+            <p:ph type="title"/>
+          </p:nvPr>
+        </p:nvSpPr>
+        <p:spPr/>
+        <p:txBody>
+          <a:bodyPr/>
+          <a:lstStyle>
+            <a:lvl1pPr>
+              <a:defRPr>
+                <a:solidFill>
+                  <a:schemeClr val="accent2"/>
+                </a:solidFill>
+              </a:defRPr>
+            </a:lvl1pPr>
+          </a:lstStyle>
+          <a:p>
+            <a:r>
+              <a:rPr lang="de-DE"/>
+              <a:t>Titelmasterformat durch Klicken bearbeiten</a:t>
+            </a:r>
+            <a:endParaRPr lang="de-CH"/>
+          </a:p>
+        </p:txBody>
+      </p:sp>
+      <p:pic>
+        <p:nvPicPr>
+          <p:cNvPr id="8" name="Picture 8">
+            <a:extLst>
+              <a:ext uri="{FF2B5EF4-FFF2-40B4-BE49-F238E27FC236}">
+                <a16:creationId xmlns:a16="http://schemas.microsoft.com/office/drawing/2014/main" id="{3CA5065B-B47F-4EFF-A8DB-739B22B705E3}"/>
+              </a:ext>
+            </a:extLst>
+          </p:cNvPr>
+          <p:cNvPicPr>
+            <a:picLocks noChangeAspect="1"/>
+          </p:cNvPicPr>
+          <p:nvPr userDrawn="1"/>
+        </p:nvPicPr>
+        <p:blipFill>
+          <a:blip r:embed="rId2" cstate="print">
+            <a:extLst>
+              <a:ext uri="{28A0092B-C50C-407E-A947-70E740481C1C}">
+                <a14:useLocalDpi xmlns:a14="http://schemas.microsoft.com/office/drawing/2010/main" val="0"/>
+              </a:ext>
+            </a:extLst>
+          </a:blip>
+          <a:stretch>
+            <a:fillRect/>
+          </a:stretch>
+        </p:blipFill>
+        <p:spPr>
+          <a:xfrm>
+            <a:off x="10931128" y="6407803"/>
+            <a:ext cx="721398" cy="181020"/>
+          </a:xfrm>
+          <a:prstGeom prst="rect">
+            <a:avLst/>
+          </a:prstGeom>
+        </p:spPr>
+      </p:pic>
+      <p:sp>
+        <p:nvSpPr>
+          <p:cNvPr id="4" name="Bildplatzhalter 10">
+            <a:extLst>
+              <a:ext uri="{FF2B5EF4-FFF2-40B4-BE49-F238E27FC236}">
+                <a16:creationId xmlns:a16="http://schemas.microsoft.com/office/drawing/2014/main" id="{5B24F6E3-B1B1-E6CD-07C4-213B3165F708}"/>
+              </a:ext>
+            </a:extLst>
+          </p:cNvPr>
+          <p:cNvSpPr>
+            <a:spLocks noGrp="1"/>
+          </p:cNvSpPr>
+          <p:nvPr>
+            <p:ph type="pic" sz="quarter" idx="14"/>
+          </p:nvPr>
+        </p:nvSpPr>
+        <p:spPr>
+          <a:xfrm>
+            <a:off x="4367822" y="2225247"/>
+            <a:ext cx="3456355" cy="3030566"/>
+          </a:xfrm>
+        </p:spPr>
+        <p:txBody>
+          <a:bodyPr/>
+          <a:lstStyle/>
+          <a:p>
+            <a:endParaRPr lang="de-CH"/>
+          </a:p>
+        </p:txBody>
+      </p:sp>
+      <p:sp>
+        <p:nvSpPr>
+          <p:cNvPr id="5" name="Picture Placeholder 4">
+            <a:extLst>
+              <a:ext uri="{FF2B5EF4-FFF2-40B4-BE49-F238E27FC236}">
+                <a16:creationId xmlns:a16="http://schemas.microsoft.com/office/drawing/2014/main" id="{27BC8EC7-2EA9-CF9C-3B05-E585AB0B2BC9}"/>
+              </a:ext>
+            </a:extLst>
+          </p:cNvPr>
+          <p:cNvSpPr>
+            <a:spLocks noGrp="1"/>
+          </p:cNvSpPr>
+          <p:nvPr>
+            <p:ph type="pic" sz="quarter" idx="15"/>
+          </p:nvPr>
+        </p:nvSpPr>
+        <p:spPr>
+          <a:xfrm>
+            <a:off x="8184261" y="2225247"/>
+            <a:ext cx="3456355" cy="3030566"/>
+          </a:xfrm>
+        </p:spPr>
+        <p:txBody>
+          <a:bodyPr/>
+          <a:lstStyle/>
+          <a:p>
+            <a:endParaRPr lang="de-CH"/>
+          </a:p>
+        </p:txBody>
+      </p:sp>
+    </p:spTree>
+    <p:extLst>
+      <p:ext uri="{BB962C8B-B14F-4D97-AF65-F5344CB8AC3E}">
+        <p14:creationId xmlns:p14="http://schemas.microsoft.com/office/powerpoint/2010/main" val="2115904746"/>
+      </p:ext>
+    </p:extLst>
+  </p:cSld>
+  <p:clrMapOvr>
+    <a:masterClrMapping/>
+  </p:clrMapOvr>
+</p:sldLayout>
+</file>
+
+<file path=ppt/slideLayouts/slideLayout8.xml><?xml version="1.0" encoding="utf-8"?>
+<p:sldLayout xmlns:a="http://schemas.openxmlformats.org/drawingml/2006/main" xmlns:r="http://schemas.openxmlformats.org/officeDocument/2006/relationships" xmlns:p="http://schemas.openxmlformats.org/presentationml/2006/main" preserve="1" userDrawn="1">
   <p:cSld name="ab_4pictures">
     <p:spTree>
       <p:nvGrpSpPr>
@@ -29316,7 +30404,7 @@
           <p:cNvPr id="2" name="Titel 1">
             <a:extLst>
               <a:ext uri="{FF2B5EF4-FFF2-40B4-BE49-F238E27FC236}">
-                <ns2:creationId id="{A1540017-C5E1-4CC7-9997-40CEFDC98621}"/>
+                <a16:creationId xmlns:a16="http://schemas.microsoft.com/office/drawing/2014/main" id="{A1540017-C5E1-4CC7-9997-40CEFDC98621}"/>
               </a:ext>
             </a:extLst>
           </p:cNvPr>
@@ -29353,7 +30441,7 @@
           <p:cNvPr id="7" name="Bildplatzhalter 6">
             <a:extLst>
               <a:ext uri="{FF2B5EF4-FFF2-40B4-BE49-F238E27FC236}">
-                <ns2:creationId id="{0382034B-75CE-4875-AF93-5B9AEC42BF3E}"/>
+                <a16:creationId xmlns:a16="http://schemas.microsoft.com/office/drawing/2014/main" id="{0382034B-75CE-4875-AF93-5B9AEC42BF3E}"/>
               </a:ext>
             </a:extLst>
           </p:cNvPr>
@@ -29366,7 +30454,7 @@
         </p:nvSpPr>
         <p:spPr>
           <a:xfrm>
-            <a:off x="550863" y="1556983"/>
+            <a:off x="551384" y="2287832"/>
             <a:ext cx="2664000" cy="2664000"/>
           </a:xfrm>
         </p:spPr>
@@ -29383,7 +30471,7 @@
           <p:cNvPr id="14" name="Bildplatzhalter 6">
             <a:extLst>
               <a:ext uri="{FF2B5EF4-FFF2-40B4-BE49-F238E27FC236}">
-                <ns2:creationId id="{B38D0A6D-8C1B-41E3-90AE-960E8DAA3BA0}"/>
+                <a16:creationId xmlns:a16="http://schemas.microsoft.com/office/drawing/2014/main" id="{B38D0A6D-8C1B-41E3-90AE-960E8DAA3BA0}"/>
               </a:ext>
             </a:extLst>
           </p:cNvPr>
@@ -29396,7 +30484,7 @@
         </p:nvSpPr>
         <p:spPr>
           <a:xfrm>
-            <a:off x="3359447" y="1556983"/>
+            <a:off x="3359968" y="2287832"/>
             <a:ext cx="2664000" cy="2664000"/>
           </a:xfrm>
         </p:spPr>
@@ -29413,7 +30501,7 @@
           <p:cNvPr id="15" name="Bildplatzhalter 6">
             <a:extLst>
               <a:ext uri="{FF2B5EF4-FFF2-40B4-BE49-F238E27FC236}">
-                <ns2:creationId id="{511998C5-CA15-491D-A5FC-E002D1FA4BB9}"/>
+                <a16:creationId xmlns:a16="http://schemas.microsoft.com/office/drawing/2014/main" id="{511998C5-CA15-491D-A5FC-E002D1FA4BB9}"/>
               </a:ext>
             </a:extLst>
           </p:cNvPr>
@@ -29426,7 +30514,7 @@
         </p:nvSpPr>
         <p:spPr>
           <a:xfrm>
-            <a:off x="6168031" y="1556983"/>
+            <a:off x="6168552" y="2287832"/>
             <a:ext cx="2664000" cy="2664000"/>
           </a:xfrm>
         </p:spPr>
@@ -29443,7 +30531,7 @@
           <p:cNvPr id="16" name="Bildplatzhalter 6">
             <a:extLst>
               <a:ext uri="{FF2B5EF4-FFF2-40B4-BE49-F238E27FC236}">
-                <ns2:creationId id="{7919B8D0-ECEF-4226-AB3A-F8F566FD56A1}"/>
+                <a16:creationId xmlns:a16="http://schemas.microsoft.com/office/drawing/2014/main" id="{7919B8D0-ECEF-4226-AB3A-F8F566FD56A1}"/>
               </a:ext>
             </a:extLst>
           </p:cNvPr>
@@ -29456,7 +30544,7 @@
         </p:nvSpPr>
         <p:spPr>
           <a:xfrm>
-            <a:off x="8976616" y="1556983"/>
+            <a:off x="8977137" y="2287832"/>
             <a:ext cx="2664000" cy="2664000"/>
           </a:xfrm>
         </p:spPr>
@@ -29471,7 +30559,7 @@
     </p:spTree>
     <p:extLst>
       <p:ext uri="{BB962C8B-B14F-4D97-AF65-F5344CB8AC3E}">
-        <ns3:creationId val="2358483093"/>
+        <p14:creationId xmlns:p14="http://schemas.microsoft.com/office/powerpoint/2010/main" val="2358483093"/>
       </p:ext>
     </p:extLst>
   </p:cSld>
@@ -29481,8 +30569,8 @@
 </p:sldLayout>
 </file>
 
-<file path=ppt/slideLayouts/slideLayout7.xml><?xml version="1.0" encoding="utf-8"?>
-<p:sldLayout xmlns:a="http://schemas.openxmlformats.org/drawingml/2006/main" xmlns:ns2="http://schemas.microsoft.com/office/drawing/2014/main" xmlns:ns3="http://schemas.microsoft.com/office/powerpoint/2010/main" xmlns:p="http://schemas.openxmlformats.org/presentationml/2006/main" preserve="1" userDrawn="1">
+<file path=ppt/slideLayouts/slideLayout9.xml><?xml version="1.0" encoding="utf-8"?>
+<p:sldLayout xmlns:a="http://schemas.openxmlformats.org/drawingml/2006/main" xmlns:r="http://schemas.openxmlformats.org/officeDocument/2006/relationships" xmlns:p="http://schemas.openxmlformats.org/presentationml/2006/main" preserve="1" userDrawn="1">
   <p:cSld name="ab_6pictures">
     <p:spTree>
       <p:nvGrpSpPr>
@@ -29503,7 +30591,7 @@
           <p:cNvPr id="2" name="Titel 1">
             <a:extLst>
               <a:ext uri="{FF2B5EF4-FFF2-40B4-BE49-F238E27FC236}">
-                <ns2:creationId id="{A1540017-C5E1-4CC7-9997-40CEFDC98621}"/>
+                <a16:creationId xmlns:a16="http://schemas.microsoft.com/office/drawing/2014/main" id="{A1540017-C5E1-4CC7-9997-40CEFDC98621}"/>
               </a:ext>
             </a:extLst>
           </p:cNvPr>
@@ -29540,7 +30628,7 @@
           <p:cNvPr id="7" name="Bildplatzhalter 6">
             <a:extLst>
               <a:ext uri="{FF2B5EF4-FFF2-40B4-BE49-F238E27FC236}">
-                <ns2:creationId id="{0382034B-75CE-4875-AF93-5B9AEC42BF3E}"/>
+                <a16:creationId xmlns:a16="http://schemas.microsoft.com/office/drawing/2014/main" id="{0382034B-75CE-4875-AF93-5B9AEC42BF3E}"/>
               </a:ext>
             </a:extLst>
           </p:cNvPr>
@@ -29570,7 +30658,7 @@
           <p:cNvPr id="13" name="Bildplatzhalter 6">
             <a:extLst>
               <a:ext uri="{FF2B5EF4-FFF2-40B4-BE49-F238E27FC236}">
-                <ns2:creationId id="{607B72A4-E39A-476A-8687-3FCD28CB83A6}"/>
+                <a16:creationId xmlns:a16="http://schemas.microsoft.com/office/drawing/2014/main" id="{607B72A4-E39A-476A-8687-3FCD28CB83A6}"/>
               </a:ext>
             </a:extLst>
           </p:cNvPr>
@@ -29600,7 +30688,7 @@
           <p:cNvPr id="17" name="Bildplatzhalter 6">
             <a:extLst>
               <a:ext uri="{FF2B5EF4-FFF2-40B4-BE49-F238E27FC236}">
-                <ns2:creationId id="{FCFD829E-5138-4372-AB3B-C9BF85E847A1}"/>
+                <a16:creationId xmlns:a16="http://schemas.microsoft.com/office/drawing/2014/main" id="{FCFD829E-5138-4372-AB3B-C9BF85E847A1}"/>
               </a:ext>
             </a:extLst>
           </p:cNvPr>
@@ -29630,7 +30718,7 @@
           <p:cNvPr id="18" name="Bildplatzhalter 6">
             <a:extLst>
               <a:ext uri="{FF2B5EF4-FFF2-40B4-BE49-F238E27FC236}">
-                <ns2:creationId id="{79805CEC-A509-420F-B7E0-C60DCCD99CC4}"/>
+                <a16:creationId xmlns:a16="http://schemas.microsoft.com/office/drawing/2014/main" id="{79805CEC-A509-420F-B7E0-C60DCCD99CC4}"/>
               </a:ext>
             </a:extLst>
           </p:cNvPr>
@@ -29660,7 +30748,7 @@
           <p:cNvPr id="19" name="Bildplatzhalter 6">
             <a:extLst>
               <a:ext uri="{FF2B5EF4-FFF2-40B4-BE49-F238E27FC236}">
-                <ns2:creationId id="{8852ACCB-309D-4DF9-AE62-015A18866698}"/>
+                <a16:creationId xmlns:a16="http://schemas.microsoft.com/office/drawing/2014/main" id="{8852ACCB-309D-4DF9-AE62-015A18866698}"/>
               </a:ext>
             </a:extLst>
           </p:cNvPr>
@@ -29690,7 +30778,7 @@
           <p:cNvPr id="20" name="Bildplatzhalter 6">
             <a:extLst>
               <a:ext uri="{FF2B5EF4-FFF2-40B4-BE49-F238E27FC236}">
-                <ns2:creationId id="{F86B3AAD-71C5-411C-BBF4-0A36C1A2DFDB}"/>
+                <a16:creationId xmlns:a16="http://schemas.microsoft.com/office/drawing/2014/main" id="{F86B3AAD-71C5-411C-BBF4-0A36C1A2DFDB}"/>
               </a:ext>
             </a:extLst>
           </p:cNvPr>
@@ -29718,7 +30806,7 @@
     </p:spTree>
     <p:extLst>
       <p:ext uri="{BB962C8B-B14F-4D97-AF65-F5344CB8AC3E}">
-        <ns3:creationId val="1527158762"/>
+        <p14:creationId xmlns:p14="http://schemas.microsoft.com/office/powerpoint/2010/main" val="1527158762"/>
       </p:ext>
     </p:extLst>
   </p:cSld>
@@ -29728,752 +30816,8 @@
 </p:sldLayout>
 </file>
 
-<file path=ppt/slideLayouts/slideLayout8.xml><?xml version="1.0" encoding="utf-8"?>
-<p:sldLayout xmlns:a="http://schemas.openxmlformats.org/drawingml/2006/main" xmlns:ns2="http://schemas.microsoft.com/office/drawing/2014/main" xmlns:ns3="http://schemas.microsoft.com/office/powerpoint/2010/main" xmlns:p="http://schemas.openxmlformats.org/presentationml/2006/main" preserve="1" userDrawn="1">
-  <p:cSld name="ab_8pictures">
-    <p:spTree>
-      <p:nvGrpSpPr>
-        <p:cNvPr id="1" name=""/>
-        <p:cNvGrpSpPr/>
-        <p:nvPr/>
-      </p:nvGrpSpPr>
-      <p:grpSpPr>
-        <a:xfrm>
-          <a:off x="0" y="0"/>
-          <a:ext cx="0" cy="0"/>
-          <a:chOff x="0" y="0"/>
-          <a:chExt cx="0" cy="0"/>
-        </a:xfrm>
-      </p:grpSpPr>
-      <p:sp>
-        <p:nvSpPr>
-          <p:cNvPr id="2" name="Titel 1">
-            <a:extLst>
-              <a:ext uri="{FF2B5EF4-FFF2-40B4-BE49-F238E27FC236}">
-                <ns2:creationId id="{A1540017-C5E1-4CC7-9997-40CEFDC98621}"/>
-              </a:ext>
-            </a:extLst>
-          </p:cNvPr>
-          <p:cNvSpPr>
-            <a:spLocks noGrp="1"/>
-          </p:cNvSpPr>
-          <p:nvPr>
-            <p:ph type="title"/>
-          </p:nvPr>
-        </p:nvSpPr>
-        <p:spPr/>
-        <p:txBody>
-          <a:bodyPr/>
-          <a:lstStyle/>
-          <a:p>
-            <a:r>
-              <a:rPr lang="de-DE"/>
-              <a:t>Mastertitelformat bearbeiten</a:t>
-            </a:r>
-            <a:endParaRPr lang="de-CH"/>
-          </a:p>
-        </p:txBody>
-      </p:sp>
-      <p:sp>
-        <p:nvSpPr>
-          <p:cNvPr id="7" name="Bildplatzhalter 6">
-            <a:extLst>
-              <a:ext uri="{FF2B5EF4-FFF2-40B4-BE49-F238E27FC236}">
-                <ns2:creationId id="{0382034B-75CE-4875-AF93-5B9AEC42BF3E}"/>
-              </a:ext>
-            </a:extLst>
-          </p:cNvPr>
-          <p:cNvSpPr>
-            <a:spLocks noGrp="1"/>
-          </p:cNvSpPr>
-          <p:nvPr>
-            <p:ph type="pic" sz="quarter" idx="10"/>
-          </p:nvPr>
-        </p:nvSpPr>
-        <p:spPr>
-          <a:xfrm>
-            <a:off x="550863" y="1556983"/>
-            <a:ext cx="2664000" cy="2340000"/>
-          </a:xfrm>
-        </p:spPr>
-        <p:txBody>
-          <a:bodyPr/>
-          <a:lstStyle/>
-          <a:p>
-            <a:endParaRPr lang="de-CH"/>
-          </a:p>
-        </p:txBody>
-      </p:sp>
-      <p:sp>
-        <p:nvSpPr>
-          <p:cNvPr id="14" name="Bildplatzhalter 6">
-            <a:extLst>
-              <a:ext uri="{FF2B5EF4-FFF2-40B4-BE49-F238E27FC236}">
-                <ns2:creationId id="{B38D0A6D-8C1B-41E3-90AE-960E8DAA3BA0}"/>
-              </a:ext>
-            </a:extLst>
-          </p:cNvPr>
-          <p:cNvSpPr>
-            <a:spLocks noGrp="1"/>
-          </p:cNvSpPr>
-          <p:nvPr>
-            <p:ph type="pic" sz="quarter" idx="11"/>
-          </p:nvPr>
-        </p:nvSpPr>
-        <p:spPr>
-          <a:xfrm>
-            <a:off x="3359447" y="1556983"/>
-            <a:ext cx="2664000" cy="2340000"/>
-          </a:xfrm>
-        </p:spPr>
-        <p:txBody>
-          <a:bodyPr/>
-          <a:lstStyle/>
-          <a:p>
-            <a:endParaRPr lang="de-CH"/>
-          </a:p>
-        </p:txBody>
-      </p:sp>
-      <p:sp>
-        <p:nvSpPr>
-          <p:cNvPr id="15" name="Bildplatzhalter 6">
-            <a:extLst>
-              <a:ext uri="{FF2B5EF4-FFF2-40B4-BE49-F238E27FC236}">
-                <ns2:creationId id="{511998C5-CA15-491D-A5FC-E002D1FA4BB9}"/>
-              </a:ext>
-            </a:extLst>
-          </p:cNvPr>
-          <p:cNvSpPr>
-            <a:spLocks noGrp="1"/>
-          </p:cNvSpPr>
-          <p:nvPr>
-            <p:ph type="pic" sz="quarter" idx="12"/>
-          </p:nvPr>
-        </p:nvSpPr>
-        <p:spPr>
-          <a:xfrm>
-            <a:off x="6168031" y="1556983"/>
-            <a:ext cx="2664000" cy="2340000"/>
-          </a:xfrm>
-        </p:spPr>
-        <p:txBody>
-          <a:bodyPr/>
-          <a:lstStyle/>
-          <a:p>
-            <a:endParaRPr lang="de-CH"/>
-          </a:p>
-        </p:txBody>
-      </p:sp>
-      <p:sp>
-        <p:nvSpPr>
-          <p:cNvPr id="16" name="Bildplatzhalter 6">
-            <a:extLst>
-              <a:ext uri="{FF2B5EF4-FFF2-40B4-BE49-F238E27FC236}">
-                <ns2:creationId id="{7919B8D0-ECEF-4226-AB3A-F8F566FD56A1}"/>
-              </a:ext>
-            </a:extLst>
-          </p:cNvPr>
-          <p:cNvSpPr>
-            <a:spLocks noGrp="1"/>
-          </p:cNvSpPr>
-          <p:nvPr>
-            <p:ph type="pic" sz="quarter" idx="13"/>
-          </p:nvPr>
-        </p:nvSpPr>
-        <p:spPr>
-          <a:xfrm>
-            <a:off x="8976616" y="1556983"/>
-            <a:ext cx="2664000" cy="2340000"/>
-          </a:xfrm>
-        </p:spPr>
-        <p:txBody>
-          <a:bodyPr/>
-          <a:lstStyle/>
-          <a:p>
-            <a:endParaRPr lang="de-CH"/>
-          </a:p>
-        </p:txBody>
-      </p:sp>
-      <p:sp>
-        <p:nvSpPr>
-          <p:cNvPr id="8" name="Bildplatzhalter 6">
-            <a:extLst>
-              <a:ext uri="{FF2B5EF4-FFF2-40B4-BE49-F238E27FC236}">
-                <ns2:creationId id="{F419A863-A24E-4DC6-98B8-87B35CD3CAD3}"/>
-              </a:ext>
-            </a:extLst>
-          </p:cNvPr>
-          <p:cNvSpPr>
-            <a:spLocks noGrp="1"/>
-          </p:cNvSpPr>
-          <p:nvPr>
-            <p:ph type="pic" sz="quarter" idx="14"/>
-          </p:nvPr>
-        </p:nvSpPr>
-        <p:spPr>
-          <a:xfrm>
-            <a:off x="569475" y="4239870"/>
-            <a:ext cx="2664000" cy="2340000"/>
-          </a:xfrm>
-        </p:spPr>
-        <p:txBody>
-          <a:bodyPr/>
-          <a:lstStyle/>
-          <a:p>
-            <a:endParaRPr lang="de-CH"/>
-          </a:p>
-        </p:txBody>
-      </p:sp>
-      <p:sp>
-        <p:nvSpPr>
-          <p:cNvPr id="9" name="Bildplatzhalter 6">
-            <a:extLst>
-              <a:ext uri="{FF2B5EF4-FFF2-40B4-BE49-F238E27FC236}">
-                <ns2:creationId id="{6108253A-EE25-4600-BE74-5FD974B5CED2}"/>
-              </a:ext>
-            </a:extLst>
-          </p:cNvPr>
-          <p:cNvSpPr>
-            <a:spLocks noGrp="1"/>
-          </p:cNvSpPr>
-          <p:nvPr>
-            <p:ph type="pic" sz="quarter" idx="15"/>
-          </p:nvPr>
-        </p:nvSpPr>
-        <p:spPr>
-          <a:xfrm>
-            <a:off x="3378059" y="4239870"/>
-            <a:ext cx="2664000" cy="2340000"/>
-          </a:xfrm>
-        </p:spPr>
-        <p:txBody>
-          <a:bodyPr/>
-          <a:lstStyle/>
-          <a:p>
-            <a:endParaRPr lang="de-CH"/>
-          </a:p>
-        </p:txBody>
-      </p:sp>
-      <p:sp>
-        <p:nvSpPr>
-          <p:cNvPr id="10" name="Bildplatzhalter 6">
-            <a:extLst>
-              <a:ext uri="{FF2B5EF4-FFF2-40B4-BE49-F238E27FC236}">
-                <ns2:creationId id="{F6293461-5015-4965-A9BF-4F87175D0672}"/>
-              </a:ext>
-            </a:extLst>
-          </p:cNvPr>
-          <p:cNvSpPr>
-            <a:spLocks noGrp="1"/>
-          </p:cNvSpPr>
-          <p:nvPr>
-            <p:ph type="pic" sz="quarter" idx="16"/>
-          </p:nvPr>
-        </p:nvSpPr>
-        <p:spPr>
-          <a:xfrm>
-            <a:off x="6186643" y="4239870"/>
-            <a:ext cx="2664000" cy="2340000"/>
-          </a:xfrm>
-        </p:spPr>
-        <p:txBody>
-          <a:bodyPr/>
-          <a:lstStyle/>
-          <a:p>
-            <a:endParaRPr lang="de-CH"/>
-          </a:p>
-        </p:txBody>
-      </p:sp>
-      <p:sp>
-        <p:nvSpPr>
-          <p:cNvPr id="11" name="Bildplatzhalter 6">
-            <a:extLst>
-              <a:ext uri="{FF2B5EF4-FFF2-40B4-BE49-F238E27FC236}">
-                <ns2:creationId id="{174B38FE-FC22-40DC-B260-374CEABC9C3A}"/>
-              </a:ext>
-            </a:extLst>
-          </p:cNvPr>
-          <p:cNvSpPr>
-            <a:spLocks noGrp="1"/>
-          </p:cNvSpPr>
-          <p:nvPr>
-            <p:ph type="pic" sz="quarter" idx="17"/>
-          </p:nvPr>
-        </p:nvSpPr>
-        <p:spPr>
-          <a:xfrm>
-            <a:off x="8995228" y="4239870"/>
-            <a:ext cx="2664000" cy="2340000"/>
-          </a:xfrm>
-        </p:spPr>
-        <p:txBody>
-          <a:bodyPr/>
-          <a:lstStyle/>
-          <a:p>
-            <a:endParaRPr lang="de-CH"/>
-          </a:p>
-        </p:txBody>
-      </p:sp>
-    </p:spTree>
-    <p:extLst>
-      <p:ext uri="{BB962C8B-B14F-4D97-AF65-F5344CB8AC3E}">
-        <ns3:creationId val="4164158816"/>
-      </p:ext>
-    </p:extLst>
-  </p:cSld>
-  <p:clrMapOvr>
-    <a:masterClrMapping/>
-  </p:clrMapOvr>
-</p:sldLayout>
-</file>
-
-<file path=ppt/slideLayouts/slideLayout9.xml><?xml version="1.0" encoding="utf-8"?>
-<p:sldLayout xmlns:a="http://schemas.openxmlformats.org/drawingml/2006/main" xmlns:r="http://schemas.openxmlformats.org/officeDocument/2006/relationships" xmlns:p="http://schemas.openxmlformats.org/presentationml/2006/main" preserve="1" userDrawn="1">
-  <p:cSld name="ab_unterlassen_d">
-    <p:spTree>
-      <p:nvGrpSpPr>
-        <p:cNvPr id="1" name=""/>
-        <p:cNvGrpSpPr/>
-        <p:nvPr/>
-      </p:nvGrpSpPr>
-      <p:grpSpPr>
-        <a:xfrm>
-          <a:off x="0" y="0"/>
-          <a:ext cx="0" cy="0"/>
-          <a:chOff x="0" y="0"/>
-          <a:chExt cx="0" cy="0"/>
-        </a:xfrm>
-      </p:grpSpPr>
-      <p:sp>
-        <p:nvSpPr>
-          <p:cNvPr id="3" name="Title 10">
-            <a:extLst>
-              <a:ext uri="{FF2B5EF4-FFF2-40B4-BE49-F238E27FC236}">
-                <a16:creationId xmlns:a16="http://schemas.microsoft.com/office/drawing/2014/main" id="{B6A1CCF6-D41A-2EB9-D226-892BFBFD27D1}"/>
-              </a:ext>
-            </a:extLst>
-          </p:cNvPr>
-          <p:cNvSpPr txBox="1">
-            <a:spLocks/>
-          </p:cNvSpPr>
-          <p:nvPr userDrawn="1"/>
-        </p:nvSpPr>
-        <p:spPr>
-          <a:xfrm>
-            <a:off x="551384" y="476672"/>
-            <a:ext cx="11089232" cy="864096"/>
-          </a:xfrm>
-          <a:prstGeom prst="rect">
-            <a:avLst/>
-          </a:prstGeom>
-        </p:spPr>
-        <p:txBody>
-          <a:bodyPr vert="horz" lIns="0" tIns="0" rIns="0" bIns="0" rtlCol="0" anchor="t">
-            <a:noAutofit/>
-          </a:bodyPr>
-          <a:lstStyle>
-            <a:lvl1pPr algn="l" defTabSz="914400" rtl="0" eaLnBrk="1" latinLnBrk="0" hangingPunct="1">
-              <a:lnSpc>
-                <a:spcPct val="100000"/>
-              </a:lnSpc>
-              <a:spcBef>
-                <a:spcPct val="0"/>
-              </a:spcBef>
-              <a:buNone/>
-              <a:defRPr sz="2400" b="1" kern="1200">
-                <a:solidFill>
-                  <a:schemeClr val="accent2"/>
-                </a:solidFill>
-                <a:latin typeface="+mj-lt"/>
-                <a:ea typeface="+mj-ea"/>
-                <a:cs typeface="+mj-cs"/>
-              </a:defRPr>
-            </a:lvl1pPr>
-          </a:lstStyle>
-          <a:p>
-            <a:r>
-              <a:rPr lang="de-CH"/>
-              <a:t>Unterlassen, </a:t>
-            </a:r>
-            <a:r>
-              <a:rPr lang="de-CH">
-                <a:solidFill>
-                  <a:schemeClr val="accent2">
-                    <a:lumMod val="60000"/>
-                    <a:lumOff val="40000"/>
-                  </a:schemeClr>
-                </a:solidFill>
-              </a:rPr>
-              <a:t>Dulden, Handeln</a:t>
-            </a:r>
-            <a:endParaRPr lang="de-CH" dirty="0"/>
-          </a:p>
-        </p:txBody>
-      </p:sp>
-      <p:sp>
-        <p:nvSpPr>
-          <p:cNvPr id="4" name="Rectangle 16">
-            <a:extLst>
-              <a:ext uri="{FF2B5EF4-FFF2-40B4-BE49-F238E27FC236}">
-                <a16:creationId xmlns:a16="http://schemas.microsoft.com/office/drawing/2014/main" id="{18A2DA9F-6EEE-4BA7-481A-7654C0D2B41B}"/>
-              </a:ext>
-            </a:extLst>
-          </p:cNvPr>
-          <p:cNvSpPr/>
-          <p:nvPr userDrawn="1"/>
-        </p:nvSpPr>
-        <p:spPr>
-          <a:xfrm>
-            <a:off x="4097586" y="5167480"/>
-            <a:ext cx="3672408" cy="1260140"/>
-          </a:xfrm>
-          <a:prstGeom prst="rect">
-            <a:avLst/>
-          </a:prstGeom>
-          <a:noFill/>
-          <a:ln w="12700" cap="flat" cmpd="sng" algn="ctr">
-            <a:solidFill>
-              <a:srgbClr val="00B8CF"/>
-            </a:solidFill>
-            <a:prstDash val="solid"/>
-            <a:miter lim="800000"/>
-          </a:ln>
-          <a:effectLst/>
-        </p:spPr>
-        <p:txBody>
-          <a:bodyPr rot="0" spcFirstLastPara="0" vert="horz" wrap="square" lIns="126000" tIns="126000" rIns="126000" bIns="126000" numCol="1" spcCol="0" rtlCol="0" fromWordArt="0" anchor="ctr" anchorCtr="0" forceAA="0" compatLnSpc="1">
-            <a:prstTxWarp prst="textNoShape">
-              <a:avLst/>
-            </a:prstTxWarp>
-            <a:noAutofit/>
-          </a:bodyPr>
-          <a:lstStyle>
-            <a:defPPr>
-              <a:defRPr lang="aa-ET"/>
-            </a:defPPr>
-            <a:lvl1pPr marL="0" algn="l" defTabSz="914400" rtl="0" eaLnBrk="1" latinLnBrk="0" hangingPunct="1">
-              <a:defRPr sz="1800" kern="1200">
-                <a:solidFill>
-                  <a:schemeClr val="tx1"/>
-                </a:solidFill>
-                <a:latin typeface="+mn-lt"/>
-                <a:ea typeface="+mn-ea"/>
-                <a:cs typeface="+mn-cs"/>
-              </a:defRPr>
-            </a:lvl1pPr>
-            <a:lvl2pPr marL="457200" algn="l" defTabSz="914400" rtl="0" eaLnBrk="1" latinLnBrk="0" hangingPunct="1">
-              <a:defRPr sz="1800" kern="1200">
-                <a:solidFill>
-                  <a:schemeClr val="tx1"/>
-                </a:solidFill>
-                <a:latin typeface="+mn-lt"/>
-                <a:ea typeface="+mn-ea"/>
-                <a:cs typeface="+mn-cs"/>
-              </a:defRPr>
-            </a:lvl2pPr>
-            <a:lvl3pPr marL="914400" algn="l" defTabSz="914400" rtl="0" eaLnBrk="1" latinLnBrk="0" hangingPunct="1">
-              <a:defRPr sz="1800" kern="1200">
-                <a:solidFill>
-                  <a:schemeClr val="tx1"/>
-                </a:solidFill>
-                <a:latin typeface="+mn-lt"/>
-                <a:ea typeface="+mn-ea"/>
-                <a:cs typeface="+mn-cs"/>
-              </a:defRPr>
-            </a:lvl3pPr>
-            <a:lvl4pPr marL="1371600" algn="l" defTabSz="914400" rtl="0" eaLnBrk="1" latinLnBrk="0" hangingPunct="1">
-              <a:defRPr sz="1800" kern="1200">
-                <a:solidFill>
-                  <a:schemeClr val="tx1"/>
-                </a:solidFill>
-                <a:latin typeface="+mn-lt"/>
-                <a:ea typeface="+mn-ea"/>
-                <a:cs typeface="+mn-cs"/>
-              </a:defRPr>
-            </a:lvl4pPr>
-            <a:lvl5pPr marL="1828800" algn="l" defTabSz="914400" rtl="0" eaLnBrk="1" latinLnBrk="0" hangingPunct="1">
-              <a:defRPr sz="1800" kern="1200">
-                <a:solidFill>
-                  <a:schemeClr val="tx1"/>
-                </a:solidFill>
-                <a:latin typeface="+mn-lt"/>
-                <a:ea typeface="+mn-ea"/>
-                <a:cs typeface="+mn-cs"/>
-              </a:defRPr>
-            </a:lvl5pPr>
-            <a:lvl6pPr marL="2286000" algn="l" defTabSz="914400" rtl="0" eaLnBrk="1" latinLnBrk="0" hangingPunct="1">
-              <a:defRPr sz="1800" kern="1200">
-                <a:solidFill>
-                  <a:schemeClr val="tx1"/>
-                </a:solidFill>
-                <a:latin typeface="+mn-lt"/>
-                <a:ea typeface="+mn-ea"/>
-                <a:cs typeface="+mn-cs"/>
-              </a:defRPr>
-            </a:lvl6pPr>
-            <a:lvl7pPr marL="2743200" algn="l" defTabSz="914400" rtl="0" eaLnBrk="1" latinLnBrk="0" hangingPunct="1">
-              <a:defRPr sz="1800" kern="1200">
-                <a:solidFill>
-                  <a:schemeClr val="tx1"/>
-                </a:solidFill>
-                <a:latin typeface="+mn-lt"/>
-                <a:ea typeface="+mn-ea"/>
-                <a:cs typeface="+mn-cs"/>
-              </a:defRPr>
-            </a:lvl7pPr>
-            <a:lvl8pPr marL="3200400" algn="l" defTabSz="914400" rtl="0" eaLnBrk="1" latinLnBrk="0" hangingPunct="1">
-              <a:defRPr sz="1800" kern="1200">
-                <a:solidFill>
-                  <a:schemeClr val="tx1"/>
-                </a:solidFill>
-                <a:latin typeface="+mn-lt"/>
-                <a:ea typeface="+mn-ea"/>
-                <a:cs typeface="+mn-cs"/>
-              </a:defRPr>
-            </a:lvl8pPr>
-            <a:lvl9pPr marL="3657600" algn="l" defTabSz="914400" rtl="0" eaLnBrk="1" latinLnBrk="0" hangingPunct="1">
-              <a:defRPr sz="1800" kern="1200">
-                <a:solidFill>
-                  <a:schemeClr val="tx1"/>
-                </a:solidFill>
-                <a:latin typeface="+mn-lt"/>
-                <a:ea typeface="+mn-ea"/>
-                <a:cs typeface="+mn-cs"/>
-              </a:defRPr>
-            </a:lvl9pPr>
-          </a:lstStyle>
-          <a:p>
-            <a:pPr marR="0" lvl="0" defTabSz="914400" eaLnBrk="1" fontAlgn="auto" latinLnBrk="0" hangingPunct="1">
-              <a:lnSpc>
-                <a:spcPct val="100000"/>
-              </a:lnSpc>
-              <a:spcBef>
-                <a:spcPts val="0"/>
-              </a:spcBef>
-              <a:spcAft>
-                <a:spcPts val="0"/>
-              </a:spcAft>
-              <a:buClrTx/>
-              <a:buSzTx/>
-              <a:tabLst/>
-              <a:defRPr/>
-            </a:pPr>
-            <a:r>
-              <a:rPr kumimoji="0" lang="de-CH" sz="1400" b="0" i="0" u="none" strike="noStrike" kern="0" cap="none" spc="0" normalizeH="0" baseline="0" noProof="0">
-                <a:ln>
-                  <a:noFill/>
-                </a:ln>
-                <a:solidFill>
-                  <a:prstClr val="black"/>
-                </a:solidFill>
-                <a:effectLst/>
-                <a:uLnTx/>
-                <a:uFillTx/>
-                <a:latin typeface="Arial" panose="020B0604020202020204"/>
-                <a:ea typeface="+mn-ea"/>
-                <a:cs typeface="+mn-cs"/>
-              </a:rPr>
-              <a:t>«Wir sind nicht nur für das verantwortlich was wir tun, sondern auch für das, was wir nicht tun.» </a:t>
-            </a:r>
-          </a:p>
-          <a:p>
-            <a:pPr marR="0" lvl="0" defTabSz="914400" eaLnBrk="1" fontAlgn="auto" latinLnBrk="0" hangingPunct="1">
-              <a:lnSpc>
-                <a:spcPct val="100000"/>
-              </a:lnSpc>
-              <a:spcBef>
-                <a:spcPts val="0"/>
-              </a:spcBef>
-              <a:spcAft>
-                <a:spcPts val="0"/>
-              </a:spcAft>
-              <a:buClrTx/>
-              <a:buSzTx/>
-              <a:tabLst/>
-              <a:defRPr/>
-            </a:pPr>
-            <a:endParaRPr kumimoji="0" lang="de-CH" sz="1400" b="0" i="0" u="none" strike="noStrike" kern="0" cap="none" spc="0" normalizeH="0" baseline="0" noProof="0">
-              <a:ln>
-                <a:noFill/>
-              </a:ln>
-              <a:solidFill>
-                <a:prstClr val="black"/>
-              </a:solidFill>
-              <a:effectLst/>
-              <a:uLnTx/>
-              <a:uFillTx/>
-              <a:latin typeface="Arial" panose="020B0604020202020204"/>
-              <a:ea typeface="+mn-ea"/>
-              <a:cs typeface="+mn-cs"/>
-            </a:endParaRPr>
-          </a:p>
-          <a:p>
-            <a:pPr marR="0" lvl="0" defTabSz="914400" eaLnBrk="1" fontAlgn="auto" latinLnBrk="0" hangingPunct="1">
-              <a:lnSpc>
-                <a:spcPct val="100000"/>
-              </a:lnSpc>
-              <a:spcBef>
-                <a:spcPts val="0"/>
-              </a:spcBef>
-              <a:spcAft>
-                <a:spcPts val="0"/>
-              </a:spcAft>
-              <a:buClrTx/>
-              <a:buSzTx/>
-              <a:tabLst/>
-              <a:defRPr/>
-            </a:pPr>
-            <a:r>
-              <a:rPr kumimoji="0" lang="de-CH" sz="1200" i="1" u="none" strike="noStrike" kern="0" cap="none" spc="0" normalizeH="0" baseline="0" noProof="0">
-                <a:ln>
-                  <a:noFill/>
-                </a:ln>
-                <a:effectLst/>
-                <a:uLnTx/>
-                <a:uFillTx/>
-                <a:latin typeface="Arial" panose="020B0604020202020204"/>
-                <a:ea typeface="+mn-ea"/>
-                <a:cs typeface="+mn-cs"/>
-              </a:rPr>
-              <a:t>Molière</a:t>
-            </a:r>
-          </a:p>
-        </p:txBody>
-      </p:sp>
-      <p:sp>
-        <p:nvSpPr>
-          <p:cNvPr id="7" name="Picture Placeholder 9">
-            <a:extLst>
-              <a:ext uri="{FF2B5EF4-FFF2-40B4-BE49-F238E27FC236}">
-                <a16:creationId xmlns:a16="http://schemas.microsoft.com/office/drawing/2014/main" id="{4AEE75B3-3B50-99B6-8D63-40FC74741D0E}"/>
-              </a:ext>
-            </a:extLst>
-          </p:cNvPr>
-          <p:cNvSpPr>
-            <a:spLocks noGrp="1"/>
-          </p:cNvSpPr>
-          <p:nvPr>
-            <p:ph type="pic" sz="quarter" idx="10"/>
-          </p:nvPr>
-        </p:nvSpPr>
-        <p:spPr>
-          <a:xfrm>
-            <a:off x="3451225" y="1060450"/>
-            <a:ext cx="5197475" cy="3848100"/>
-          </a:xfrm>
-          <a:solidFill>
-            <a:schemeClr val="tx2"/>
-          </a:solidFill>
-          <a:ln>
-            <a:noFill/>
-          </a:ln>
-        </p:spPr>
-        <p:txBody>
-          <a:bodyPr/>
-          <a:lstStyle>
-            <a:lvl1pPr marL="0" indent="0">
-              <a:buNone/>
-              <a:defRPr/>
-            </a:lvl1pPr>
-          </a:lstStyle>
-          <a:p>
-            <a:endParaRPr lang="de-CH" dirty="0"/>
-          </a:p>
-        </p:txBody>
-      </p:sp>
-    </p:spTree>
-    <p:extLst>
-      <p:ext uri="{BB962C8B-B14F-4D97-AF65-F5344CB8AC3E}">
-        <p14:creationId xmlns:p14="http://schemas.microsoft.com/office/powerpoint/2010/main" val="2717718308"/>
-      </p:ext>
-    </p:extLst>
-  </p:cSld>
-  <p:clrMapOvr>
-    <a:masterClrMapping/>
-  </p:clrMapOvr>
-  <p:timing>
-    <p:tnLst>
-      <p:par>
-        <p:cTn id="1" dur="indefinite" restart="never" nodeType="tmRoot">
-          <p:childTnLst>
-            <p:seq concurrent="1" nextAc="seek">
-              <p:cTn id="2" dur="indefinite" nodeType="mainSeq">
-                <p:childTnLst>
-                  <p:par>
-                    <p:cTn id="3" fill="hold">
-                      <p:stCondLst>
-                        <p:cond delay="indefinite"/>
-                      </p:stCondLst>
-                      <p:childTnLst>
-                        <p:par>
-                          <p:cTn id="4" fill="hold">
-                            <p:stCondLst>
-                              <p:cond delay="0"/>
-                            </p:stCondLst>
-                            <p:childTnLst>
-                              <p:par>
-                                <p:cTn id="5" presetID="1" presetClass="entr" presetSubtype="0" fill="hold" grpId="0" nodeType="clickEffect">
-                                  <p:stCondLst>
-                                    <p:cond delay="0"/>
-                                  </p:stCondLst>
-                                  <p:childTnLst>
-                                    <p:set>
-                                      <p:cBhvr>
-                                        <p:cTn id="6" dur="1" fill="hold">
-                                          <p:stCondLst>
-                                            <p:cond delay="0"/>
-                                          </p:stCondLst>
-                                        </p:cTn>
-                                        <p:tgtEl>
-                                          <p:spTgt spid="4"/>
-                                        </p:tgtEl>
-                                        <p:attrNameLst>
-                                          <p:attrName>style.visibility</p:attrName>
-                                        </p:attrNameLst>
-                                      </p:cBhvr>
-                                      <p:to>
-                                        <p:strVal val="visible"/>
-                                      </p:to>
-                                    </p:set>
-                                  </p:childTnLst>
-                                </p:cTn>
-                              </p:par>
-                            </p:childTnLst>
-                          </p:cTn>
-                        </p:par>
-                      </p:childTnLst>
-                    </p:cTn>
-                  </p:par>
-                </p:childTnLst>
-              </p:cTn>
-              <p:prevCondLst>
-                <p:cond evt="onPrev" delay="0">
-                  <p:tgtEl>
-                    <p:sldTgt/>
-                  </p:tgtEl>
-                </p:cond>
-              </p:prevCondLst>
-              <p:nextCondLst>
-                <p:cond evt="onNext" delay="0">
-                  <p:tgtEl>
-                    <p:sldTgt/>
-                  </p:tgtEl>
-                </p:cond>
-              </p:nextCondLst>
-            </p:seq>
-          </p:childTnLst>
-        </p:cTn>
-      </p:par>
-    </p:tnLst>
-    <p:bldLst>
-      <p:bldP spid="4" grpId="0" animBg="1"/>
-    </p:bldLst>
-  </p:timing>
-</p:sldLayout>
-</file>
-
 <file path=ppt/slideMasters/slideMaster1.xml><?xml version="1.0" encoding="utf-8"?>
-<p:sldMaster xmlns:a="http://schemas.openxmlformats.org/drawingml/2006/main" xmlns:ns2="http://schemas.microsoft.com/office/drawing/2014/main" xmlns:ns3="http://schemas.microsoft.com/office/powerpoint/2010/main" xmlns:ns5="http://schemas.microsoft.com/office/powerpoint/2012/main" xmlns:p="http://schemas.openxmlformats.org/presentationml/2006/main" xmlns:r="http://schemas.openxmlformats.org/officeDocument/2006/relationships">
+<p:sldMaster xmlns:a="http://schemas.openxmlformats.org/drawingml/2006/main" xmlns:r="http://schemas.openxmlformats.org/officeDocument/2006/relationships" xmlns:p="http://schemas.openxmlformats.org/presentationml/2006/main">
   <p:cSld>
     <p:bg bwMode="gray">
       <p:bgRef idx="1001">
@@ -30499,7 +30843,7 @@
           <p:cNvPr id="2" name="Title Placeholder 1">
             <a:extLst>
               <a:ext uri="{FF2B5EF4-FFF2-40B4-BE49-F238E27FC236}">
-                <ns2:creationId id="{F83FC17E-321B-4008-A509-7E5184EC4A30}"/>
+                <a16:creationId xmlns:a16="http://schemas.microsoft.com/office/drawing/2014/main" id="{F83FC17E-321B-4008-A509-7E5184EC4A30}"/>
               </a:ext>
             </a:extLst>
           </p:cNvPr>
@@ -30538,7 +30882,7 @@
           <p:cNvPr id="3" name="Text Placeholder 2">
             <a:extLst>
               <a:ext uri="{FF2B5EF4-FFF2-40B4-BE49-F238E27FC236}">
-                <ns2:creationId id="{441BE9E9-71C8-4301-87F2-0B38A8ED3FAB}"/>
+                <a16:creationId xmlns:a16="http://schemas.microsoft.com/office/drawing/2014/main" id="{441BE9E9-71C8-4301-87F2-0B38A8ED3FAB}"/>
               </a:ext>
             </a:extLst>
           </p:cNvPr>
@@ -30631,7 +30975,7 @@
     </p:spTree>
     <p:extLst>
       <p:ext uri="{BB962C8B-B14F-4D97-AF65-F5344CB8AC3E}">
-        <ns3:creationId val="500272812"/>
+        <p14:creationId xmlns:p14="http://schemas.microsoft.com/office/powerpoint/2010/main" val="500272812"/>
       </p:ext>
     </p:extLst>
   </p:cSld>
@@ -30642,60 +30986,62 @@
     <p:sldLayoutId id="2147483787" r:id="rId3"/>
     <p:sldLayoutId id="2147483788" r:id="rId4"/>
     <p:sldLayoutId id="2147483785" r:id="rId5"/>
-    <p:sldLayoutId id="2147483782" r:id="rId6"/>
-    <p:sldLayoutId id="2147483783" r:id="rId7"/>
-    <p:sldLayoutId id="2147483784" r:id="rId8"/>
-    <p:sldLayoutId id="2147483775" r:id="rId9"/>
-    <p:sldLayoutId id="2147483774" r:id="rId10"/>
-    <p:sldLayoutId id="2147483776" r:id="rId11"/>
-    <p:sldLayoutId id="2147483786" r:id="rId12"/>
-    <p:sldLayoutId id="2147483777" r:id="rId13"/>
-    <p:sldLayoutId id="2147483778" r:id="rId14"/>
-    <p:sldLayoutId id="2147483779" r:id="rId15"/>
-    <p:sldLayoutId id="2147483780" r:id="rId16"/>
-    <p:sldLayoutId id="2147483781" r:id="rId17"/>
-    <p:sldLayoutId id="2147483666" r:id="rId18"/>
-    <p:sldLayoutId id="2147483698" r:id="rId19"/>
-    <p:sldLayoutId id="2147483708" r:id="rId20"/>
-    <p:sldLayoutId id="2147483662" r:id="rId21"/>
-    <p:sldLayoutId id="2147483663" r:id="rId22"/>
-    <p:sldLayoutId id="2147483686" r:id="rId23"/>
-    <p:sldLayoutId id="2147483688" r:id="rId24"/>
-    <p:sldLayoutId id="2147483685" r:id="rId25"/>
-    <p:sldLayoutId id="2147483652" r:id="rId26"/>
-    <p:sldLayoutId id="2147483687" r:id="rId27"/>
-    <p:sldLayoutId id="2147483670" r:id="rId28"/>
-    <p:sldLayoutId id="2147483690" r:id="rId29"/>
-    <p:sldLayoutId id="2147483691" r:id="rId30"/>
-    <p:sldLayoutId id="2147483671" r:id="rId31"/>
-    <p:sldLayoutId id="2147483672" r:id="rId32"/>
-    <p:sldLayoutId id="2147483674" r:id="rId33"/>
-    <p:sldLayoutId id="2147483676" r:id="rId34"/>
-    <p:sldLayoutId id="2147483679" r:id="rId35"/>
-    <p:sldLayoutId id="2147483709" r:id="rId36"/>
-    <p:sldLayoutId id="2147483710" r:id="rId37"/>
-    <p:sldLayoutId id="2147483711" r:id="rId38"/>
-    <p:sldLayoutId id="2147483718" r:id="rId39"/>
-    <p:sldLayoutId id="2147483719" r:id="rId40"/>
-    <p:sldLayoutId id="2147483720" r:id="rId41"/>
-    <p:sldLayoutId id="2147483721" r:id="rId42"/>
-    <p:sldLayoutId id="2147483772" r:id="rId43"/>
-    <p:sldLayoutId id="2147483790" r:id="rId45"/>
-    <p:sldLayoutId id="2147483791" r:id="rId46"/>
-    <p:sldLayoutId id="2147483792" r:id="rId47"/>
-    <p:sldLayoutId id="2147483793" r:id="rId48"/>
-    <p:sldLayoutId id="2147483794" r:id="rId49"/>
-    <p:sldLayoutId id="2147483795" r:id="rId50"/>
-    <p:sldLayoutId id="2147483796" r:id="rId51"/>
-    <p:sldLayoutId id="2147483797" r:id="rId52"/>
-    <p:sldLayoutId id="2147483798" r:id="rId53"/>
-    <p:sldLayoutId id="2147483799" r:id="rId54"/>
-    <p:sldLayoutId id="2147483800" r:id="rId55"/>
-    <p:sldLayoutId id="2147483801" r:id="rId56"/>
-    <p:sldLayoutId id="2147483802" r:id="rId57"/>
-    <p:sldLayoutId id="2147483803" r:id="rId58"/>
-    <p:sldLayoutId id="2147483804" r:id="rId59"/>
-    <p:sldLayoutId id="2147483805" r:id="rId60"/>
+    <p:sldLayoutId id="2147483806" r:id="rId6"/>
+    <p:sldLayoutId id="2147483807" r:id="rId7"/>
+    <p:sldLayoutId id="2147483782" r:id="rId8"/>
+    <p:sldLayoutId id="2147483783" r:id="rId9"/>
+    <p:sldLayoutId id="2147483784" r:id="rId10"/>
+    <p:sldLayoutId id="2147483775" r:id="rId11"/>
+    <p:sldLayoutId id="2147483774" r:id="rId12"/>
+    <p:sldLayoutId id="2147483776" r:id="rId13"/>
+    <p:sldLayoutId id="2147483786" r:id="rId14"/>
+    <p:sldLayoutId id="2147483777" r:id="rId15"/>
+    <p:sldLayoutId id="2147483778" r:id="rId16"/>
+    <p:sldLayoutId id="2147483779" r:id="rId17"/>
+    <p:sldLayoutId id="2147483780" r:id="rId18"/>
+    <p:sldLayoutId id="2147483781" r:id="rId19"/>
+    <p:sldLayoutId id="2147483666" r:id="rId20"/>
+    <p:sldLayoutId id="2147483698" r:id="rId21"/>
+    <p:sldLayoutId id="2147483708" r:id="rId22"/>
+    <p:sldLayoutId id="2147483662" r:id="rId23"/>
+    <p:sldLayoutId id="2147483663" r:id="rId24"/>
+    <p:sldLayoutId id="2147483686" r:id="rId25"/>
+    <p:sldLayoutId id="2147483688" r:id="rId26"/>
+    <p:sldLayoutId id="2147483685" r:id="rId27"/>
+    <p:sldLayoutId id="2147483652" r:id="rId28"/>
+    <p:sldLayoutId id="2147483687" r:id="rId29"/>
+    <p:sldLayoutId id="2147483670" r:id="rId30"/>
+    <p:sldLayoutId id="2147483690" r:id="rId31"/>
+    <p:sldLayoutId id="2147483691" r:id="rId32"/>
+    <p:sldLayoutId id="2147483671" r:id="rId33"/>
+    <p:sldLayoutId id="2147483672" r:id="rId34"/>
+    <p:sldLayoutId id="2147483674" r:id="rId35"/>
+    <p:sldLayoutId id="2147483676" r:id="rId36"/>
+    <p:sldLayoutId id="2147483679" r:id="rId37"/>
+    <p:sldLayoutId id="2147483709" r:id="rId38"/>
+    <p:sldLayoutId id="2147483710" r:id="rId39"/>
+    <p:sldLayoutId id="2147483711" r:id="rId40"/>
+    <p:sldLayoutId id="2147483718" r:id="rId41"/>
+    <p:sldLayoutId id="2147483719" r:id="rId42"/>
+    <p:sldLayoutId id="2147483720" r:id="rId43"/>
+    <p:sldLayoutId id="2147483721" r:id="rId44"/>
+    <p:sldLayoutId id="2147483772" r:id="rId45"/>
+    <p:sldLayoutId id="2147483790" r:id="rId46"/>
+    <p:sldLayoutId id="2147483791" r:id="rId47"/>
+    <p:sldLayoutId id="2147483792" r:id="rId48"/>
+    <p:sldLayoutId id="2147483793" r:id="rId49"/>
+    <p:sldLayoutId id="2147483794" r:id="rId50"/>
+    <p:sldLayoutId id="2147483795" r:id="rId51"/>
+    <p:sldLayoutId id="2147483796" r:id="rId52"/>
+    <p:sldLayoutId id="2147483797" r:id="rId53"/>
+    <p:sldLayoutId id="2147483798" r:id="rId54"/>
+    <p:sldLayoutId id="2147483799" r:id="rId55"/>
+    <p:sldLayoutId id="2147483800" r:id="rId56"/>
+    <p:sldLayoutId id="2147483801" r:id="rId57"/>
+    <p:sldLayoutId id="2147483802" r:id="rId58"/>
+    <p:sldLayoutId id="2147483803" r:id="rId59"/>
+    <p:sldLayoutId id="2147483804" r:id="rId60"/>
+    <p:sldLayoutId id="2147483805" r:id="rId61"/>
   </p:sldLayoutIdLst>
   <p:hf sldNum="0" hdr="0" ftr="0" dt="0"/>
   <p:txStyles>
@@ -30980,38 +31326,38 @@
   </p:txStyles>
   <p:extLst>
     <p:ext uri="{27BBF7A9-308A-43DC-89C8-2F10F3537804}">
-      <ns5:sldGuideLst>
-        <ns5:guide id="1" pos="347" userDrawn="1">
-          <ns5:clr>
+      <p15:sldGuideLst xmlns:p15="http://schemas.microsoft.com/office/powerpoint/2012/main">
+        <p15:guide id="1" pos="347" userDrawn="1">
+          <p15:clr>
             <a:srgbClr val="F26B43"/>
-          </ns5:clr>
-        </ns5:guide>
-        <ns5:guide id="2" orient="horz" pos="482" userDrawn="1">
-          <ns5:clr>
+          </p15:clr>
+        </p15:guide>
+        <p15:guide id="2" orient="horz" pos="482" userDrawn="1">
+          <p15:clr>
             <a:srgbClr val="F26B43"/>
-          </ns5:clr>
-        </ns5:guide>
-        <ns5:guide id="3" pos="7333" userDrawn="1">
-          <ns5:clr>
+          </p15:clr>
+        </p15:guide>
+        <p15:guide id="3" pos="7333" userDrawn="1">
+          <p15:clr>
             <a:srgbClr val="F26B43"/>
-          </ns5:clr>
-        </ns5:guide>
-        <ns5:guide id="4" orient="horz" pos="981" userDrawn="1">
-          <ns5:clr>
+          </p15:clr>
+        </p15:guide>
+        <p15:guide id="4" orient="horz" pos="981" userDrawn="1">
+          <p15:clr>
             <a:srgbClr val="F26B43"/>
-          </ns5:clr>
-        </ns5:guide>
-        <ns5:guide id="5" orient="horz" pos="3884" userDrawn="1">
-          <ns5:clr>
+          </p15:clr>
+        </p15:guide>
+        <p15:guide id="5" orient="horz" pos="3884" userDrawn="1">
+          <p15:clr>
             <a:srgbClr val="F26B43"/>
-          </ns5:clr>
-        </ns5:guide>
-        <ns5:guide id="6" orient="horz" pos="4146" userDrawn="1">
-          <ns5:clr>
+          </p15:clr>
+        </p15:guide>
+        <p15:guide id="6" orient="horz" pos="4146" userDrawn="1">
+          <p15:clr>
             <a:srgbClr val="F26B43"/>
-          </ns5:clr>
-        </ns5:guide>
-      </ns5:sldGuideLst>
+          </p15:clr>
+        </p15:guide>
+      </p15:sldGuideLst>
     </p:ext>
   </p:extLst>
 </p:sldMaster>
@@ -31929,30 +32275,6 @@
 </file>
 
 <file path=customXml/item1.xml><?xml version="1.0" encoding="utf-8"?>
-<?mso-contentType ?>
-<FormTemplates xmlns="http://schemas.microsoft.com/sharepoint/v3/contenttype/forms">
-  <Display>DocumentLibraryForm</Display>
-  <Edit>DocumentLibraryForm</Edit>
-  <New>DocumentLibraryForm</New>
-</FormTemplates>
-</file>
-
-<file path=customXml/item2.xml><?xml version="1.0" encoding="utf-8"?>
-<p:properties xmlns:p="http://schemas.microsoft.com/office/2006/metadata/properties" xmlns:xsi="http://www.w3.org/2001/XMLSchema-instance" xmlns:pc="http://schemas.microsoft.com/office/infopath/2007/PartnerControls">
-  <documentManagement>
-    <lcf76f155ced4ddcb4097134ff3c332f xmlns="4b2400fe-f831-49a8-a009-c60ecffd4822">
-      <Terms xmlns="http://schemas.microsoft.com/office/infopath/2007/PartnerControls"/>
-    </lcf76f155ced4ddcb4097134ff3c332f>
-    <test xmlns="4b2400fe-f831-49a8-a009-c60ecffd4822" xsi:nil="true"/>
-    <TaxCatchAll xmlns="a808b08c-7c2d-4bd0-a9ec-71cceca54455" xsi:nil="true"/>
-    <_Flow_SignoffStatus xmlns="4b2400fe-f831-49a8-a009-c60ecffd4822" xsi:nil="true"/>
-    <_ip_UnifiedCompliancePolicyUIAction xmlns="http://schemas.microsoft.com/sharepoint/v3" xsi:nil="true"/>
-    <_ip_UnifiedCompliancePolicyProperties xmlns="http://schemas.microsoft.com/sharepoint/v3" xsi:nil="true"/>
-  </documentManagement>
-</p:properties>
-</file>
-
-<file path=customXml/item3.xml><?xml version="1.0" encoding="utf-8"?>
 <ct:contentTypeSchema xmlns:ct="http://schemas.microsoft.com/office/2006/metadata/contentType" xmlns:ma="http://schemas.microsoft.com/office/2006/metadata/properties/metaAttributes" ct:_="" ma:_="" ma:contentTypeName="Dokument" ma:contentTypeID="0x010100859D6B2F2F8B184B84CD1A0E1ADAAB78" ma:contentTypeVersion="20" ma:contentTypeDescription="Ein neues Dokument erstellen." ma:contentTypeScope="" ma:versionID="3fcfa37e0be72f645c279f7488897fb0">
   <xsd:schema xmlns:xsd="http://www.w3.org/2001/XMLSchema" xmlns:xs="http://www.w3.org/2001/XMLSchema" xmlns:p="http://schemas.microsoft.com/office/2006/metadata/properties" xmlns:ns1="http://schemas.microsoft.com/sharepoint/v3" xmlns:ns2="4b2400fe-f831-49a8-a009-c60ecffd4822" xmlns:ns3="a808b08c-7c2d-4bd0-a9ec-71cceca54455" targetNamespace="http://schemas.microsoft.com/office/2006/metadata/properties" ma:root="true" ma:fieldsID="47a7f7023c42d4d432f1ab1db246cb28" ns1:_="" ns2:_="" ns3:_="">
     <xsd:import namespace="http://schemas.microsoft.com/sharepoint/v3"/>
@@ -32222,10 +32544,46 @@
 </ct:contentTypeSchema>
 </file>
 
+<file path=customXml/item2.xml><?xml version="1.0" encoding="utf-8"?>
+<p:properties xmlns:p="http://schemas.microsoft.com/office/2006/metadata/properties" xmlns:xsi="http://www.w3.org/2001/XMLSchema-instance" xmlns:pc="http://schemas.microsoft.com/office/infopath/2007/PartnerControls">
+  <documentManagement>
+    <lcf76f155ced4ddcb4097134ff3c332f xmlns="4b2400fe-f831-49a8-a009-c60ecffd4822">
+      <Terms xmlns="http://schemas.microsoft.com/office/infopath/2007/PartnerControls"/>
+    </lcf76f155ced4ddcb4097134ff3c332f>
+    <test xmlns="4b2400fe-f831-49a8-a009-c60ecffd4822" xsi:nil="true"/>
+    <TaxCatchAll xmlns="a808b08c-7c2d-4bd0-a9ec-71cceca54455" xsi:nil="true"/>
+    <_Flow_SignoffStatus xmlns="4b2400fe-f831-49a8-a009-c60ecffd4822" xsi:nil="true"/>
+    <_ip_UnifiedCompliancePolicyUIAction xmlns="http://schemas.microsoft.com/sharepoint/v3" xsi:nil="true"/>
+    <_ip_UnifiedCompliancePolicyProperties xmlns="http://schemas.microsoft.com/sharepoint/v3" xsi:nil="true"/>
+  </documentManagement>
+</p:properties>
+</file>
+
+<file path=customXml/item3.xml><?xml version="1.0" encoding="utf-8"?>
+<?mso-contentType ?>
+<FormTemplates xmlns="http://schemas.microsoft.com/sharepoint/v3/contenttype/forms">
+  <Display>DocumentLibraryForm</Display>
+  <Edit>DocumentLibraryForm</Edit>
+  <New>DocumentLibraryForm</New>
+</FormTemplates>
+</file>
+
 <file path=customXml/itemProps1.xml><?xml version="1.0" encoding="utf-8"?>
-<ds:datastoreItem xmlns:ds="http://schemas.openxmlformats.org/officeDocument/2006/customXml" ds:itemID="{CF891001-4D14-494C-BFD9-9723B1F905FA}">
+<ds:datastoreItem xmlns:ds="http://schemas.openxmlformats.org/officeDocument/2006/customXml" ds:itemID="{EAF9DBD2-5E95-4B1C-8D5D-5ED2AFB6EDEF}">
   <ds:schemaRefs>
-    <ds:schemaRef ds:uri="http://schemas.microsoft.com/sharepoint/v3/contenttype/forms"/>
+    <ds:schemaRef ds:uri="4b2400fe-f831-49a8-a009-c60ecffd4822"/>
+    <ds:schemaRef ds:uri="a808b08c-7c2d-4bd0-a9ec-71cceca54455"/>
+    <ds:schemaRef ds:uri="http://purl.org/dc/elements/1.1/"/>
+    <ds:schemaRef ds:uri="http://purl.org/dc/terms/"/>
+    <ds:schemaRef ds:uri="http://schemas.microsoft.com/internal/obd"/>
+    <ds:schemaRef ds:uri="http://schemas.microsoft.com/office/2006/documentManagement/types"/>
+    <ds:schemaRef ds:uri="http://schemas.microsoft.com/office/2006/metadata/contentType"/>
+    <ds:schemaRef ds:uri="http://schemas.microsoft.com/office/2006/metadata/properties"/>
+    <ds:schemaRef ds:uri="http://schemas.microsoft.com/office/2006/metadata/properties/metaAttributes"/>
+    <ds:schemaRef ds:uri="http://schemas.microsoft.com/office/infopath/2007/PartnerControls"/>
+    <ds:schemaRef ds:uri="http://schemas.microsoft.com/sharepoint/v3"/>
+    <ds:schemaRef ds:uri="http://schemas.openxmlformats.org/package/2006/metadata/core-properties"/>
+    <ds:schemaRef ds:uri="http://www.w3.org/2001/XMLSchema"/>
   </ds:schemaRefs>
 </ds:datastoreItem>
 </file>
@@ -32249,21 +32607,9 @@
 </file>
 
 <file path=customXml/itemProps3.xml><?xml version="1.0" encoding="utf-8"?>
-<ds:datastoreItem xmlns:ds="http://schemas.openxmlformats.org/officeDocument/2006/customXml" ds:itemID="{EAF9DBD2-5E95-4B1C-8D5D-5ED2AFB6EDEF}">
+<ds:datastoreItem xmlns:ds="http://schemas.openxmlformats.org/officeDocument/2006/customXml" ds:itemID="{CF891001-4D14-494C-BFD9-9723B1F905FA}">
   <ds:schemaRefs>
-    <ds:schemaRef ds:uri="4b2400fe-f831-49a8-a009-c60ecffd4822"/>
-    <ds:schemaRef ds:uri="a808b08c-7c2d-4bd0-a9ec-71cceca54455"/>
-    <ds:schemaRef ds:uri="http://purl.org/dc/elements/1.1/"/>
-    <ds:schemaRef ds:uri="http://purl.org/dc/terms/"/>
-    <ds:schemaRef ds:uri="http://schemas.microsoft.com/internal/obd"/>
-    <ds:schemaRef ds:uri="http://schemas.microsoft.com/office/2006/documentManagement/types"/>
-    <ds:schemaRef ds:uri="http://schemas.microsoft.com/office/2006/metadata/contentType"/>
-    <ds:schemaRef ds:uri="http://schemas.microsoft.com/office/2006/metadata/properties"/>
-    <ds:schemaRef ds:uri="http://schemas.microsoft.com/office/2006/metadata/properties/metaAttributes"/>
-    <ds:schemaRef ds:uri="http://schemas.microsoft.com/office/infopath/2007/PartnerControls"/>
-    <ds:schemaRef ds:uri="http://schemas.microsoft.com/sharepoint/v3"/>
-    <ds:schemaRef ds:uri="http://schemas.openxmlformats.org/package/2006/metadata/core-properties"/>
-    <ds:schemaRef ds:uri="http://www.w3.org/2001/XMLSchema"/>
+    <ds:schemaRef ds:uri="http://schemas.microsoft.com/sharepoint/v3/contenttype/forms"/>
   </ds:schemaRefs>
 </ds:datastoreItem>
 </file>

</xml_diff>